<commit_message>
fix slide attribution: dsarch AQ builds the tar, dsglobus uploads batches
dsarch AQ can upload one tar as it builds it, but dsquasar calls dsglobus
directly with a whole 90 GB list of tars, so a batch costs one transfer
request instead of one per tar.

Co-Authored-By: Claude Opus 4.6 <noreply@anthropic.com>
</commit_message>
<xml_diff>
--- a/docs/slides/dsquasar_guide.pptx
+++ b/docs/slides/dsquasar_guide.pptx
@@ -3638,7 +3638,7 @@
                 <a:ea typeface="Courier New" pitchFamily="34" charset="-122"/>
                 <a:cs typeface="Courier New" pitchFamily="34" charset="-120"/>
               </a:rPr>
-              <a:t>Tars &amp; uploads through  dsarch -AQ  •  scheduled by the  dscheck  daemon</a:t>
+              <a:t>Tars through  dsarch AQ  •  uploads through  dsglobus  •  scheduled by  dscheck</a:t>
             </a:r>
             <a:endParaRPr lang="en-US" sz="1200" dirty="0"/>
           </a:p>
@@ -8354,7 +8354,7 @@
                 <a:ea typeface="Poppins" pitchFamily="34" charset="-122"/>
                 <a:cs typeface="Poppins" pitchFamily="34" charset="-120"/>
               </a:rPr>
-              <a:t>Transfer the batch with one Globus request — Drdata first when the flag is 'D', then Backup</a:t>
+              <a:t>Hand the whole list to dsglobus as one transfer — Drdata first when the flag is 'D', then Backup</a:t>
             </a:r>
             <a:endParaRPr lang="en-US" sz="1350" dirty="0"/>
           </a:p>
@@ -8988,7 +8988,7 @@
                 <a:ea typeface="Poppins" pitchFamily="34" charset="-122"/>
                 <a:cs typeface="Poppins" pitchFamily="34" charset="-120"/>
               </a:rPr>
-              <a:t>18 tar files × 5 GB  =  one 90 GB Globus transfer</a:t>
+              <a:t>18 tar files × 5 GB  =  one 90 GB dsglobus transfer</a:t>
             </a:r>
             <a:endParaRPr lang="en-US" sz="1300" dirty="0"/>
           </a:p>
@@ -9003,7 +9003,7 @@
         <p:spPr>
           <a:xfrm>
             <a:off x="6446520" y="3520440"/>
-            <a:ext cx="5029200" cy="411480"/>
+            <a:ext cx="5029200" cy="548640"/>
           </a:xfrm>
           <a:prstGeom prst="rect">
             <a:avLst/>
@@ -9017,12 +9017,12 @@
           <a:p>
             <a:pPr indent="0" marL="0">
               <a:lnSpc>
-                <a:spcPct val="105000"/>
+                <a:spcPct val="103000"/>
               </a:lnSpc>
               <a:buNone/>
             </a:pPr>
             <a:r>
-              <a:rPr lang="en-US" sz="1150" dirty="0">
+              <a:rPr lang="en-US" sz="1100" dirty="0">
                 <a:solidFill>
                   <a:srgbClr val="53565A"/>
                 </a:solidFill>
@@ -9030,9 +9030,9 @@
                 <a:ea typeface="Poppins" pitchFamily="34" charset="-122"/>
                 <a:cs typeface="Poppins" pitchFamily="34" charset="-120"/>
               </a:rPr>
-              <a:t>One request per batch instead of per tar keeps Globus queueing and per-transfer overhead down; each batch is also the unit of parallelism, so one child process handles one batch.</a:t>
-            </a:r>
-            <a:endParaRPr lang="en-US" sz="1150" dirty="0"/>
+              <a:t>dsarch AQ can upload a tar as it builds it, but only one at a time. dsquasar instead calls dsglobus directly with the whole list, so a batch costs one transfer request rather than eighteen. Each batch is also the unit of parallelism — one child process per batch.</a:t>
+            </a:r>
+            <a:endParaRPr lang="en-US" sz="1100" dirty="0"/>
           </a:p>
         </p:txBody>
       </p:sp>
@@ -17511,7 +17511,7 @@
                 <a:ea typeface="Poppins" pitchFamily="34" charset="-122"/>
                 <a:cs typeface="Poppins" pitchFamily="34" charset="-120"/>
               </a:rPr>
-              <a:t>. It finds Web and Saved files that have never been backed up, groups them into large tar files, and ships those to the NCAR Quasar Globus end points through </a:t>
+              <a:t>. It finds Web and Saved files that have never been backed up, groups them into large tar files built by </a:t>
             </a:r>
             <a:pPr indent="0" marL="0">
               <a:lnSpc>
@@ -17528,7 +17528,41 @@
                 <a:ea typeface="Courier New" pitchFamily="34" charset="-122"/>
                 <a:cs typeface="Courier New" pitchFamily="34" charset="-120"/>
               </a:rPr>
-              <a:t>dsarch -AQ</a:t>
+              <a:t>dsarch AQ</a:t>
+            </a:r>
+            <a:pPr indent="0" marL="0">
+              <a:lnSpc>
+                <a:spcPct val="115000"/>
+              </a:lnSpc>
+              <a:buNone/>
+            </a:pPr>
+            <a:r>
+              <a:rPr lang="en-US" sz="1600" dirty="0">
+                <a:solidFill>
+                  <a:srgbClr val="00357A"/>
+                </a:solidFill>
+                <a:latin typeface="Poppins" pitchFamily="34" charset="0"/>
+                <a:ea typeface="Poppins" pitchFamily="34" charset="-122"/>
+                <a:cs typeface="Poppins" pitchFamily="34" charset="-120"/>
+              </a:rPr>
+              <a:t>, then uploads many of those tars at once to the NCAR Quasar Globus end points with </a:t>
+            </a:r>
+            <a:pPr indent="0" marL="0">
+              <a:lnSpc>
+                <a:spcPct val="115000"/>
+              </a:lnSpc>
+              <a:buNone/>
+            </a:pPr>
+            <a:r>
+              <a:rPr lang="en-US" sz="1600" b="1" dirty="0">
+                <a:solidFill>
+                  <a:srgbClr val="0057C2"/>
+                </a:solidFill>
+                <a:latin typeface="Courier New" pitchFamily="34" charset="0"/>
+                <a:ea typeface="Courier New" pitchFamily="34" charset="-122"/>
+                <a:cs typeface="Courier New" pitchFamily="34" charset="-120"/>
+              </a:rPr>
+              <a:t>dsglobus</a:t>
             </a:r>
             <a:pPr indent="0" marL="0">
               <a:lnSpc>
@@ -18569,7 +18603,7 @@
                 <a:ea typeface="Poppins" pitchFamily="34" charset="-122"/>
                 <a:cs typeface="Poppins" pitchFamily="34" charset="-120"/>
               </a:rPr>
-              <a:t>Globus batches to gdex-quasar (+drdata)</a:t>
+              <a:t>dsglobus batches to gdex-quasar (+drdata)</a:t>
             </a:r>
             <a:endParaRPr lang="en-US" sz="1200" dirty="0"/>
           </a:p>
@@ -32166,7 +32200,7 @@
                 <a:ea typeface="Poppins" pitchFamily="34" charset="-122"/>
                 <a:cs typeface="Poppins" pitchFamily="34" charset="-120"/>
               </a:rPr>
-              <a:t>built on gdex-glade by dsarch -AQ -TO, status 'T'</a:t>
+              <a:t>built on gdex-glade by dsarch AQ -TO, status 'T'</a:t>
             </a:r>
             <a:endParaRPr lang="en-US" sz="1150" dirty="0"/>
           </a:p>
@@ -32372,7 +32406,7 @@
                 <a:ea typeface="Poppins" pitchFamily="34" charset="-122"/>
                 <a:cs typeface="Poppins" pitchFamily="34" charset="-120"/>
               </a:rPr>
-              <a:t>Globus transfer to gdex-quasar (+drdata), status 'A'</a:t>
+              <a:t>dsglobus transfer to gdex-quasar (+drdata), status 'A'</a:t>
             </a:r>
             <a:endParaRPr lang="en-US" sz="1150" dirty="0"/>
           </a:p>
@@ -35989,7 +36023,7 @@
                 <a:ea typeface="Poppins" pitchFamily="34" charset="-122"/>
                 <a:cs typeface="Poppins" pitchFamily="34" charset="-120"/>
               </a:rPr>
-              <a:t>Batches built tars into &gt;=90 GB Globus transfers.</a:t>
+              <a:t>Batches built tars into &gt;=90 GB dsglobus transfers.</a:t>
             </a:r>
             <a:endParaRPr lang="en-US" sz="1150" dirty="0"/>
           </a:p>
@@ -39305,7 +39339,7 @@
                 <a:ea typeface="Poppins" pitchFamily="34" charset="-122"/>
                 <a:cs typeface="Poppins" pitchFamily="34" charset="-120"/>
               </a:rPr>
-              <a:t>Globus batches of 'T' tars to Quasar → 'A'</a:t>
+              <a:t>dsglobus batches of 'T' tars to Quasar → 'A'</a:t>
             </a:r>
             <a:endParaRPr lang="en-US" sz="1050" dirty="0"/>
           </a:p>

</xml_diff>

<commit_message>
fix wrapping of the -A action labels under the pipeline and lifecycle arrows
The labels were spread with runs of spaces inside one centred text box, so
the line wrapped and -A 4 dropped onto a second line. Position one label
per arrow instead.

Co-Authored-By: Claude Opus 4.6 <noreply@anthropic.com>
</commit_message>
<xml_diff>
--- a/docs/slides/dsquasar_guide.pptx
+++ b/docs/slides/dsquasar_guide.pptx
@@ -4341,8 +4341,8 @@
         </p:nvSpPr>
         <p:spPr>
           <a:xfrm>
-            <a:off x="2286000" y="3337560"/>
-            <a:ext cx="7772400" cy="320040"/>
+            <a:off x="3429000" y="3337560"/>
+            <a:ext cx="1828800" cy="320040"/>
           </a:xfrm>
           <a:prstGeom prst="rect">
             <a:avLst/>
@@ -4368,32 +4368,43 @@
               </a:rPr>
               <a:t>-A 2 / -A 3</a:t>
             </a:r>
+            <a:endParaRPr lang="en-US" sz="1300" dirty="0"/>
+          </a:p>
+        </p:txBody>
+      </p:sp>
+      <p:sp>
+        <p:nvSpPr>
+          <p:cNvPr id="22" name="Text 20"/>
+          <p:cNvSpPr/>
+          <p:nvPr/>
+        </p:nvSpPr>
+        <p:spPr>
+          <a:xfrm>
+            <a:off x="6812280" y="3337560"/>
+            <a:ext cx="1828800" cy="320040"/>
+          </a:xfrm>
+          <a:prstGeom prst="rect">
+            <a:avLst/>
+          </a:prstGeom>
+          <a:noFill/>
+          <a:ln/>
+        </p:spPr>
+        <p:txBody>
+          <a:bodyPr wrap="square" lIns="0" tIns="0" rIns="0" bIns="0" rtlCol="0" anchor="ctr"/>
+          <a:lstStyle/>
+          <a:p>
             <a:pPr algn="ctr" indent="0" marL="0">
               <a:buNone/>
             </a:pPr>
             <a:r>
-              <a:rPr lang="en-US" sz="1300" dirty="0">
-                <a:solidFill>
-                  <a:srgbClr val="000000"/>
+              <a:rPr lang="en-US" sz="1300" b="1" dirty="0">
+                <a:solidFill>
+                  <a:srgbClr val="C25E00"/>
                 </a:solidFill>
                 <a:latin typeface="Courier New" pitchFamily="34" charset="0"/>
                 <a:ea typeface="Courier New" pitchFamily="34" charset="-122"/>
                 <a:cs typeface="Courier New" pitchFamily="34" charset="-120"/>
               </a:rPr>
-              <a:t>                                </a:t>
-            </a:r>
-            <a:pPr algn="ctr" indent="0" marL="0">
-              <a:buNone/>
-            </a:pPr>
-            <a:r>
-              <a:rPr lang="en-US" sz="1300" b="1" dirty="0">
-                <a:solidFill>
-                  <a:srgbClr val="C25E00"/>
-                </a:solidFill>
-                <a:latin typeface="Courier New" pitchFamily="34" charset="0"/>
-                <a:ea typeface="Courier New" pitchFamily="34" charset="-122"/>
-                <a:cs typeface="Courier New" pitchFamily="34" charset="-120"/>
-              </a:rPr>
               <a:t>-A 4</a:t>
             </a:r>
             <a:endParaRPr lang="en-US" sz="1300" dirty="0"/>
@@ -4402,7 +4413,7 @@
       </p:sp>
       <p:sp>
         <p:nvSpPr>
-          <p:cNvPr id="22" name="Text 20"/>
+          <p:cNvPr id="23" name="Text 21"/>
           <p:cNvSpPr/>
           <p:nvPr/>
         </p:nvSpPr>
@@ -4441,7 +4452,7 @@
       </p:sp>
       <p:sp>
         <p:nvSpPr>
-          <p:cNvPr id="23" name="Shape 21"/>
+          <p:cNvPr id="24" name="Shape 22"/>
           <p:cNvSpPr/>
           <p:nvPr/>
         </p:nvSpPr>
@@ -4468,7 +4479,7 @@
       </p:sp>
       <p:sp>
         <p:nvSpPr>
-          <p:cNvPr id="24" name="Text 22"/>
+          <p:cNvPr id="25" name="Text 23"/>
           <p:cNvSpPr/>
           <p:nvPr/>
         </p:nvSpPr>
@@ -4507,7 +4518,7 @@
       </p:sp>
       <p:sp>
         <p:nvSpPr>
-          <p:cNvPr id="25" name="Text 23"/>
+          <p:cNvPr id="26" name="Text 24"/>
           <p:cNvSpPr/>
           <p:nvPr/>
         </p:nvSpPr>
@@ -4546,7 +4557,7 @@
       </p:sp>
       <p:sp>
         <p:nvSpPr>
-          <p:cNvPr id="26" name="Shape 24"/>
+          <p:cNvPr id="27" name="Shape 25"/>
           <p:cNvSpPr/>
           <p:nvPr/>
         </p:nvSpPr>
@@ -4573,7 +4584,7 @@
       </p:sp>
       <p:sp>
         <p:nvSpPr>
-          <p:cNvPr id="27" name="Text 25"/>
+          <p:cNvPr id="28" name="Text 26"/>
           <p:cNvSpPr/>
           <p:nvPr/>
         </p:nvSpPr>
@@ -4612,7 +4623,7 @@
       </p:sp>
       <p:sp>
         <p:nvSpPr>
-          <p:cNvPr id="28" name="Text 26"/>
+          <p:cNvPr id="29" name="Text 27"/>
           <p:cNvSpPr/>
           <p:nvPr/>
         </p:nvSpPr>
@@ -4651,7 +4662,7 @@
       </p:sp>
       <p:sp>
         <p:nvSpPr>
-          <p:cNvPr id="29" name="Shape 27"/>
+          <p:cNvPr id="30" name="Shape 28"/>
           <p:cNvSpPr/>
           <p:nvPr/>
         </p:nvSpPr>
@@ -4678,7 +4689,7 @@
       </p:sp>
       <p:sp>
         <p:nvSpPr>
-          <p:cNvPr id="30" name="Text 28"/>
+          <p:cNvPr id="31" name="Text 29"/>
           <p:cNvSpPr/>
           <p:nvPr/>
         </p:nvSpPr>
@@ -4717,7 +4728,7 @@
       </p:sp>
       <p:sp>
         <p:nvSpPr>
-          <p:cNvPr id="31" name="Text 29"/>
+          <p:cNvPr id="32" name="Text 30"/>
           <p:cNvSpPr/>
           <p:nvPr/>
         </p:nvSpPr>
@@ -4756,7 +4767,7 @@
       </p:sp>
       <p:sp>
         <p:nvSpPr>
-          <p:cNvPr id="32" name="Text 30"/>
+          <p:cNvPr id="33" name="Text 31"/>
           <p:cNvSpPr/>
           <p:nvPr/>
         </p:nvSpPr>
@@ -4851,7 +4862,7 @@
       </p:sp>
       <p:pic>
         <p:nvPicPr>
-          <p:cNvPr id="33" name="Image 0" descr="nsf_ncar_logo_color.png">    </p:cNvPr>
+          <p:cNvPr id="34" name="Image 0" descr="nsf_ncar_logo_color.png">    </p:cNvPr>
           <p:cNvPicPr>
             <a:picLocks noChangeAspect="1"/>
           </p:cNvPicPr>
@@ -4875,7 +4886,7 @@
       </p:pic>
       <p:sp>
         <p:nvSpPr>
-          <p:cNvPr id="34" name="Text 31"/>
+          <p:cNvPr id="35" name="Text 32"/>
           <p:cNvSpPr/>
           <p:nvPr/>
         </p:nvSpPr>
@@ -4914,7 +4925,7 @@
       </p:sp>
       <p:sp>
         <p:nvSpPr>
-          <p:cNvPr id="35" name="Text 32"/>
+          <p:cNvPr id="36" name="Text 33"/>
           <p:cNvSpPr/>
           <p:nvPr/>
         </p:nvSpPr>
@@ -32420,8 +32431,8 @@
         </p:nvSpPr>
         <p:spPr>
           <a:xfrm>
-            <a:off x="1828800" y="4343400"/>
-            <a:ext cx="8686800" cy="320040"/>
+            <a:off x="2724912" y="4343400"/>
+            <a:ext cx="1097280" cy="320040"/>
           </a:xfrm>
           <a:prstGeom prst="rect">
             <a:avLst/>
@@ -32447,60 +32458,82 @@
               </a:rPr>
               <a:t>-A 1</a:t>
             </a:r>
+            <a:endParaRPr lang="en-US" sz="1400" dirty="0"/>
+          </a:p>
+        </p:txBody>
+      </p:sp>
+      <p:sp>
+        <p:nvSpPr>
+          <p:cNvPr id="28" name="Text 26"/>
+          <p:cNvSpPr/>
+          <p:nvPr/>
+        </p:nvSpPr>
+        <p:spPr>
+          <a:xfrm>
+            <a:off x="5623560" y="4343400"/>
+            <a:ext cx="1097280" cy="320040"/>
+          </a:xfrm>
+          <a:prstGeom prst="rect">
+            <a:avLst/>
+          </a:prstGeom>
+          <a:noFill/>
+          <a:ln/>
+        </p:spPr>
+        <p:txBody>
+          <a:bodyPr wrap="square" lIns="0" tIns="0" rIns="0" bIns="0" rtlCol="0" anchor="ctr"/>
+          <a:lstStyle/>
+          <a:p>
             <a:pPr algn="ctr" indent="0" marL="0">
               <a:buNone/>
             </a:pPr>
             <a:r>
-              <a:rPr lang="en-US" sz="1400" dirty="0">
-                <a:solidFill>
-                  <a:srgbClr val="000000"/>
+              <a:rPr lang="en-US" sz="1400" b="1" dirty="0">
+                <a:solidFill>
+                  <a:srgbClr val="0097A7"/>
                 </a:solidFill>
                 <a:latin typeface="Courier New" pitchFamily="34" charset="0"/>
                 <a:ea typeface="Courier New" pitchFamily="34" charset="-122"/>
                 <a:cs typeface="Courier New" pitchFamily="34" charset="-120"/>
               </a:rPr>
-              <a:t>                                   </a:t>
-            </a:r>
+              <a:t>-A 2</a:t>
+            </a:r>
+            <a:endParaRPr lang="en-US" sz="1400" dirty="0"/>
+          </a:p>
+        </p:txBody>
+      </p:sp>
+      <p:sp>
+        <p:nvSpPr>
+          <p:cNvPr id="29" name="Text 27"/>
+          <p:cNvSpPr/>
+          <p:nvPr/>
+        </p:nvSpPr>
+        <p:spPr>
+          <a:xfrm>
+            <a:off x="8522208" y="4343400"/>
+            <a:ext cx="1097280" cy="320040"/>
+          </a:xfrm>
+          <a:prstGeom prst="rect">
+            <a:avLst/>
+          </a:prstGeom>
+          <a:noFill/>
+          <a:ln/>
+        </p:spPr>
+        <p:txBody>
+          <a:bodyPr wrap="square" lIns="0" tIns="0" rIns="0" bIns="0" rtlCol="0" anchor="ctr"/>
+          <a:lstStyle/>
+          <a:p>
             <a:pPr algn="ctr" indent="0" marL="0">
               <a:buNone/>
             </a:pPr>
             <a:r>
               <a:rPr lang="en-US" sz="1400" b="1" dirty="0">
                 <a:solidFill>
-                  <a:srgbClr val="0097A7"/>
+                  <a:srgbClr val="C25E00"/>
                 </a:solidFill>
                 <a:latin typeface="Courier New" pitchFamily="34" charset="0"/>
                 <a:ea typeface="Courier New" pitchFamily="34" charset="-122"/>
                 <a:cs typeface="Courier New" pitchFamily="34" charset="-120"/>
               </a:rPr>
-              <a:t>-A 2</a:t>
-            </a:r>
-            <a:pPr algn="ctr" indent="0" marL="0">
-              <a:buNone/>
-            </a:pPr>
-            <a:r>
-              <a:rPr lang="en-US" sz="1400" dirty="0">
-                <a:solidFill>
-                  <a:srgbClr val="000000"/>
-                </a:solidFill>
-                <a:latin typeface="Courier New" pitchFamily="34" charset="0"/>
-                <a:ea typeface="Courier New" pitchFamily="34" charset="-122"/>
-                <a:cs typeface="Courier New" pitchFamily="34" charset="-120"/>
-              </a:rPr>
-              <a:t>                                   </a:t>
-            </a:r>
-            <a:pPr algn="ctr" indent="0" marL="0">
-              <a:buNone/>
-            </a:pPr>
-            <a:r>
-              <a:rPr lang="en-US" sz="1400" b="1" dirty="0">
-                <a:solidFill>
-                  <a:srgbClr val="C25E00"/>
-                </a:solidFill>
-                <a:latin typeface="Courier New" pitchFamily="34" charset="0"/>
-                <a:ea typeface="Courier New" pitchFamily="34" charset="-122"/>
-                <a:cs typeface="Courier New" pitchFamily="34" charset="-120"/>
-              </a:rPr>
               <a:t>-A 4</a:t>
             </a:r>
             <a:endParaRPr lang="en-US" sz="1400" dirty="0"/>
@@ -32509,7 +32542,7 @@
       </p:sp>
       <p:sp>
         <p:nvSpPr>
-          <p:cNvPr id="28" name="Shape 26"/>
+          <p:cNvPr id="30" name="Shape 28"/>
           <p:cNvSpPr/>
           <p:nvPr/>
         </p:nvSpPr>
@@ -32536,7 +32569,7 @@
       </p:sp>
       <p:sp>
         <p:nvSpPr>
-          <p:cNvPr id="29" name="Shape 27"/>
+          <p:cNvPr id="31" name="Shape 29"/>
           <p:cNvSpPr/>
           <p:nvPr/>
         </p:nvSpPr>
@@ -32556,7 +32589,7 @@
       </p:sp>
       <p:sp>
         <p:nvSpPr>
-          <p:cNvPr id="30" name="Text 28"/>
+          <p:cNvPr id="32" name="Text 30"/>
           <p:cNvSpPr/>
           <p:nvPr/>
         </p:nvSpPr>
@@ -32595,7 +32628,7 @@
       </p:sp>
       <p:sp>
         <p:nvSpPr>
-          <p:cNvPr id="31" name="Text 29"/>
+          <p:cNvPr id="33" name="Text 31"/>
           <p:cNvSpPr/>
           <p:nvPr/>
         </p:nvSpPr>
@@ -32756,7 +32789,7 @@
       </p:sp>
       <p:pic>
         <p:nvPicPr>
-          <p:cNvPr id="32" name="Image 0" descr="nsf_ncar_logo_color.png">    </p:cNvPr>
+          <p:cNvPr id="34" name="Image 0" descr="nsf_ncar_logo_color.png">    </p:cNvPr>
           <p:cNvPicPr>
             <a:picLocks noChangeAspect="1"/>
           </p:cNvPicPr>
@@ -32780,7 +32813,7 @@
       </p:pic>
       <p:sp>
         <p:nvSpPr>
-          <p:cNvPr id="33" name="Text 30"/>
+          <p:cNvPr id="35" name="Text 32"/>
           <p:cNvSpPr/>
           <p:nvPr/>
         </p:nvSpPr>
@@ -32819,7 +32852,7 @@
       </p:sp>
       <p:sp>
         <p:nvSpPr>
-          <p:cNvPr id="34" name="Text 31"/>
+          <p:cNvPr id="36" name="Text 33"/>
           <p:cNvSpPr/>
           <p:nvPr/>
         </p:nvSpPr>

</xml_diff>

<commit_message>
state plainly that dataset.backflag is what enrolls a dataset for backup
The flag slide listed the values but never said which field puts a dataset
under Quasar backup in the first place, and read as though the group flag
were the primary one. dsgroup.backflag only refines an already enrolled
dataset.

Co-Authored-By: Claude Opus 4.6 <noreply@anthropic.com>
</commit_message>
<xml_diff>
--- a/docs/slides/dsquasar_guide.pptx
+++ b/docs/slides/dsquasar_guide.pptx
@@ -17698,7 +17698,7 @@
                 <a:ea typeface="Poppins" pitchFamily="34" charset="-122"/>
                 <a:cs typeface="Poppins" pitchFamily="34" charset="-120"/>
               </a:rPr>
-              <a:t>Nothing is configured per run: </a:t>
+              <a:t>Nothing is configured per run: a dataset joins the backup when </a:t>
             </a:r>
             <a:pPr indent="0" marL="0">
               <a:lnSpc>
@@ -17732,7 +17732,7 @@
                 <a:ea typeface="Poppins" pitchFamily="34" charset="-122"/>
                 <a:cs typeface="Poppins" pitchFamily="34" charset="-120"/>
               </a:rPr>
-              <a:t> and </a:t>
+              <a:t> is set, and </a:t>
             </a:r>
             <a:pPr indent="0" marL="0">
               <a:lnSpc>
@@ -17766,7 +17766,7 @@
                 <a:ea typeface="Poppins" pitchFamily="34" charset="-122"/>
                 <a:cs typeface="Poppins" pitchFamily="34" charset="-120"/>
               </a:rPr>
-              <a:t> say what to back up.</a:t>
+              <a:t> refines it per group.</a:t>
             </a:r>
             <a:pPr indent="0" marL="0">
               <a:lnSpc>
@@ -28895,7 +28895,7 @@
                 <a:ea typeface="Poppins" pitchFamily="34" charset="-122"/>
                 <a:cs typeface="Poppins" pitchFamily="34" charset="-120"/>
               </a:rPr>
-              <a:t>Flags decide, not you</a:t>
+              <a:t>dataset.backflag enrolls</a:t>
             </a:r>
             <a:endParaRPr lang="en-US" sz="1350" dirty="0"/>
           </a:p>
@@ -28937,7 +28937,7 @@
                 <a:ea typeface="Poppins" pitchFamily="34" charset="-122"/>
                 <a:cs typeface="Poppins" pitchFamily="34" charset="-120"/>
               </a:rPr>
-              <a:t>Backup flags on the dataset and group records choose what is gathered. -t narrows the run; it does not override a flag.</a:t>
+              <a:t>Setting that one field puts a dataset under backup; dsgroup.backflag refines it. -t narrows a run, it does not override a flag.</a:t>
             </a:r>
             <a:endParaRPr lang="en-US" sz="1100" dirty="0"/>
           </a:p>
@@ -37133,6 +37133,82 @@
           </a:p>
         </p:txBody>
       </p:sp>
+      <p:sp>
+        <p:nvSpPr>
+          <p:cNvPr id="4" name="Text 2"/>
+          <p:cNvSpPr/>
+          <p:nvPr/>
+        </p:nvSpPr>
+        <p:spPr>
+          <a:xfrm>
+            <a:off x="457200" y="1481328"/>
+            <a:ext cx="5532120" cy="658368"/>
+          </a:xfrm>
+          <a:prstGeom prst="rect">
+            <a:avLst/>
+          </a:prstGeom>
+          <a:noFill/>
+          <a:ln/>
+        </p:spPr>
+        <p:txBody>
+          <a:bodyPr wrap="square" lIns="0" tIns="0" rIns="0" bIns="0" rtlCol="0" anchor="t"/>
+          <a:lstStyle/>
+          <a:p>
+            <a:pPr indent="0" marL="0">
+              <a:lnSpc>
+                <a:spcPct val="108000"/>
+              </a:lnSpc>
+              <a:buNone/>
+            </a:pPr>
+            <a:r>
+              <a:rPr lang="en-US" sz="1300" dirty="0">
+                <a:solidFill>
+                  <a:srgbClr val="00357A"/>
+                </a:solidFill>
+                <a:latin typeface="Poppins" pitchFamily="34" charset="0"/>
+                <a:ea typeface="Poppins" pitchFamily="34" charset="-122"/>
+                <a:cs typeface="Poppins" pitchFamily="34" charset="-120"/>
+              </a:rPr>
+              <a:t>A dataset is put under Quasar backup by setting </a:t>
+            </a:r>
+            <a:pPr indent="0" marL="0">
+              <a:lnSpc>
+                <a:spcPct val="108000"/>
+              </a:lnSpc>
+              <a:buNone/>
+            </a:pPr>
+            <a:r>
+              <a:rPr lang="en-US" sz="1300" b="1" dirty="0">
+                <a:solidFill>
+                  <a:srgbClr val="0057C2"/>
+                </a:solidFill>
+                <a:latin typeface="Courier New" pitchFamily="34" charset="0"/>
+                <a:ea typeface="Courier New" pitchFamily="34" charset="-122"/>
+                <a:cs typeface="Courier New" pitchFamily="34" charset="-120"/>
+              </a:rPr>
+              <a:t>dataset.backflag</a:t>
+            </a:r>
+            <a:pPr indent="0" marL="0">
+              <a:lnSpc>
+                <a:spcPct val="108000"/>
+              </a:lnSpc>
+              <a:buNone/>
+            </a:pPr>
+            <a:r>
+              <a:rPr lang="en-US" sz="1300" dirty="0">
+                <a:solidFill>
+                  <a:srgbClr val="00357A"/>
+                </a:solidFill>
+                <a:latin typeface="Poppins" pitchFamily="34" charset="0"/>
+                <a:ea typeface="Poppins" pitchFamily="34" charset="-122"/>
+                <a:cs typeface="Poppins" pitchFamily="34" charset="-120"/>
+              </a:rPr>
+              <a:t>. That one field is the switch — dsquasar reads it for every dataset it visits, and nothing else enrolls a dataset.</a:t>
+            </a:r>
+            <a:endParaRPr lang="en-US" sz="1300" dirty="0"/>
+          </a:p>
+        </p:txBody>
+      </p:sp>
       <p:graphicFrame>
         <p:nvGraphicFramePr>
           <p:cNvPr id="9" name="Table 0"/>
@@ -37148,7 +37224,7 @@
           </p:nvPr>
         </p:nvGraphicFramePr>
         <p:xfrm>
-          <a:off x="457200" y="1554480"/>
+          <a:off x="457200" y="2194560"/>
           <a:ext cx="5532120" cy="914400"/>
         </p:xfrm>
         <a:graphic>
@@ -37245,7 +37321,7 @@
                           <a:ea typeface="Poppins" pitchFamily="34" charset="-122"/>
                           <a:cs typeface="Poppins" pitchFamily="34" charset="-120"/>
                         </a:rPr>
-                        <a:t>Meaning in dataset.backflag / dsgroup.backflag</a:t>
+                        <a:t>Value in dataset.backflag / dsgroup.backflag</a:t>
                       </a:r>
                       <a:endParaRPr lang="en-US" sz="1200" dirty="0">
                         <a:latin typeface="Poppins" charset="0"/>
@@ -37855,14 +37931,14 @@
       </p:graphicFrame>
       <p:sp>
         <p:nvSpPr>
-          <p:cNvPr id="5" name="Text 2"/>
-          <p:cNvSpPr/>
-          <p:nvPr/>
-        </p:nvSpPr>
-        <p:spPr>
-          <a:xfrm>
-            <a:off x="457200" y="3703320"/>
-            <a:ext cx="5532120" cy="1234440"/>
+          <p:cNvPr id="6" name="Text 3"/>
+          <p:cNvSpPr/>
+          <p:nvPr/>
+        </p:nvSpPr>
+        <p:spPr>
+          <a:xfrm>
+            <a:off x="457200" y="3840480"/>
+            <a:ext cx="5532120" cy="1143000"/>
           </a:xfrm>
           <a:prstGeom prst="rect">
             <a:avLst/>
@@ -37876,12 +37952,12 @@
           <a:p>
             <a:pPr indent="0" marL="0">
               <a:lnSpc>
-                <a:spcPct val="110000"/>
+                <a:spcPct val="108000"/>
               </a:lnSpc>
               <a:buNone/>
             </a:pPr>
             <a:r>
-              <a:rPr lang="en-US" sz="1300" b="1" dirty="0">
+              <a:rPr lang="en-US" sz="1250" b="1" dirty="0">
                 <a:solidFill>
                   <a:srgbClr val="0057C2"/>
                 </a:solidFill>
@@ -37889,16 +37965,16 @@
                 <a:ea typeface="Poppins" pitchFamily="34" charset="-122"/>
                 <a:cs typeface="Poppins" pitchFamily="34" charset="-120"/>
               </a:rPr>
-              <a:t>Group flags win.  </a:t>
+              <a:t>Group flags refine, they do not enroll.  </a:t>
             </a:r>
             <a:pPr indent="0" marL="0">
               <a:lnSpc>
-                <a:spcPct val="110000"/>
+                <a:spcPct val="108000"/>
               </a:lnSpc>
               <a:buNone/>
             </a:pPr>
             <a:r>
-              <a:rPr lang="en-US" sz="1300" dirty="0">
+              <a:rPr lang="en-US" sz="1250" dirty="0">
                 <a:solidFill>
                   <a:srgbClr val="00357A"/>
                 </a:solidFill>
@@ -37906,16 +37982,16 @@
                 <a:ea typeface="Poppins" pitchFamily="34" charset="-122"/>
                 <a:cs typeface="Poppins" pitchFamily="34" charset="-120"/>
               </a:rPr>
-              <a:t>If any top-level </a:t>
+              <a:t>Once the dataset flag is set, any top-level </a:t>
             </a:r>
             <a:pPr indent="0" marL="0">
               <a:lnSpc>
-                <a:spcPct val="110000"/>
+                <a:spcPct val="108000"/>
               </a:lnSpc>
               <a:buNone/>
             </a:pPr>
             <a:r>
-              <a:rPr lang="en-US" sz="1300" b="1" dirty="0">
+              <a:rPr lang="en-US" sz="1250" b="1" dirty="0">
                 <a:solidFill>
                   <a:srgbClr val="00357A"/>
                 </a:solidFill>
@@ -37927,12 +38003,12 @@
             </a:r>
             <a:pPr indent="0" marL="0">
               <a:lnSpc>
-                <a:spcPct val="110000"/>
+                <a:spcPct val="108000"/>
               </a:lnSpc>
               <a:buNone/>
             </a:pPr>
             <a:r>
-              <a:rPr lang="en-US" sz="1300" dirty="0">
+              <a:rPr lang="en-US" sz="1250" dirty="0">
                 <a:solidFill>
                   <a:srgbClr val="00357A"/>
                 </a:solidFill>
@@ -37940,16 +38016,16 @@
                 <a:ea typeface="Poppins" pitchFamily="34" charset="-122"/>
                 <a:cs typeface="Poppins" pitchFamily="34" charset="-120"/>
               </a:rPr>
-              <a:t> carries its own flag, dsquasar walks the dataset group by group and applies each group's flag; groups flagged </a:t>
+              <a:t> carrying its own flag is applied group by group — </a:t>
             </a:r>
             <a:pPr indent="0" marL="0">
               <a:lnSpc>
-                <a:spcPct val="110000"/>
+                <a:spcPct val="108000"/>
               </a:lnSpc>
               <a:buNone/>
             </a:pPr>
             <a:r>
-              <a:rPr lang="en-US" sz="1300" b="1" dirty="0">
+              <a:rPr lang="en-US" sz="1250" b="1" dirty="0">
                 <a:solidFill>
                   <a:srgbClr val="00357A"/>
                 </a:solidFill>
@@ -37957,16 +38033,50 @@
                 <a:ea typeface="Courier New" pitchFamily="34" charset="-122"/>
                 <a:cs typeface="Courier New" pitchFamily="34" charset="-120"/>
               </a:rPr>
+              <a:t>'P'</a:t>
+            </a:r>
+            <a:pPr indent="0" marL="0">
+              <a:lnSpc>
+                <a:spcPct val="108000"/>
+              </a:lnSpc>
+              <a:buNone/>
+            </a:pPr>
+            <a:r>
+              <a:rPr lang="en-US" sz="1250" dirty="0">
+                <a:solidFill>
+                  <a:srgbClr val="00357A"/>
+                </a:solidFill>
+                <a:latin typeface="Poppins" pitchFamily="34" charset="0"/>
+                <a:ea typeface="Poppins" pitchFamily="34" charset="-122"/>
+                <a:cs typeface="Poppins" pitchFamily="34" charset="-120"/>
+              </a:rPr>
+              <a:t> inherits the dataset flag, </a:t>
+            </a:r>
+            <a:pPr indent="0" marL="0">
+              <a:lnSpc>
+                <a:spcPct val="108000"/>
+              </a:lnSpc>
+              <a:buNone/>
+            </a:pPr>
+            <a:r>
+              <a:rPr lang="en-US" sz="1250" b="1" dirty="0">
+                <a:solidFill>
+                  <a:srgbClr val="00357A"/>
+                </a:solidFill>
+                <a:latin typeface="Courier New" pitchFamily="34" charset="0"/>
+                <a:ea typeface="Courier New" pitchFamily="34" charset="-122"/>
+                <a:cs typeface="Courier New" pitchFamily="34" charset="-120"/>
+              </a:rPr>
               <a:t>'N'</a:t>
             </a:r>
             <a:pPr indent="0" marL="0">
               <a:lnSpc>
-                <a:spcPct val="110000"/>
+                <a:spcPct val="108000"/>
               </a:lnSpc>
               <a:buNone/>
             </a:pPr>
             <a:r>
-              <a:rPr lang="en-US" sz="1300" dirty="0">
+              <a:rPr lang="en-US" sz="1250" dirty="0">
                 <a:solidFill>
                   <a:srgbClr val="00357A"/>
                 </a:solidFill>
@@ -37974,15 +38084,15 @@
                 <a:ea typeface="Poppins" pitchFamily="34" charset="-122"/>
                 <a:cs typeface="Poppins" pitchFamily="34" charset="-120"/>
               </a:rPr>
-              <a:t> are skipped. A dataset with no group flags is treated as one unit.</a:t>
-            </a:r>
-            <a:endParaRPr lang="en-US" sz="1300" dirty="0"/>
-          </a:p>
-        </p:txBody>
-      </p:sp>
-      <p:sp>
-        <p:nvSpPr>
-          <p:cNvPr id="6" name="Shape 3"/>
+              <a:t> excludes the group. A dataset with no group flags is one unit.</a:t>
+            </a:r>
+            <a:endParaRPr lang="en-US" sz="1250" dirty="0"/>
+          </a:p>
+        </p:txBody>
+      </p:sp>
+      <p:sp>
+        <p:nvSpPr>
+          <p:cNvPr id="7" name="Shape 4"/>
           <p:cNvSpPr/>
           <p:nvPr/>
         </p:nvSpPr>
@@ -38009,7 +38119,7 @@
       </p:sp>
       <p:sp>
         <p:nvSpPr>
-          <p:cNvPr id="7" name="Text 4"/>
+          <p:cNvPr id="8" name="Text 5"/>
           <p:cNvSpPr/>
           <p:nvPr/>
         </p:nvSpPr>
@@ -38119,7 +38229,7 @@
       </p:sp>
       <p:sp>
         <p:nvSpPr>
-          <p:cNvPr id="8" name="Shape 5"/>
+          <p:cNvPr id="9" name="Shape 6"/>
           <p:cNvSpPr/>
           <p:nvPr/>
         </p:nvSpPr>
@@ -38146,7 +38256,7 @@
       </p:sp>
       <p:sp>
         <p:nvSpPr>
-          <p:cNvPr id="9" name="Text 6"/>
+          <p:cNvPr id="10" name="Text 7"/>
           <p:cNvSpPr/>
           <p:nvPr/>
         </p:nvSpPr>
@@ -38185,7 +38295,7 @@
       </p:sp>
       <p:sp>
         <p:nvSpPr>
-          <p:cNvPr id="10" name="Shape 7"/>
+          <p:cNvPr id="11" name="Shape 8"/>
           <p:cNvSpPr/>
           <p:nvPr/>
         </p:nvSpPr>
@@ -38207,7 +38317,7 @@
       </p:sp>
       <p:sp>
         <p:nvSpPr>
-          <p:cNvPr id="11" name="Text 8"/>
+          <p:cNvPr id="12" name="Text 9"/>
           <p:cNvSpPr/>
           <p:nvPr/>
         </p:nvSpPr>
@@ -38261,7 +38371,7 @@
       </p:sp>
       <p:sp>
         <p:nvSpPr>
-          <p:cNvPr id="12" name="Text 9"/>
+          <p:cNvPr id="13" name="Text 10"/>
           <p:cNvSpPr/>
           <p:nvPr/>
         </p:nvSpPr>
@@ -38300,7 +38410,7 @@
       </p:sp>
       <p:sp>
         <p:nvSpPr>
-          <p:cNvPr id="13" name="Shape 10"/>
+          <p:cNvPr id="14" name="Shape 11"/>
           <p:cNvSpPr/>
           <p:nvPr/>
         </p:nvSpPr>
@@ -38327,7 +38437,7 @@
       </p:sp>
       <p:sp>
         <p:nvSpPr>
-          <p:cNvPr id="14" name="Text 11"/>
+          <p:cNvPr id="15" name="Text 12"/>
           <p:cNvSpPr/>
           <p:nvPr/>
         </p:nvSpPr>
@@ -38366,7 +38476,7 @@
       </p:sp>
       <p:sp>
         <p:nvSpPr>
-          <p:cNvPr id="15" name="Text 12"/>
+          <p:cNvPr id="16" name="Text 13"/>
           <p:cNvSpPr/>
           <p:nvPr/>
         </p:nvSpPr>
@@ -38405,7 +38515,7 @@
       </p:sp>
       <p:sp>
         <p:nvSpPr>
-          <p:cNvPr id="16" name="Shape 13"/>
+          <p:cNvPr id="17" name="Shape 14"/>
           <p:cNvSpPr/>
           <p:nvPr/>
         </p:nvSpPr>
@@ -38432,7 +38542,7 @@
       </p:sp>
       <p:sp>
         <p:nvSpPr>
-          <p:cNvPr id="17" name="Text 14"/>
+          <p:cNvPr id="18" name="Text 15"/>
           <p:cNvSpPr/>
           <p:nvPr/>
         </p:nvSpPr>
@@ -38471,7 +38581,7 @@
       </p:sp>
       <p:sp>
         <p:nvSpPr>
-          <p:cNvPr id="18" name="Text 15"/>
+          <p:cNvPr id="19" name="Text 16"/>
           <p:cNvSpPr/>
           <p:nvPr/>
         </p:nvSpPr>
@@ -38510,7 +38620,7 @@
       </p:sp>
       <p:sp>
         <p:nvSpPr>
-          <p:cNvPr id="19" name="Text 16"/>
+          <p:cNvPr id="20" name="Text 17"/>
           <p:cNvSpPr/>
           <p:nvPr/>
         </p:nvSpPr>
@@ -38552,7 +38662,7 @@
       </p:sp>
       <p:pic>
         <p:nvPicPr>
-          <p:cNvPr id="20" name="Image 0" descr="nsf_ncar_logo_color.png">    </p:cNvPr>
+          <p:cNvPr id="21" name="Image 0" descr="nsf_ncar_logo_color.png">    </p:cNvPr>
           <p:cNvPicPr>
             <a:picLocks noChangeAspect="1"/>
           </p:cNvPicPr>
@@ -38576,7 +38686,7 @@
       </p:pic>
       <p:sp>
         <p:nvSpPr>
-          <p:cNvPr id="21" name="Text 17"/>
+          <p:cNvPr id="22" name="Text 18"/>
           <p:cNvSpPr/>
           <p:nvPr/>
         </p:nvSpPr>
@@ -38615,7 +38725,7 @@
       </p:sp>
       <p:sp>
         <p:nvSpPr>
-          <p:cNvPr id="22" name="Text 18"/>
+          <p:cNvPr id="23" name="Text 19"/>
           <p:cNvSpPr/>
           <p:nvPr/>
         </p:nvSpPr>

</xml_diff>

<commit_message>
show where backflag is actually edited: the rda_pg_config web tool
Adds a linked note on the backup-flag slide and in the environment slide
pointing at gdex.ucar.edu/rda_pg_config/ under DSARCH -> Dataset
Information, and fixes the flag table overlapping the paragraph below it.

Co-Authored-By: Claude Opus 4.6 <noreply@anthropic.com>
</commit_message>
<xml_diff>
--- a/docs/slides/dsquasar_guide.pptx
+++ b/docs/slides/dsquasar_guide.pptx
@@ -26340,7 +26340,42 @@
                 <a:ea typeface="Poppins" pitchFamily="34" charset="-122"/>
                 <a:cs typeface="Poppins" pitchFamily="34" charset="-120"/>
               </a:rPr>
-              <a:t>All three are installed by the rda_python_dsquasar package and share the rda_python_common configuration.</a:t>
+              <a:t>All three are installed by the rda_python_dsquasar package and share the rda_python_common configuration.   Backup flags are edited at </a:t>
+            </a:r>
+            <a:pPr indent="0" marL="0">
+              <a:buNone/>
+            </a:pPr>
+            <a:r>
+              <a:rPr lang="en-US" sz="1100" b="1" u="sng" dirty="0">
+                <a:solidFill>
+                  <a:srgbClr val="0057C2"/>
+                </a:solidFill>
+                <a:latin typeface="Courier New" pitchFamily="34" charset="0"/>
+                <a:ea typeface="Courier New" pitchFamily="34" charset="-122"/>
+                <a:cs typeface="Courier New" pitchFamily="34" charset="-120"/>
+                <a:hlinkClick r:id="rId1" invalidUrl="" action="" tgtFrame="" tooltip="" history="1" highlightClick="0" endSnd="0">
+                  <a:extLst>
+                    <a:ext uri="{A12FA001-AC4F-418D-AE19-62706E023703}">
+                      <ahyp:hlinkClr xmlns:ahyp="http://schemas.microsoft.com/office/drawing/2018/hyperlinkcolor" val="tx"/>
+                    </a:ext>
+                  </a:extLst>
+                </a:hlinkClick>
+              </a:rPr>
+              <a:t>gdex.ucar.edu/rda_pg_config/</a:t>
+            </a:r>
+            <a:pPr indent="0" marL="0">
+              <a:buNone/>
+            </a:pPr>
+            <a:r>
+              <a:rPr lang="en-US" sz="1100" i="1" dirty="0">
+                <a:solidFill>
+                  <a:srgbClr val="53565A"/>
+                </a:solidFill>
+                <a:latin typeface="Poppins" pitchFamily="34" charset="0"/>
+                <a:ea typeface="Poppins" pitchFamily="34" charset="-122"/>
+                <a:cs typeface="Poppins" pitchFamily="34" charset="-120"/>
+              </a:rPr>
+              <a:t>  (DSARCH → Dataset Information).</a:t>
             </a:r>
             <a:endParaRPr lang="en-US" sz="1100" dirty="0"/>
           </a:p>
@@ -26355,7 +26390,7 @@
           <p:nvPr/>
         </p:nvPicPr>
         <p:blipFill>
-          <a:blip r:embed="rId1"/>
+          <a:blip r:embed="rId2"/>
           <a:stretch>
             <a:fillRect/>
           </a:stretch>
@@ -37141,8 +37176,8 @@
         </p:nvSpPr>
         <p:spPr>
           <a:xfrm>
-            <a:off x="457200" y="1481328"/>
-            <a:ext cx="5532120" cy="658368"/>
+            <a:off x="457200" y="1463040"/>
+            <a:ext cx="5532120" cy="621792"/>
           </a:xfrm>
           <a:prstGeom prst="rect">
             <a:avLst/>
@@ -37224,7 +37259,7 @@
           </p:nvPr>
         </p:nvGraphicFramePr>
         <p:xfrm>
-          <a:off x="457200" y="2194560"/>
+          <a:off x="457200" y="2121408"/>
           <a:ext cx="5532120" cy="914400"/>
         </p:xfrm>
         <a:graphic>
@@ -37937,8 +37972,8 @@
         </p:nvSpPr>
         <p:spPr>
           <a:xfrm>
-            <a:off x="457200" y="3840480"/>
-            <a:ext cx="5532120" cy="1143000"/>
+            <a:off x="457200" y="4023360"/>
+            <a:ext cx="5532120" cy="777240"/>
           </a:xfrm>
           <a:prstGeom prst="rect">
             <a:avLst/>
@@ -37952,12 +37987,12 @@
           <a:p>
             <a:pPr indent="0" marL="0">
               <a:lnSpc>
-                <a:spcPct val="108000"/>
+                <a:spcPct val="106000"/>
               </a:lnSpc>
               <a:buNone/>
             </a:pPr>
             <a:r>
-              <a:rPr lang="en-US" sz="1250" b="1" dirty="0">
+              <a:rPr lang="en-US" sz="1200" b="1" dirty="0">
                 <a:solidFill>
                   <a:srgbClr val="0057C2"/>
                 </a:solidFill>
@@ -37969,12 +38004,12 @@
             </a:r>
             <a:pPr indent="0" marL="0">
               <a:lnSpc>
-                <a:spcPct val="108000"/>
+                <a:spcPct val="106000"/>
               </a:lnSpc>
               <a:buNone/>
             </a:pPr>
             <a:r>
-              <a:rPr lang="en-US" sz="1250" dirty="0">
+              <a:rPr lang="en-US" sz="1200" dirty="0">
                 <a:solidFill>
                   <a:srgbClr val="00357A"/>
                 </a:solidFill>
@@ -37982,16 +38017,16 @@
                 <a:ea typeface="Poppins" pitchFamily="34" charset="-122"/>
                 <a:cs typeface="Poppins" pitchFamily="34" charset="-120"/>
               </a:rPr>
-              <a:t>Once the dataset flag is set, any top-level </a:t>
+              <a:t>Once the dataset flag is set, a top-level </a:t>
             </a:r>
             <a:pPr indent="0" marL="0">
               <a:lnSpc>
-                <a:spcPct val="108000"/>
+                <a:spcPct val="106000"/>
               </a:lnSpc>
               <a:buNone/>
             </a:pPr>
             <a:r>
-              <a:rPr lang="en-US" sz="1250" b="1" dirty="0">
+              <a:rPr lang="en-US" sz="1200" b="1" dirty="0">
                 <a:solidFill>
                   <a:srgbClr val="00357A"/>
                 </a:solidFill>
@@ -38003,12 +38038,12 @@
             </a:r>
             <a:pPr indent="0" marL="0">
               <a:lnSpc>
-                <a:spcPct val="108000"/>
+                <a:spcPct val="106000"/>
               </a:lnSpc>
               <a:buNone/>
             </a:pPr>
             <a:r>
-              <a:rPr lang="en-US" sz="1250" dirty="0">
+              <a:rPr lang="en-US" sz="1200" dirty="0">
                 <a:solidFill>
                   <a:srgbClr val="00357A"/>
                 </a:solidFill>
@@ -38016,16 +38051,16 @@
                 <a:ea typeface="Poppins" pitchFamily="34" charset="-122"/>
                 <a:cs typeface="Poppins" pitchFamily="34" charset="-120"/>
               </a:rPr>
-              <a:t> carrying its own flag is applied group by group — </a:t>
+              <a:t> with its own flag is applied group by group — </a:t>
             </a:r>
             <a:pPr indent="0" marL="0">
               <a:lnSpc>
-                <a:spcPct val="108000"/>
+                <a:spcPct val="106000"/>
               </a:lnSpc>
               <a:buNone/>
             </a:pPr>
             <a:r>
-              <a:rPr lang="en-US" sz="1250" b="1" dirty="0">
+              <a:rPr lang="en-US" sz="1200" b="1" dirty="0">
                 <a:solidFill>
                   <a:srgbClr val="00357A"/>
                 </a:solidFill>
@@ -38037,12 +38072,12 @@
             </a:r>
             <a:pPr indent="0" marL="0">
               <a:lnSpc>
-                <a:spcPct val="108000"/>
+                <a:spcPct val="106000"/>
               </a:lnSpc>
               <a:buNone/>
             </a:pPr>
             <a:r>
-              <a:rPr lang="en-US" sz="1250" dirty="0">
+              <a:rPr lang="en-US" sz="1200" dirty="0">
                 <a:solidFill>
                   <a:srgbClr val="00357A"/>
                 </a:solidFill>
@@ -38050,16 +38085,16 @@
                 <a:ea typeface="Poppins" pitchFamily="34" charset="-122"/>
                 <a:cs typeface="Poppins" pitchFamily="34" charset="-120"/>
               </a:rPr>
-              <a:t> inherits the dataset flag, </a:t>
+              <a:t> inherits, </a:t>
             </a:r>
             <a:pPr indent="0" marL="0">
               <a:lnSpc>
-                <a:spcPct val="108000"/>
+                <a:spcPct val="106000"/>
               </a:lnSpc>
               <a:buNone/>
             </a:pPr>
             <a:r>
-              <a:rPr lang="en-US" sz="1250" b="1" dirty="0">
+              <a:rPr lang="en-US" sz="1200" b="1" dirty="0">
                 <a:solidFill>
                   <a:srgbClr val="00357A"/>
                 </a:solidFill>
@@ -38071,12 +38106,12 @@
             </a:r>
             <a:pPr indent="0" marL="0">
               <a:lnSpc>
-                <a:spcPct val="108000"/>
+                <a:spcPct val="106000"/>
               </a:lnSpc>
               <a:buNone/>
             </a:pPr>
             <a:r>
-              <a:rPr lang="en-US" sz="1250" dirty="0">
+              <a:rPr lang="en-US" sz="1200" dirty="0">
                 <a:solidFill>
                   <a:srgbClr val="00357A"/>
                 </a:solidFill>
@@ -38084,9 +38119,9 @@
                 <a:ea typeface="Poppins" pitchFamily="34" charset="-122"/>
                 <a:cs typeface="Poppins" pitchFamily="34" charset="-120"/>
               </a:rPr>
-              <a:t> excludes the group. A dataset with no group flags is one unit.</a:t>
-            </a:r>
-            <a:endParaRPr lang="en-US" sz="1250" dirty="0"/>
+              <a:t> excludes.</a:t>
+            </a:r>
+            <a:endParaRPr lang="en-US" sz="1200" dirty="0"/>
           </a:p>
         </p:txBody>
       </p:sp>
@@ -38098,12 +38133,12 @@
         </p:nvSpPr>
         <p:spPr>
           <a:xfrm>
-            <a:off x="457200" y="5029200"/>
-            <a:ext cx="5532120" cy="1051560"/>
+            <a:off x="457200" y="4846320"/>
+            <a:ext cx="5532120" cy="713232"/>
           </a:xfrm>
           <a:prstGeom prst="roundRect">
             <a:avLst>
-              <a:gd name="adj" fmla="val 8696"/>
+              <a:gd name="adj" fmla="val 11538"/>
             </a:avLst>
           </a:prstGeom>
           <a:solidFill>
@@ -38125,8 +38160,8 @@
         </p:nvSpPr>
         <p:spPr>
           <a:xfrm>
-            <a:off x="685800" y="5074920"/>
-            <a:ext cx="5120640" cy="960120"/>
+            <a:off x="658368" y="4846320"/>
+            <a:ext cx="5120640" cy="713232"/>
           </a:xfrm>
           <a:prstGeom prst="rect">
             <a:avLst/>
@@ -38140,12 +38175,12 @@
           <a:p>
             <a:pPr indent="0" marL="0">
               <a:lnSpc>
-                <a:spcPct val="108000"/>
+                <a:spcPct val="105000"/>
               </a:lnSpc>
               <a:buNone/>
             </a:pPr>
             <a:r>
-              <a:rPr lang="en-US" sz="1250" b="1" dirty="0">
+              <a:rPr lang="en-US" sz="1100" b="1" dirty="0">
                 <a:solidFill>
                   <a:srgbClr val="0057C2"/>
                 </a:solidFill>
@@ -38153,33 +38188,49 @@
                 <a:ea typeface="Poppins" pitchFamily="34" charset="-122"/>
                 <a:cs typeface="Poppins" pitchFamily="34" charset="-120"/>
               </a:rPr>
-              <a:t>Command-line override:  </a:t>
+              <a:t>Set it in the web config tool:  </a:t>
             </a:r>
             <a:pPr indent="0" marL="0">
               <a:lnSpc>
-                <a:spcPct val="108000"/>
+                <a:spcPct val="105000"/>
               </a:lnSpc>
               <a:buNone/>
             </a:pPr>
             <a:r>
-              <a:rPr lang="en-US" sz="1250" b="1" dirty="0">
-                <a:solidFill>
-                  <a:srgbClr val="00357A"/>
+              <a:rPr lang="en-US" sz="1100" b="1" u="sng" dirty="0">
+                <a:solidFill>
+                  <a:srgbClr val="0057C2"/>
                 </a:solidFill>
                 <a:latin typeface="Courier New" pitchFamily="34" charset="0"/>
                 <a:ea typeface="Courier New" pitchFamily="34" charset="-122"/>
                 <a:cs typeface="Courier New" pitchFamily="34" charset="-120"/>
-              </a:rPr>
-              <a:t>-B</a:t>
+                <a:hlinkClick r:id="rId1" invalidUrl="" action="" tgtFrame="" tooltip="" history="1" highlightClick="0" endSnd="0">
+                  <a:extLst>
+                    <a:ext uri="{A12FA001-AC4F-418D-AE19-62706E023703}">
+                      <ahyp:hlinkClr xmlns:ahyp="http://schemas.microsoft.com/office/drawing/2018/hyperlinkcolor" val="tx"/>
+                    </a:ext>
+                  </a:extLst>
+                </a:hlinkClick>
+              </a:rPr>
+              <a:t>gdex.ucar.edu/rda_pg_config/</a:t>
             </a:r>
             <a:pPr indent="0" marL="0">
               <a:lnSpc>
-                <a:spcPct val="108000"/>
+                <a:spcPct val="105000"/>
               </a:lnSpc>
               <a:buNone/>
             </a:pPr>
-            <a:r>
-              <a:rPr lang="en-US" sz="1250" dirty="0">
+            <a:endParaRPr lang="en-US" sz="1100" dirty="0"/>
+          </a:p>
+          <a:p>
+            <a:pPr indent="0" marL="0">
+              <a:lnSpc>
+                <a:spcPct val="105000"/>
+              </a:lnSpc>
+              <a:buNone/>
+            </a:pPr>
+            <a:r>
+              <a:rPr lang="en-US" sz="1100" dirty="0">
                 <a:solidFill>
                   <a:srgbClr val="00357A"/>
                 </a:solidFill>
@@ -38187,16 +38238,116 @@
                 <a:ea typeface="Poppins" pitchFamily="34" charset="-122"/>
                 <a:cs typeface="Poppins" pitchFamily="34" charset="-120"/>
               </a:rPr>
-              <a:t> or </a:t>
-            </a:r>
+              <a:t>under </a:t>
+            </a:r>
+            <a:endParaRPr lang="en-US" sz="1100" dirty="0"/>
+          </a:p>
+          <a:p>
             <a:pPr indent="0" marL="0">
               <a:lnSpc>
-                <a:spcPct val="108000"/>
+                <a:spcPct val="105000"/>
               </a:lnSpc>
               <a:buNone/>
             </a:pPr>
             <a:r>
-              <a:rPr lang="en-US" sz="1250" b="1" dirty="0">
+              <a:rPr lang="en-US" sz="1100" b="1" dirty="0">
+                <a:solidFill>
+                  <a:srgbClr val="00357A"/>
+                </a:solidFill>
+                <a:latin typeface="Poppins" pitchFamily="34" charset="0"/>
+                <a:ea typeface="Poppins" pitchFamily="34" charset="-122"/>
+                <a:cs typeface="Poppins" pitchFamily="34" charset="-120"/>
+              </a:rPr>
+              <a:t>DSARCH → Dataset Information</a:t>
+            </a:r>
+            <a:pPr indent="0" marL="0">
+              <a:lnSpc>
+                <a:spcPct val="105000"/>
+              </a:lnSpc>
+              <a:buNone/>
+            </a:pPr>
+            <a:r>
+              <a:rPr lang="en-US" sz="1100" dirty="0">
+                <a:solidFill>
+                  <a:srgbClr val="00357A"/>
+                </a:solidFill>
+                <a:latin typeface="Poppins" pitchFamily="34" charset="0"/>
+                <a:ea typeface="Poppins" pitchFamily="34" charset="-122"/>
+                <a:cs typeface="Poppins" pitchFamily="34" charset="-120"/>
+              </a:rPr>
+              <a:t>, where backflag is set or changed per dataset.</a:t>
+            </a:r>
+            <a:endParaRPr lang="en-US" sz="1100" dirty="0"/>
+          </a:p>
+        </p:txBody>
+      </p:sp>
+      <p:sp>
+        <p:nvSpPr>
+          <p:cNvPr id="9" name="Shape 6"/>
+          <p:cNvSpPr/>
+          <p:nvPr/>
+        </p:nvSpPr>
+        <p:spPr>
+          <a:xfrm>
+            <a:off x="457200" y="5614416"/>
+            <a:ext cx="5532120" cy="457200"/>
+          </a:xfrm>
+          <a:prstGeom prst="roundRect">
+            <a:avLst>
+              <a:gd name="adj" fmla="val 16000"/>
+            </a:avLst>
+          </a:prstGeom>
+          <a:solidFill>
+            <a:srgbClr val="C7E4F5"/>
+          </a:solidFill>
+          <a:ln w="12700">
+            <a:solidFill>
+              <a:srgbClr val="A9D6F2"/>
+            </a:solidFill>
+            <a:prstDash val="solid"/>
+          </a:ln>
+        </p:spPr>
+      </p:sp>
+      <p:sp>
+        <p:nvSpPr>
+          <p:cNvPr id="10" name="Text 7"/>
+          <p:cNvSpPr/>
+          <p:nvPr/>
+        </p:nvSpPr>
+        <p:spPr>
+          <a:xfrm>
+            <a:off x="658368" y="5614416"/>
+            <a:ext cx="5120640" cy="457200"/>
+          </a:xfrm>
+          <a:prstGeom prst="rect">
+            <a:avLst/>
+          </a:prstGeom>
+          <a:noFill/>
+          <a:ln/>
+        </p:spPr>
+        <p:txBody>
+          <a:bodyPr wrap="square" lIns="0" tIns="0" rIns="0" bIns="0" rtlCol="0" anchor="ctr"/>
+          <a:lstStyle/>
+          <a:p>
+            <a:pPr indent="0" marL="0">
+              <a:buNone/>
+            </a:pPr>
+            <a:r>
+              <a:rPr lang="en-US" sz="1050" b="1" dirty="0">
+                <a:solidFill>
+                  <a:srgbClr val="0057C2"/>
+                </a:solidFill>
+                <a:latin typeface="Poppins" pitchFamily="34" charset="0"/>
+                <a:ea typeface="Poppins" pitchFamily="34" charset="-122"/>
+                <a:cs typeface="Poppins" pitchFamily="34" charset="-120"/>
+              </a:rPr>
+              <a:t>Per-run override:  </a:t>
+            </a:r>
+            <a:pPr indent="0" marL="0">
+              <a:buNone/>
+            </a:pPr>
+            <a:r>
+              <a:rPr lang="en-US" sz="1050" b="1" dirty="0">
                 <a:solidFill>
                   <a:srgbClr val="00357A"/>
                 </a:solidFill>
@@ -38204,16 +38355,41 @@
                 <a:ea typeface="Courier New" pitchFamily="34" charset="-122"/>
                 <a:cs typeface="Courier New" pitchFamily="34" charset="-120"/>
               </a:rPr>
+              <a:t>-B</a:t>
+            </a:r>
+            <a:pPr indent="0" marL="0">
+              <a:buNone/>
+            </a:pPr>
+            <a:r>
+              <a:rPr lang="en-US" sz="1050" dirty="0">
+                <a:solidFill>
+                  <a:srgbClr val="00357A"/>
+                </a:solidFill>
+                <a:latin typeface="Poppins" pitchFamily="34" charset="0"/>
+                <a:ea typeface="Poppins" pitchFamily="34" charset="-122"/>
+                <a:cs typeface="Poppins" pitchFamily="34" charset="-120"/>
+              </a:rPr>
+              <a:t> or </a:t>
+            </a:r>
+            <a:pPr indent="0" marL="0">
+              <a:buNone/>
+            </a:pPr>
+            <a:r>
+              <a:rPr lang="en-US" sz="1050" b="1" dirty="0">
+                <a:solidFill>
+                  <a:srgbClr val="00357A"/>
+                </a:solidFill>
+                <a:latin typeface="Courier New" pitchFamily="34" charset="0"/>
+                <a:ea typeface="Courier New" pitchFamily="34" charset="-122"/>
+                <a:cs typeface="Courier New" pitchFamily="34" charset="-120"/>
+              </a:rPr>
               <a:t>-D</a:t>
             </a:r>
             <a:pPr indent="0" marL="0">
-              <a:lnSpc>
-                <a:spcPct val="108000"/>
-              </a:lnSpc>
-              <a:buNone/>
-            </a:pPr>
-            <a:r>
-              <a:rPr lang="en-US" sz="1250" dirty="0">
+              <a:buNone/>
+            </a:pPr>
+            <a:r>
+              <a:rPr lang="en-US" sz="1050" dirty="0">
                 <a:solidFill>
                   <a:srgbClr val="00357A"/>
                 </a:solidFill>
@@ -38221,15 +38397,15 @@
                 <a:ea typeface="Poppins" pitchFamily="34" charset="-122"/>
                 <a:cs typeface="Poppins" pitchFamily="34" charset="-120"/>
               </a:rPr>
-              <a:t> narrows a run to just that copy — they are mutually exclusive, and giving neither works on both.</a:t>
-            </a:r>
-            <a:endParaRPr lang="en-US" sz="1250" dirty="0"/>
-          </a:p>
-        </p:txBody>
-      </p:sp>
-      <p:sp>
-        <p:nvSpPr>
-          <p:cNvPr id="9" name="Shape 6"/>
+              <a:t> narrows a run to one copy — mutually exclusive; neither means both.</a:t>
+            </a:r>
+            <a:endParaRPr lang="en-US" sz="1050" dirty="0"/>
+          </a:p>
+        </p:txBody>
+      </p:sp>
+      <p:sp>
+        <p:nvSpPr>
+          <p:cNvPr id="11" name="Shape 8"/>
           <p:cNvSpPr/>
           <p:nvPr/>
         </p:nvSpPr>
@@ -38256,7 +38432,7 @@
       </p:sp>
       <p:sp>
         <p:nvSpPr>
-          <p:cNvPr id="10" name="Text 7"/>
+          <p:cNvPr id="12" name="Text 9"/>
           <p:cNvSpPr/>
           <p:nvPr/>
         </p:nvSpPr>
@@ -38295,7 +38471,7 @@
       </p:sp>
       <p:sp>
         <p:nvSpPr>
-          <p:cNvPr id="11" name="Shape 8"/>
+          <p:cNvPr id="13" name="Shape 10"/>
           <p:cNvSpPr/>
           <p:nvPr/>
         </p:nvSpPr>
@@ -38317,7 +38493,7 @@
       </p:sp>
       <p:sp>
         <p:nvSpPr>
-          <p:cNvPr id="12" name="Text 9"/>
+          <p:cNvPr id="14" name="Text 11"/>
           <p:cNvSpPr/>
           <p:nvPr/>
         </p:nvSpPr>
@@ -38371,7 +38547,7 @@
       </p:sp>
       <p:sp>
         <p:nvSpPr>
-          <p:cNvPr id="13" name="Text 10"/>
+          <p:cNvPr id="15" name="Text 12"/>
           <p:cNvSpPr/>
           <p:nvPr/>
         </p:nvSpPr>
@@ -38410,7 +38586,7 @@
       </p:sp>
       <p:sp>
         <p:nvSpPr>
-          <p:cNvPr id="14" name="Shape 11"/>
+          <p:cNvPr id="16" name="Shape 13"/>
           <p:cNvSpPr/>
           <p:nvPr/>
         </p:nvSpPr>
@@ -38437,7 +38613,7 @@
       </p:sp>
       <p:sp>
         <p:nvSpPr>
-          <p:cNvPr id="15" name="Text 12"/>
+          <p:cNvPr id="17" name="Text 14"/>
           <p:cNvSpPr/>
           <p:nvPr/>
         </p:nvSpPr>
@@ -38476,7 +38652,7 @@
       </p:sp>
       <p:sp>
         <p:nvSpPr>
-          <p:cNvPr id="16" name="Text 13"/>
+          <p:cNvPr id="18" name="Text 15"/>
           <p:cNvSpPr/>
           <p:nvPr/>
         </p:nvSpPr>
@@ -38515,7 +38691,7 @@
       </p:sp>
       <p:sp>
         <p:nvSpPr>
-          <p:cNvPr id="17" name="Shape 14"/>
+          <p:cNvPr id="19" name="Shape 16"/>
           <p:cNvSpPr/>
           <p:nvPr/>
         </p:nvSpPr>
@@ -38542,7 +38718,7 @@
       </p:sp>
       <p:sp>
         <p:nvSpPr>
-          <p:cNvPr id="18" name="Text 15"/>
+          <p:cNvPr id="20" name="Text 17"/>
           <p:cNvSpPr/>
           <p:nvPr/>
         </p:nvSpPr>
@@ -38581,7 +38757,7 @@
       </p:sp>
       <p:sp>
         <p:nvSpPr>
-          <p:cNvPr id="19" name="Text 16"/>
+          <p:cNvPr id="21" name="Text 18"/>
           <p:cNvSpPr/>
           <p:nvPr/>
         </p:nvSpPr>
@@ -38620,7 +38796,7 @@
       </p:sp>
       <p:sp>
         <p:nvSpPr>
-          <p:cNvPr id="20" name="Text 17"/>
+          <p:cNvPr id="22" name="Text 19"/>
           <p:cNvSpPr/>
           <p:nvPr/>
         </p:nvSpPr>
@@ -38662,14 +38838,14 @@
       </p:sp>
       <p:pic>
         <p:nvPicPr>
-          <p:cNvPr id="21" name="Image 0" descr="nsf_ncar_logo_color.png">    </p:cNvPr>
+          <p:cNvPr id="23" name="Image 0" descr="nsf_ncar_logo_color.png">    </p:cNvPr>
           <p:cNvPicPr>
             <a:picLocks noChangeAspect="1"/>
           </p:cNvPicPr>
           <p:nvPr/>
         </p:nvPicPr>
         <p:blipFill>
-          <a:blip r:embed="rId1"/>
+          <a:blip r:embed="rId2"/>
           <a:stretch>
             <a:fillRect/>
           </a:stretch>
@@ -38686,7 +38862,7 @@
       </p:pic>
       <p:sp>
         <p:nvSpPr>
-          <p:cNvPr id="22" name="Text 18"/>
+          <p:cNvPr id="24" name="Text 20"/>
           <p:cNvSpPr/>
           <p:nvPr/>
         </p:nvSpPr>
@@ -38725,7 +38901,7 @@
       </p:sp>
       <p:sp>
         <p:nvSpPr>
-          <p:cNvPr id="23" name="Text 19"/>
+          <p:cNvPr id="25" name="Text 21"/>
           <p:cNvSpPr/>
           <p:nvPr/>
         </p:nvSpPr>

</xml_diff>

<commit_message>
fix slide layout defects found by rendering every slide
Text clipped inside fixed-height boxes and boxes overlapping the footer
were invisible in the source but obvious once each slide was rendered.
Shortened overlong card bodies and list items, retuned the y positions on
slides 2, 7, 8, 10, 11, 13, 14, 15, 18, 20, 23, 24 and 25, split the
timeline labels on 18 so they no longer collide, and rebuilt the deck.

Co-Authored-By: Claude Opus 4.6 <noreply@anthropic.com>
</commit_message>
<xml_diff>
--- a/docs/slides/dsquasar_guide.pptx
+++ b/docs/slides/dsquasar_guide.pptx
@@ -4458,12 +4458,12 @@
         </p:nvSpPr>
         <p:spPr>
           <a:xfrm>
-            <a:off x="457200" y="4206240"/>
-            <a:ext cx="11247120" cy="603504"/>
+            <a:off x="457200" y="4187952"/>
+            <a:ext cx="11247120" cy="548640"/>
           </a:xfrm>
           <a:prstGeom prst="roundRect">
             <a:avLst>
-              <a:gd name="adj" fmla="val 12121"/>
+              <a:gd name="adj" fmla="val 13333"/>
             </a:avLst>
           </a:prstGeom>
           <a:solidFill>
@@ -4485,8 +4485,8 @@
         </p:nvSpPr>
         <p:spPr>
           <a:xfrm>
-            <a:off x="685800" y="4206240"/>
-            <a:ext cx="2377440" cy="603504"/>
+            <a:off x="685800" y="4187952"/>
+            <a:ext cx="2377440" cy="548640"/>
           </a:xfrm>
           <a:prstGeom prst="rect">
             <a:avLst/>
@@ -4524,8 +4524,8 @@
         </p:nvSpPr>
         <p:spPr>
           <a:xfrm>
-            <a:off x="3108960" y="4206240"/>
-            <a:ext cx="8412480" cy="603504"/>
+            <a:off x="3108960" y="4187952"/>
+            <a:ext cx="8412480" cy="548640"/>
           </a:xfrm>
           <a:prstGeom prst="rect">
             <a:avLst/>
@@ -4563,12 +4563,12 @@
         </p:nvSpPr>
         <p:spPr>
           <a:xfrm>
-            <a:off x="457200" y="4919472"/>
-            <a:ext cx="11247120" cy="603504"/>
+            <a:off x="457200" y="4809744"/>
+            <a:ext cx="11247120" cy="548640"/>
           </a:xfrm>
           <a:prstGeom prst="roundRect">
             <a:avLst>
-              <a:gd name="adj" fmla="val 12121"/>
+              <a:gd name="adj" fmla="val 13333"/>
             </a:avLst>
           </a:prstGeom>
           <a:solidFill>
@@ -4590,8 +4590,8 @@
         </p:nvSpPr>
         <p:spPr>
           <a:xfrm>
-            <a:off x="685800" y="4919472"/>
-            <a:ext cx="2377440" cy="603504"/>
+            <a:off x="685800" y="4809744"/>
+            <a:ext cx="2377440" cy="548640"/>
           </a:xfrm>
           <a:prstGeom prst="rect">
             <a:avLst/>
@@ -4629,8 +4629,8 @@
         </p:nvSpPr>
         <p:spPr>
           <a:xfrm>
-            <a:off x="3108960" y="4919472"/>
-            <a:ext cx="8412480" cy="603504"/>
+            <a:off x="3108960" y="4809744"/>
+            <a:ext cx="8412480" cy="548640"/>
           </a:xfrm>
           <a:prstGeom prst="rect">
             <a:avLst/>
@@ -4668,12 +4668,12 @@
         </p:nvSpPr>
         <p:spPr>
           <a:xfrm>
-            <a:off x="457200" y="5632704"/>
-            <a:ext cx="11247120" cy="603504"/>
+            <a:off x="457200" y="5431536"/>
+            <a:ext cx="11247120" cy="548640"/>
           </a:xfrm>
           <a:prstGeom prst="roundRect">
             <a:avLst>
-              <a:gd name="adj" fmla="val 12121"/>
+              <a:gd name="adj" fmla="val 13333"/>
             </a:avLst>
           </a:prstGeom>
           <a:solidFill>
@@ -4695,8 +4695,8 @@
         </p:nvSpPr>
         <p:spPr>
           <a:xfrm>
-            <a:off x="685800" y="5632704"/>
-            <a:ext cx="2377440" cy="603504"/>
+            <a:off x="685800" y="5431536"/>
+            <a:ext cx="2377440" cy="548640"/>
           </a:xfrm>
           <a:prstGeom prst="rect">
             <a:avLst/>
@@ -4734,8 +4734,8 @@
         </p:nvSpPr>
         <p:spPr>
           <a:xfrm>
-            <a:off x="3108960" y="5632704"/>
-            <a:ext cx="8412480" cy="603504"/>
+            <a:off x="3108960" y="5431536"/>
+            <a:ext cx="8412480" cy="548640"/>
           </a:xfrm>
           <a:prstGeom prst="rect">
             <a:avLst/>
@@ -4773,8 +4773,8 @@
         </p:nvSpPr>
         <p:spPr>
           <a:xfrm>
-            <a:off x="457200" y="6309360"/>
-            <a:ext cx="11274552" cy="320040"/>
+            <a:off x="457200" y="6035040"/>
+            <a:ext cx="11274552" cy="292608"/>
           </a:xfrm>
           <a:prstGeom prst="rect">
             <a:avLst/>
@@ -4790,7 +4790,7 @@
               <a:buNone/>
             </a:pPr>
             <a:r>
-              <a:rPr lang="en-US" sz="1250" dirty="0">
+              <a:rPr lang="en-US" sz="1200" dirty="0">
                 <a:solidFill>
                   <a:srgbClr val="53565A"/>
                 </a:solidFill>
@@ -4804,7 +4804,7 @@
               <a:buNone/>
             </a:pPr>
             <a:r>
-              <a:rPr lang="en-US" sz="1250" b="1" dirty="0">
+              <a:rPr lang="en-US" sz="1200" b="1" dirty="0">
                 <a:solidFill>
                   <a:srgbClr val="53565A"/>
                 </a:solidFill>
@@ -4818,7 +4818,7 @@
               <a:buNone/>
             </a:pPr>
             <a:r>
-              <a:rPr lang="en-US" sz="1250" dirty="0">
+              <a:rPr lang="en-US" sz="1200" dirty="0">
                 <a:solidFill>
                   <a:srgbClr val="53565A"/>
                 </a:solidFill>
@@ -4832,7 +4832,7 @@
               <a:buNone/>
             </a:pPr>
             <a:r>
-              <a:rPr lang="en-US" sz="1250" b="1" dirty="0">
+              <a:rPr lang="en-US" sz="1200" b="1" dirty="0">
                 <a:solidFill>
                   <a:srgbClr val="53565A"/>
                 </a:solidFill>
@@ -4846,7 +4846,7 @@
               <a:buNone/>
             </a:pPr>
             <a:r>
-              <a:rPr lang="en-US" sz="1250" dirty="0">
+              <a:rPr lang="en-US" sz="1200" dirty="0">
                 <a:solidFill>
                   <a:srgbClr val="53565A"/>
                 </a:solidFill>
@@ -4856,7 +4856,7 @@
               </a:rPr>
               <a:t> is simply picked up by the next run.</a:t>
             </a:r>
-            <a:endParaRPr lang="en-US" sz="1250" dirty="0"/>
+            <a:endParaRPr lang="en-US" sz="1200" dirty="0"/>
           </a:p>
         </p:txBody>
       </p:sp>
@@ -5147,7 +5147,7 @@
         <p:spPr>
           <a:xfrm>
             <a:off x="822960" y="2194560"/>
-            <a:ext cx="4937760" cy="2377440"/>
+            <a:ext cx="4937760" cy="2286000"/>
           </a:xfrm>
           <a:prstGeom prst="rect">
             <a:avLst/>
@@ -5161,7 +5161,7 @@
           <a:p>
             <a:pPr marL="254000" indent="-254000">
               <a:lnSpc>
-                <a:spcPct val="110000"/>
+                <a:spcPct val="108000"/>
               </a:lnSpc>
               <a:spcAft>
                 <a:spcPts val="900"/>
@@ -5171,7 +5171,7 @@
               <a:buAutoNum type="arabicPeriod" startAt="1"/>
             </a:pPr>
             <a:r>
-              <a:rPr lang="en-US" sz="1350" dirty="0">
+              <a:rPr lang="en-US" sz="1250" dirty="0">
                 <a:solidFill>
                   <a:srgbClr val="00357A"/>
                 </a:solidFill>
@@ -5181,12 +5181,12 @@
               </a:rPr>
               <a:t>Lock the dataset, then re-gather its files under the lock</a:t>
             </a:r>
-            <a:endParaRPr lang="en-US" sz="1350" dirty="0"/>
+            <a:endParaRPr lang="en-US" sz="1250" dirty="0"/>
           </a:p>
           <a:p>
             <a:pPr marL="254000" indent="-254000">
               <a:lnSpc>
-                <a:spcPct val="110000"/>
+                <a:spcPct val="108000"/>
               </a:lnSpc>
               <a:spcAft>
                 <a:spcPts val="900"/>
@@ -5196,7 +5196,7 @@
               <a:buAutoNum type="arabicPeriod" startAt="1"/>
             </a:pPr>
             <a:r>
-              <a:rPr lang="en-US" sz="1350" dirty="0">
+              <a:rPr lang="en-US" sz="1250" dirty="0">
                 <a:solidFill>
                   <a:srgbClr val="00357A"/>
                 </a:solidFill>
@@ -5206,12 +5206,12 @@
               </a:rPr>
               <a:t>Skip files already listed in an open 'N' record</a:t>
             </a:r>
-            <a:endParaRPr lang="en-US" sz="1350" dirty="0"/>
+            <a:endParaRPr lang="en-US" sz="1250" dirty="0"/>
           </a:p>
           <a:p>
             <a:pPr marL="254000" indent="-254000">
               <a:lnSpc>
-                <a:spcPct val="110000"/>
+                <a:spcPct val="108000"/>
               </a:lnSpc>
               <a:spcAft>
                 <a:spcPts val="900"/>
@@ -5221,7 +5221,7 @@
               <a:buAutoNum type="arabicPeriod" startAt="1"/>
             </a:pPr>
             <a:r>
-              <a:rPr lang="en-US" sz="1350" dirty="0">
+              <a:rPr lang="en-US" sz="1250" dirty="0">
                 <a:solidFill>
                   <a:srgbClr val="00357A"/>
                 </a:solidFill>
@@ -5229,14 +5229,14 @@
                 <a:ea typeface="Poppins" pitchFamily="34" charset="-122"/>
                 <a:cs typeface="Poppins" pitchFamily="34" charset="-120"/>
               </a:rPr>
-              <a:t>Re-check each file on disk or object storage; fix size, checksum and timestamp in GDEXDB if they drifted</a:t>
-            </a:r>
-            <a:endParaRPr lang="en-US" sz="1350" dirty="0"/>
+              <a:t>Re-check each file on disk or object storage; fix size, checksum and timestamp in GDEXDB</a:t>
+            </a:r>
+            <a:endParaRPr lang="en-US" sz="1250" dirty="0"/>
           </a:p>
           <a:p>
             <a:pPr marL="254000" indent="-254000">
               <a:lnSpc>
-                <a:spcPct val="110000"/>
+                <a:spcPct val="108000"/>
               </a:lnSpc>
               <a:spcAft>
                 <a:spcPts val="900"/>
@@ -5246,7 +5246,7 @@
               <a:buAutoNum type="arabicPeriod" startAt="1"/>
             </a:pPr>
             <a:r>
-              <a:rPr lang="en-US" sz="1350" dirty="0">
+              <a:rPr lang="en-US" sz="1250" dirty="0">
                 <a:solidFill>
                   <a:srgbClr val="00357A"/>
                 </a:solidFill>
@@ -5254,21 +5254,21 @@
                 <a:ea typeface="Poppins" pitchFamily="34" charset="-122"/>
                 <a:cs typeface="Poppins" pitchFamily="34" charset="-120"/>
               </a:rPr>
-              <a:t>Append a line per file to a dsarch input file, one per dataset and file type</a:t>
-            </a:r>
-            <a:endParaRPr lang="en-US" sz="1350" dirty="0"/>
+              <a:t>Append a line per file to a dsarch input file, per type</a:t>
+            </a:r>
+            <a:endParaRPr lang="en-US" sz="1250" dirty="0"/>
           </a:p>
           <a:p>
             <a:pPr marL="254000" indent="-254000">
               <a:lnSpc>
-                <a:spcPct val="110000"/>
+                <a:spcPct val="108000"/>
               </a:lnSpc>
               <a:buSzPct val="100000"/>
               <a:buFont typeface="+mj-lt"/>
               <a:buAutoNum type="arabicPeriod" startAt="1"/>
             </a:pPr>
             <a:r>
-              <a:rPr lang="en-US" sz="1350" dirty="0">
+              <a:rPr lang="en-US" sz="1250" dirty="0">
                 <a:solidFill>
                   <a:srgbClr val="00357A"/>
                 </a:solidFill>
@@ -5276,9 +5276,9 @@
                 <a:ea typeface="Poppins" pitchFamily="34" charset="-122"/>
                 <a:cs typeface="Poppins" pitchFamily="34" charset="-120"/>
               </a:rPr>
-              <a:t>Close the group once it is big enough and add the bfile placeholder record</a:t>
-            </a:r>
-            <a:endParaRPr lang="en-US" sz="1350" dirty="0"/>
+              <a:t>Close the group when big enough; add the bfile record</a:t>
+            </a:r>
+            <a:endParaRPr lang="en-US" sz="1250" dirty="0"/>
           </a:p>
         </p:txBody>
       </p:sp>
@@ -8283,7 +8283,7 @@
         <p:spPr>
           <a:xfrm>
             <a:off x="822960" y="2194560"/>
-            <a:ext cx="4937760" cy="2651760"/>
+            <a:ext cx="4937760" cy="2560320"/>
           </a:xfrm>
           <a:prstGeom prst="rect">
             <a:avLst/>
@@ -8297,7 +8297,7 @@
           <a:p>
             <a:pPr marL="254000" indent="-254000">
               <a:lnSpc>
-                <a:spcPct val="110000"/>
+                <a:spcPct val="108000"/>
               </a:lnSpc>
               <a:spcAft>
                 <a:spcPts val="900"/>
@@ -8307,7 +8307,7 @@
               <a:buAutoNum type="arabicPeriod" startAt="1"/>
             </a:pPr>
             <a:r>
-              <a:rPr lang="en-US" sz="1350" dirty="0">
+              <a:rPr lang="en-US" sz="1250" dirty="0">
                 <a:solidFill>
                   <a:srgbClr val="00357A"/>
                 </a:solidFill>
@@ -8315,14 +8315,14 @@
                 <a:ea typeface="Poppins" pitchFamily="34" charset="-122"/>
                 <a:cs typeface="Poppins" pitchFamily="34" charset="-120"/>
               </a:rPr>
-              <a:t>Walk the status 'T' records and accumulate tars until the batch reaches 90 GB</a:t>
-            </a:r>
-            <a:endParaRPr lang="en-US" sz="1350" dirty="0"/>
+              <a:t>Walk the 'T' records, accumulating tars until the batch hits 90 GB</a:t>
+            </a:r>
+            <a:endParaRPr lang="en-US" sz="1250" dirty="0"/>
           </a:p>
           <a:p>
             <a:pPr marL="254000" indent="-254000">
               <a:lnSpc>
-                <a:spcPct val="110000"/>
+                <a:spcPct val="108000"/>
               </a:lnSpc>
               <a:spcAft>
                 <a:spcPts val="900"/>
@@ -8332,7 +8332,7 @@
               <a:buAutoNum type="arabicPeriod" startAt="1"/>
             </a:pPr>
             <a:r>
-              <a:rPr lang="en-US" sz="1350" dirty="0">
+              <a:rPr lang="en-US" sz="1250" dirty="0">
                 <a:solidFill>
                   <a:srgbClr val="00357A"/>
                 </a:solidFill>
@@ -8340,14 +8340,14 @@
                 <a:ea typeface="Poppins" pitchFamily="34" charset="-122"/>
                 <a:cs typeface="Poppins" pitchFamily="34" charset="-120"/>
               </a:rPr>
-              <a:t>Confirm each tar still exists on gdex-glade; if not, reset that record to 'N' to be rebuilt</a:t>
-            </a:r>
-            <a:endParaRPr lang="en-US" sz="1350" dirty="0"/>
+              <a:t>Confirm each tar still exists on gdex-glade; if not, reset it to 'N'</a:t>
+            </a:r>
+            <a:endParaRPr lang="en-US" sz="1250" dirty="0"/>
           </a:p>
           <a:p>
             <a:pPr marL="254000" indent="-254000">
               <a:lnSpc>
-                <a:spcPct val="110000"/>
+                <a:spcPct val="108000"/>
               </a:lnSpc>
               <a:spcAft>
                 <a:spcPts val="900"/>
@@ -8357,7 +8357,7 @@
               <a:buAutoNum type="arabicPeriod" startAt="1"/>
             </a:pPr>
             <a:r>
-              <a:rPr lang="en-US" sz="1350" dirty="0">
+              <a:rPr lang="en-US" sz="1250" dirty="0">
                 <a:solidFill>
                   <a:srgbClr val="00357A"/>
                 </a:solidFill>
@@ -8365,14 +8365,14 @@
                 <a:ea typeface="Poppins" pitchFamily="34" charset="-122"/>
                 <a:cs typeface="Poppins" pitchFamily="34" charset="-120"/>
               </a:rPr>
-              <a:t>Hand the whole list to dsglobus as one transfer — Drdata first when the flag is 'D', then Backup</a:t>
-            </a:r>
-            <a:endParaRPr lang="en-US" sz="1350" dirty="0"/>
+              <a:t>Hand the whole list to dsglobus as one transfer — Drdata first, then Backup</a:t>
+            </a:r>
+            <a:endParaRPr lang="en-US" sz="1250" dirty="0"/>
           </a:p>
           <a:p>
             <a:pPr marL="254000" indent="-254000">
               <a:lnSpc>
-                <a:spcPct val="110000"/>
+                <a:spcPct val="108000"/>
               </a:lnSpc>
               <a:spcAft>
                 <a:spcPts val="900"/>
@@ -8382,7 +8382,7 @@
               <a:buAutoNum type="arabicPeriod" startAt="1"/>
             </a:pPr>
             <a:r>
-              <a:rPr lang="en-US" sz="1350" dirty="0">
+              <a:rPr lang="en-US" sz="1250" dirty="0">
                 <a:solidFill>
                   <a:srgbClr val="00357A"/>
                 </a:solidFill>
@@ -8392,19 +8392,19 @@
               </a:rPr>
               <a:t>Wait for both transfers to report finished</a:t>
             </a:r>
-            <a:endParaRPr lang="en-US" sz="1350" dirty="0"/>
+            <a:endParaRPr lang="en-US" sz="1250" dirty="0"/>
           </a:p>
           <a:p>
             <a:pPr marL="254000" indent="-254000">
               <a:lnSpc>
-                <a:spcPct val="110000"/>
+                <a:spcPct val="108000"/>
               </a:lnSpc>
               <a:buSzPct val="100000"/>
               <a:buFont typeface="+mj-lt"/>
               <a:buAutoNum type="arabicPeriod" startAt="1"/>
             </a:pPr>
             <a:r>
-              <a:rPr lang="en-US" sz="1350" dirty="0">
+              <a:rPr lang="en-US" sz="1250" dirty="0">
                 <a:solidFill>
                   <a:srgbClr val="00357A"/>
                 </a:solidFill>
@@ -8412,9 +8412,9 @@
                 <a:ea typeface="Poppins" pitchFamily="34" charset="-122"/>
                 <a:cs typeface="Poppins" pitchFamily="34" charset="-120"/>
               </a:rPr>
-              <a:t>Delete the local tars and set every record in the batch to status 'A'</a:t>
-            </a:r>
-            <a:endParaRPr lang="en-US" sz="1350" dirty="0"/>
+              <a:t>Delete the local tars and set every record to status 'A'</a:t>
+            </a:r>
+            <a:endParaRPr lang="en-US" sz="1250" dirty="0"/>
           </a:p>
         </p:txBody>
       </p:sp>
@@ -8551,12 +8551,12 @@
         </p:nvSpPr>
         <p:spPr>
           <a:xfrm>
-            <a:off x="6199632" y="1965960"/>
-            <a:ext cx="5532120" cy="2011680"/>
+            <a:off x="6199632" y="1938528"/>
+            <a:ext cx="5532120" cy="1600200"/>
           </a:xfrm>
           <a:prstGeom prst="roundRect">
             <a:avLst>
-              <a:gd name="adj" fmla="val 4545"/>
+              <a:gd name="adj" fmla="val 5714"/>
             </a:avLst>
           </a:prstGeom>
           <a:solidFill>
@@ -8578,7 +8578,7 @@
         </p:nvSpPr>
         <p:spPr>
           <a:xfrm>
-            <a:off x="6446520" y="2240280"/>
+            <a:off x="6446520" y="2148840"/>
             <a:ext cx="457200" cy="347472"/>
           </a:xfrm>
           <a:prstGeom prst="roundRect">
@@ -8600,7 +8600,7 @@
         </p:nvSpPr>
         <p:spPr>
           <a:xfrm>
-            <a:off x="6995160" y="2240280"/>
+            <a:off x="6995160" y="2148840"/>
             <a:ext cx="457200" cy="347472"/>
           </a:xfrm>
           <a:prstGeom prst="roundRect">
@@ -8622,7 +8622,7 @@
         </p:nvSpPr>
         <p:spPr>
           <a:xfrm>
-            <a:off x="7543800" y="2240280"/>
+            <a:off x="7543800" y="2148840"/>
             <a:ext cx="457200" cy="347472"/>
           </a:xfrm>
           <a:prstGeom prst="roundRect">
@@ -8644,7 +8644,7 @@
         </p:nvSpPr>
         <p:spPr>
           <a:xfrm>
-            <a:off x="8092440" y="2240280"/>
+            <a:off x="8092440" y="2148840"/>
             <a:ext cx="457200" cy="347472"/>
           </a:xfrm>
           <a:prstGeom prst="roundRect">
@@ -8666,7 +8666,7 @@
         </p:nvSpPr>
         <p:spPr>
           <a:xfrm>
-            <a:off x="8641080" y="2240280"/>
+            <a:off x="8641080" y="2148840"/>
             <a:ext cx="457200" cy="347472"/>
           </a:xfrm>
           <a:prstGeom prst="roundRect">
@@ -8688,7 +8688,7 @@
         </p:nvSpPr>
         <p:spPr>
           <a:xfrm>
-            <a:off x="9189720" y="2240280"/>
+            <a:off x="9189720" y="2148840"/>
             <a:ext cx="457200" cy="347472"/>
           </a:xfrm>
           <a:prstGeom prst="roundRect">
@@ -8710,7 +8710,7 @@
         </p:nvSpPr>
         <p:spPr>
           <a:xfrm>
-            <a:off x="9738360" y="2240280"/>
+            <a:off x="9738360" y="2148840"/>
             <a:ext cx="457200" cy="347472"/>
           </a:xfrm>
           <a:prstGeom prst="roundRect">
@@ -8732,7 +8732,7 @@
         </p:nvSpPr>
         <p:spPr>
           <a:xfrm>
-            <a:off x="10287000" y="2240280"/>
+            <a:off x="10287000" y="2148840"/>
             <a:ext cx="457200" cy="347472"/>
           </a:xfrm>
           <a:prstGeom prst="roundRect">
@@ -8754,7 +8754,7 @@
         </p:nvSpPr>
         <p:spPr>
           <a:xfrm>
-            <a:off x="10835640" y="2240280"/>
+            <a:off x="10835640" y="2148840"/>
             <a:ext cx="457200" cy="347472"/>
           </a:xfrm>
           <a:prstGeom prst="roundRect">
@@ -8776,7 +8776,7 @@
         </p:nvSpPr>
         <p:spPr>
           <a:xfrm>
-            <a:off x="6446520" y="2697480"/>
+            <a:off x="6446520" y="2606040"/>
             <a:ext cx="457200" cy="347472"/>
           </a:xfrm>
           <a:prstGeom prst="roundRect">
@@ -8798,7 +8798,7 @@
         </p:nvSpPr>
         <p:spPr>
           <a:xfrm>
-            <a:off x="6995160" y="2697480"/>
+            <a:off x="6995160" y="2606040"/>
             <a:ext cx="457200" cy="347472"/>
           </a:xfrm>
           <a:prstGeom prst="roundRect">
@@ -8820,7 +8820,7 @@
         </p:nvSpPr>
         <p:spPr>
           <a:xfrm>
-            <a:off x="7543800" y="2697480"/>
+            <a:off x="7543800" y="2606040"/>
             <a:ext cx="457200" cy="347472"/>
           </a:xfrm>
           <a:prstGeom prst="roundRect">
@@ -8842,7 +8842,7 @@
         </p:nvSpPr>
         <p:spPr>
           <a:xfrm>
-            <a:off x="8092440" y="2697480"/>
+            <a:off x="8092440" y="2606040"/>
             <a:ext cx="457200" cy="347472"/>
           </a:xfrm>
           <a:prstGeom prst="roundRect">
@@ -8864,7 +8864,7 @@
         </p:nvSpPr>
         <p:spPr>
           <a:xfrm>
-            <a:off x="8641080" y="2697480"/>
+            <a:off x="8641080" y="2606040"/>
             <a:ext cx="457200" cy="347472"/>
           </a:xfrm>
           <a:prstGeom prst="roundRect">
@@ -8886,7 +8886,7 @@
         </p:nvSpPr>
         <p:spPr>
           <a:xfrm>
-            <a:off x="9189720" y="2697480"/>
+            <a:off x="9189720" y="2606040"/>
             <a:ext cx="457200" cy="347472"/>
           </a:xfrm>
           <a:prstGeom prst="roundRect">
@@ -8908,7 +8908,7 @@
         </p:nvSpPr>
         <p:spPr>
           <a:xfrm>
-            <a:off x="9738360" y="2697480"/>
+            <a:off x="9738360" y="2606040"/>
             <a:ext cx="457200" cy="347472"/>
           </a:xfrm>
           <a:prstGeom prst="roundRect">
@@ -8930,7 +8930,7 @@
         </p:nvSpPr>
         <p:spPr>
           <a:xfrm>
-            <a:off x="10287000" y="2697480"/>
+            <a:off x="10287000" y="2606040"/>
             <a:ext cx="457200" cy="347472"/>
           </a:xfrm>
           <a:prstGeom prst="roundRect">
@@ -8952,7 +8952,7 @@
         </p:nvSpPr>
         <p:spPr>
           <a:xfrm>
-            <a:off x="10835640" y="2697480"/>
+            <a:off x="10835640" y="2606040"/>
             <a:ext cx="457200" cy="347472"/>
           </a:xfrm>
           <a:prstGeom prst="roundRect">
@@ -8974,7 +8974,7 @@
         </p:nvSpPr>
         <p:spPr>
           <a:xfrm>
-            <a:off x="6446520" y="3200400"/>
+            <a:off x="6446520" y="3108960"/>
             <a:ext cx="5029200" cy="320040"/>
           </a:xfrm>
           <a:prstGeom prst="rect">
@@ -9013,8 +9013,8 @@
         </p:nvSpPr>
         <p:spPr>
           <a:xfrm>
-            <a:off x="6446520" y="3520440"/>
-            <a:ext cx="5029200" cy="548640"/>
+            <a:off x="6199632" y="3611880"/>
+            <a:ext cx="5532120" cy="457200"/>
           </a:xfrm>
           <a:prstGeom prst="rect">
             <a:avLst/>
@@ -9041,7 +9041,7 @@
                 <a:ea typeface="Poppins" pitchFamily="34" charset="-122"/>
                 <a:cs typeface="Poppins" pitchFamily="34" charset="-120"/>
               </a:rPr>
-              <a:t>dsarch AQ can upload a tar as it builds it, but only one at a time. dsquasar instead calls dsglobus directly with the whole list, so a batch costs one transfer request rather than eighteen. Each batch is also the unit of parallelism — one child process per batch.</a:t>
+              <a:t>dsarch AQ can upload a tar as it builds it, but only one at a time. dsquasar calls dsglobus with the whole list, so a batch costs one request, not eighteen.</a:t>
             </a:r>
             <a:endParaRPr lang="en-US" sz="1100" dirty="0"/>
           </a:p>
@@ -9055,7 +9055,7 @@
         </p:nvSpPr>
         <p:spPr>
           <a:xfrm>
-            <a:off x="6199632" y="4114800"/>
+            <a:off x="6199632" y="4133088"/>
             <a:ext cx="5532120" cy="320040"/>
           </a:xfrm>
           <a:prstGeom prst="rect">
@@ -9437,7 +9437,7 @@
                 <a:ea typeface="Poppins" pitchFamily="34" charset="-122"/>
                 <a:cs typeface="Poppins" pitchFamily="34" charset="-120"/>
               </a:rPr>
-              <a:t>CHANGED FILES</a:t>
+              <a:t>-C CHANGEDAYS</a:t>
             </a:r>
             <a:endParaRPr lang="en-US" sz="1200" dirty="0"/>
           </a:p>
@@ -9476,7 +9476,7 @@
                 <a:ea typeface="Poppins" pitchFamily="34" charset="-122"/>
                 <a:cs typeface="Poppins" pitchFamily="34" charset="-120"/>
               </a:rPr>
-              <a:t>-c ChangeDays  —  Re-Backing Up What Moved</a:t>
+              <a:t>Re-Backing Up Files That Changed</a:t>
             </a:r>
             <a:endParaRPr lang="en-US" sz="3200" dirty="0"/>
           </a:p>
@@ -9510,7 +9510,7 @@
               <a:buNone/>
             </a:pPr>
             <a:r>
-              <a:rPr lang="en-US" sz="1450" dirty="0">
+              <a:rPr lang="en-US" sz="1350" dirty="0">
                 <a:solidFill>
                   <a:srgbClr val="00357A"/>
                 </a:solidFill>
@@ -9518,9 +9518,9 @@
                 <a:ea typeface="Poppins" pitchFamily="34" charset="-122"/>
                 <a:cs typeface="Poppins" pitchFamily="34" charset="-120"/>
               </a:rPr>
-              <a:t>A file already on tape can be replaced on disk: a corrected version, a re-generated grid, a re-processed year. The tape copy is then stale. -c tells dsquasar to look past the “never backed up” test and pick up files whose GDEXDB record changed recently.</a:t>
-            </a:r>
-            <a:endParaRPr lang="en-US" sz="1450" dirty="0"/>
+              <a:t>A file already on tape can be replaced on disk: a corrected version, a re-processed year. The tape copy is then stale. -c looks past the “never backed up” test and picks up files whose GDEXDB record changed recently.</a:t>
+            </a:r>
+            <a:endParaRPr lang="en-US" sz="1350" dirty="0"/>
           </a:p>
         </p:txBody>
       </p:sp>
@@ -11969,7 +11969,7 @@
           </p:nvPr>
         </p:nvGraphicFramePr>
         <p:xfrm>
-          <a:off x="6537960" y="3611880"/>
+          <a:off x="6537960" y="3547872"/>
           <a:ext cx="5029200" cy="914400"/>
         </p:xfrm>
         <a:graphic>
@@ -12204,7 +12204,7 @@
                           <a:ea typeface="Poppins" pitchFamily="34" charset="-122"/>
                           <a:cs typeface="Poppins" pitchFamily="34" charset="-120"/>
                         </a:rPr>
-                        <a:t>file count and total size already on Quasar</a:t>
+                        <a:t>count and size already on Quasar</a:t>
                       </a:r>
                       <a:endParaRPr lang="en-US" sz="1200" dirty="0">
                         <a:latin typeface="Poppins" charset="0"/>
@@ -12342,7 +12342,7 @@
                           <a:ea typeface="Poppins" pitchFamily="34" charset="-122"/>
                           <a:cs typeface="Poppins" pitchFamily="34" charset="-120"/>
                         </a:rPr>
-                        <a:t>count and size of files waiting to be backed up</a:t>
+                        <a:t>count and size still waiting</a:t>
                       </a:r>
                       <a:endParaRPr lang="en-US" sz="1200" dirty="0">
                         <a:latin typeface="Poppins" charset="0"/>
@@ -12618,7 +12618,7 @@
                           <a:ea typeface="Poppins" pitchFamily="34" charset="-122"/>
                           <a:cs typeface="Poppins" pitchFamily="34" charset="-120"/>
                         </a:rPr>
-                        <a:t>one line each, with a summary row at the end</a:t>
+                        <a:t>one line each, plus a summary row</a:t>
                       </a:r>
                       <a:endParaRPr lang="en-US" sz="1200" dirty="0">
                         <a:latin typeface="Poppins" charset="0"/>
@@ -12682,12 +12682,12 @@
         </p:nvSpPr>
         <p:spPr>
           <a:xfrm>
-            <a:off x="6537960" y="5230368"/>
-            <a:ext cx="5029200" cy="566928"/>
+            <a:off x="6537960" y="5440680"/>
+            <a:ext cx="5029200" cy="502920"/>
           </a:xfrm>
           <a:prstGeom prst="roundRect">
             <a:avLst>
-              <a:gd name="adj" fmla="val 12903"/>
+              <a:gd name="adj" fmla="val 14545"/>
             </a:avLst>
           </a:prstGeom>
           <a:solidFill>
@@ -12709,8 +12709,8 @@
         </p:nvSpPr>
         <p:spPr>
           <a:xfrm>
-            <a:off x="6720840" y="5230368"/>
-            <a:ext cx="4663440" cy="566928"/>
+            <a:off x="6720840" y="5440680"/>
+            <a:ext cx="4663440" cy="502920"/>
           </a:xfrm>
           <a:prstGeom prst="rect">
             <a:avLst/>
@@ -15249,8 +15249,8 @@
         </p:nvSpPr>
         <p:spPr>
           <a:xfrm>
-            <a:off x="0" y="2971800"/>
-            <a:ext cx="1645920" cy="274320"/>
+            <a:off x="8705850" y="2185416"/>
+            <a:ext cx="2194560" cy="274320"/>
           </a:xfrm>
           <a:prstGeom prst="rect">
             <a:avLst/>
@@ -15262,19 +15262,19 @@
           <a:bodyPr wrap="square" lIns="0" tIns="0" rIns="0" bIns="0" rtlCol="0" anchor="ctr"/>
           <a:lstStyle/>
           <a:p>
-            <a:pPr algn="ctr" indent="0" marL="0">
+            <a:pPr algn="r" indent="0" marL="0">
               <a:buNone/>
             </a:pPr>
             <a:r>
               <a:rPr lang="en-US" sz="1000" dirty="0">
                 <a:solidFill>
-                  <a:srgbClr val="97999B"/>
+                  <a:srgbClr val="42C0FF"/>
                 </a:solidFill>
                 <a:latin typeface="Courier New" pitchFamily="34" charset="0"/>
                 <a:ea typeface="Courier New" pitchFamily="34" charset="-122"/>
                 <a:cs typeface="Courier New" pitchFamily="34" charset="-120"/>
               </a:rPr>
-              <a:t>0 h</a:t>
+              <a:t>MAXRUNTIME  23 h</a:t>
             </a:r>
             <a:endParaRPr lang="en-US" sz="1000" dirty="0"/>
           </a:p>
@@ -15288,7 +15288,7 @@
         </p:nvSpPr>
         <p:spPr>
           <a:xfrm>
-            <a:off x="10077450" y="2971800"/>
+            <a:off x="822960" y="2971800"/>
             <a:ext cx="1645920" cy="274320"/>
           </a:xfrm>
           <a:prstGeom prst="rect">
@@ -15301,7 +15301,7 @@
           <a:bodyPr wrap="square" lIns="0" tIns="0" rIns="0" bIns="0" rtlCol="0" anchor="ctr"/>
           <a:lstStyle/>
           <a:p>
-            <a:pPr algn="ctr" indent="0" marL="0">
+            <a:pPr algn="l" indent="0" marL="0">
               <a:buNone/>
             </a:pPr>
             <a:r>
@@ -15313,7 +15313,7 @@
                 <a:ea typeface="Courier New" pitchFamily="34" charset="-122"/>
                 <a:cs typeface="Courier New" pitchFamily="34" charset="-120"/>
               </a:rPr>
-              <a:t>23 h  MAXRUNTIME</a:t>
+              <a:t>0 h</a:t>
             </a:r>
             <a:endParaRPr lang="en-US" sz="1000" dirty="0"/>
           </a:p>
@@ -15327,8 +15327,8 @@
         </p:nvSpPr>
         <p:spPr>
           <a:xfrm>
-            <a:off x="10515600" y="2971800"/>
-            <a:ext cx="1645920" cy="274320"/>
+            <a:off x="9144000" y="2971800"/>
+            <a:ext cx="2194560" cy="274320"/>
           </a:xfrm>
           <a:prstGeom prst="rect">
             <a:avLst/>
@@ -15340,7 +15340,7 @@
           <a:bodyPr wrap="square" lIns="0" tIns="0" rIns="0" bIns="0" rtlCol="0" anchor="ctr"/>
           <a:lstStyle/>
           <a:p>
-            <a:pPr algn="ctr" indent="0" marL="0">
+            <a:pPr algn="r" indent="0" marL="0">
               <a:buNone/>
             </a:pPr>
             <a:r>
@@ -15352,7 +15352,7 @@
                 <a:ea typeface="Courier New" pitchFamily="34" charset="-122"/>
                 <a:cs typeface="Courier New" pitchFamily="34" charset="-120"/>
               </a:rPr>
-              <a:t>24 h  walltime</a:t>
+              <a:t>24 h  PBS walltime</a:t>
             </a:r>
             <a:endParaRPr lang="en-US" sz="1000" dirty="0"/>
           </a:p>
@@ -17443,7 +17443,7 @@
         </p:nvSpPr>
         <p:spPr>
           <a:xfrm>
-            <a:off x="457200" y="1508760"/>
+            <a:off x="457200" y="1481328"/>
             <a:ext cx="4846320" cy="1737360"/>
           </a:xfrm>
           <a:prstGeom prst="rect">
@@ -17458,12 +17458,12 @@
           <a:p>
             <a:pPr indent="0" marL="0">
               <a:lnSpc>
-                <a:spcPct val="115000"/>
+                <a:spcPct val="112000"/>
               </a:lnSpc>
               <a:buNone/>
             </a:pPr>
             <a:r>
-              <a:rPr lang="en-US" sz="1600" b="1" dirty="0">
+              <a:rPr lang="en-US" sz="1500" b="1" dirty="0">
                 <a:solidFill>
                   <a:srgbClr val="0057C2"/>
                 </a:solidFill>
@@ -17475,12 +17475,12 @@
             </a:r>
             <a:pPr indent="0" marL="0">
               <a:lnSpc>
-                <a:spcPct val="115000"/>
+                <a:spcPct val="112000"/>
               </a:lnSpc>
               <a:buNone/>
             </a:pPr>
             <a:r>
-              <a:rPr lang="en-US" sz="1600" dirty="0">
+              <a:rPr lang="en-US" sz="1500" dirty="0">
                 <a:solidFill>
                   <a:srgbClr val="00357A"/>
                 </a:solidFill>
@@ -17492,12 +17492,12 @@
             </a:r>
             <a:pPr indent="0" marL="0">
               <a:lnSpc>
-                <a:spcPct val="115000"/>
+                <a:spcPct val="112000"/>
               </a:lnSpc>
               <a:buNone/>
             </a:pPr>
             <a:r>
-              <a:rPr lang="en-US" sz="1600" b="1" dirty="0">
+              <a:rPr lang="en-US" sz="1500" b="1" dirty="0">
                 <a:solidFill>
                   <a:srgbClr val="00357A"/>
                 </a:solidFill>
@@ -17509,12 +17509,12 @@
             </a:r>
             <a:pPr indent="0" marL="0">
               <a:lnSpc>
-                <a:spcPct val="115000"/>
+                <a:spcPct val="112000"/>
               </a:lnSpc>
               <a:buNone/>
             </a:pPr>
             <a:r>
-              <a:rPr lang="en-US" sz="1600" dirty="0">
+              <a:rPr lang="en-US" sz="1500" dirty="0">
                 <a:solidFill>
                   <a:srgbClr val="00357A"/>
                 </a:solidFill>
@@ -17522,16 +17522,16 @@
                 <a:ea typeface="Poppins" pitchFamily="34" charset="-122"/>
                 <a:cs typeface="Poppins" pitchFamily="34" charset="-120"/>
               </a:rPr>
-              <a:t>. It finds Web and Saved files that have never been backed up, groups them into large tar files built by </a:t>
+              <a:t>. It finds files never backed up, bundles them into large tar files with </a:t>
             </a:r>
             <a:pPr indent="0" marL="0">
               <a:lnSpc>
-                <a:spcPct val="115000"/>
+                <a:spcPct val="112000"/>
               </a:lnSpc>
               <a:buNone/>
             </a:pPr>
             <a:r>
-              <a:rPr lang="en-US" sz="1600" b="1" dirty="0">
+              <a:rPr lang="en-US" sz="1500" b="1" dirty="0">
                 <a:solidFill>
                   <a:srgbClr val="0057C2"/>
                 </a:solidFill>
@@ -17543,12 +17543,12 @@
             </a:r>
             <a:pPr indent="0" marL="0">
               <a:lnSpc>
-                <a:spcPct val="115000"/>
+                <a:spcPct val="112000"/>
               </a:lnSpc>
               <a:buNone/>
             </a:pPr>
             <a:r>
-              <a:rPr lang="en-US" sz="1600" dirty="0">
+              <a:rPr lang="en-US" sz="1500" dirty="0">
                 <a:solidFill>
                   <a:srgbClr val="00357A"/>
                 </a:solidFill>
@@ -17556,16 +17556,16 @@
                 <a:ea typeface="Poppins" pitchFamily="34" charset="-122"/>
                 <a:cs typeface="Poppins" pitchFamily="34" charset="-120"/>
               </a:rPr>
-              <a:t>, then uploads many of those tars at once to the NCAR Quasar Globus end points with </a:t>
+              <a:t>, then uploads many tars at once to the Quasar end points with </a:t>
             </a:r>
             <a:pPr indent="0" marL="0">
               <a:lnSpc>
-                <a:spcPct val="115000"/>
+                <a:spcPct val="112000"/>
               </a:lnSpc>
               <a:buNone/>
             </a:pPr>
             <a:r>
-              <a:rPr lang="en-US" sz="1600" b="1" dirty="0">
+              <a:rPr lang="en-US" sz="1500" b="1" dirty="0">
                 <a:solidFill>
                   <a:srgbClr val="0057C2"/>
                 </a:solidFill>
@@ -17577,12 +17577,12 @@
             </a:r>
             <a:pPr indent="0" marL="0">
               <a:lnSpc>
-                <a:spcPct val="115000"/>
+                <a:spcPct val="112000"/>
               </a:lnSpc>
               <a:buNone/>
             </a:pPr>
             <a:r>
-              <a:rPr lang="en-US" sz="1600" dirty="0">
+              <a:rPr lang="en-US" sz="1500" dirty="0">
                 <a:solidFill>
                   <a:srgbClr val="00357A"/>
                 </a:solidFill>
@@ -17592,7 +17592,7 @@
               </a:rPr>
               <a:t>.</a:t>
             </a:r>
-            <a:endParaRPr lang="en-US" sz="1600" dirty="0"/>
+            <a:endParaRPr lang="en-US" sz="1500" dirty="0"/>
           </a:p>
         </p:txBody>
       </p:sp>
@@ -17670,7 +17670,7 @@
         </p:nvSpPr>
         <p:spPr>
           <a:xfrm>
-            <a:off x="685800" y="3931920"/>
+            <a:off x="685800" y="3913632"/>
             <a:ext cx="4434840" cy="2011680"/>
           </a:xfrm>
           <a:prstGeom prst="rect">
@@ -17685,12 +17685,12 @@
           <a:p>
             <a:pPr indent="0" marL="0">
               <a:lnSpc>
-                <a:spcPct val="112000"/>
+                <a:spcPct val="110000"/>
               </a:lnSpc>
               <a:buNone/>
             </a:pPr>
             <a:r>
-              <a:rPr lang="en-US" sz="1300" dirty="0">
+              <a:rPr lang="en-US" sz="1200" dirty="0">
                 <a:solidFill>
                   <a:srgbClr val="00357A"/>
                 </a:solidFill>
@@ -17702,12 +17702,12 @@
             </a:r>
             <a:pPr indent="0" marL="0">
               <a:lnSpc>
-                <a:spcPct val="112000"/>
+                <a:spcPct val="110000"/>
               </a:lnSpc>
               <a:buNone/>
             </a:pPr>
             <a:r>
-              <a:rPr lang="en-US" sz="1300" b="1" dirty="0">
+              <a:rPr lang="en-US" sz="1200" b="1" dirty="0">
                 <a:solidFill>
                   <a:srgbClr val="0057C2"/>
                 </a:solidFill>
@@ -17719,12 +17719,12 @@
             </a:r>
             <a:pPr indent="0" marL="0">
               <a:lnSpc>
-                <a:spcPct val="112000"/>
+                <a:spcPct val="110000"/>
               </a:lnSpc>
               <a:buNone/>
             </a:pPr>
             <a:r>
-              <a:rPr lang="en-US" sz="1300" dirty="0">
+              <a:rPr lang="en-US" sz="1200" dirty="0">
                 <a:solidFill>
                   <a:srgbClr val="00357A"/>
                 </a:solidFill>
@@ -17736,12 +17736,12 @@
             </a:r>
             <a:pPr indent="0" marL="0">
               <a:lnSpc>
-                <a:spcPct val="112000"/>
+                <a:spcPct val="110000"/>
               </a:lnSpc>
               <a:buNone/>
             </a:pPr>
             <a:r>
-              <a:rPr lang="en-US" sz="1300" b="1" dirty="0">
+              <a:rPr lang="en-US" sz="1200" b="1" dirty="0">
                 <a:solidFill>
                   <a:srgbClr val="0057C2"/>
                 </a:solidFill>
@@ -17753,12 +17753,12 @@
             </a:r>
             <a:pPr indent="0" marL="0">
               <a:lnSpc>
-                <a:spcPct val="112000"/>
+                <a:spcPct val="110000"/>
               </a:lnSpc>
               <a:buNone/>
             </a:pPr>
             <a:r>
-              <a:rPr lang="en-US" sz="1300" dirty="0">
+              <a:rPr lang="en-US" sz="1200" dirty="0">
                 <a:solidFill>
                   <a:srgbClr val="00357A"/>
                 </a:solidFill>
@@ -17770,21 +17770,21 @@
             </a:r>
             <a:pPr indent="0" marL="0">
               <a:lnSpc>
-                <a:spcPct val="112000"/>
+                <a:spcPct val="110000"/>
               </a:lnSpc>
               <a:buNone/>
             </a:pPr>
-            <a:endParaRPr lang="en-US" sz="1300" dirty="0"/>
+            <a:endParaRPr lang="en-US" sz="1200" dirty="0"/>
           </a:p>
           <a:p>
             <a:pPr indent="0" marL="0">
               <a:lnSpc>
-                <a:spcPct val="112000"/>
+                <a:spcPct val="110000"/>
               </a:lnSpc>
               <a:buNone/>
             </a:pPr>
             <a:r>
-              <a:rPr lang="en-US" sz="1300" dirty="0">
+              <a:rPr lang="en-US" sz="1200" dirty="0">
                 <a:solidFill>
                   <a:srgbClr val="00357A"/>
                 </a:solidFill>
@@ -17794,17 +17794,17 @@
               </a:rPr>
               <a:t>Any file with </a:t>
             </a:r>
-            <a:endParaRPr lang="en-US" sz="1300" dirty="0"/>
+            <a:endParaRPr lang="en-US" sz="1200" dirty="0"/>
           </a:p>
           <a:p>
             <a:pPr indent="0" marL="0">
               <a:lnSpc>
-                <a:spcPct val="112000"/>
+                <a:spcPct val="110000"/>
               </a:lnSpc>
               <a:buNone/>
             </a:pPr>
             <a:r>
-              <a:rPr lang="en-US" sz="1300" b="1" dirty="0">
+              <a:rPr lang="en-US" sz="1200" b="1" dirty="0">
                 <a:solidFill>
                   <a:srgbClr val="0057C2"/>
                 </a:solidFill>
@@ -17816,12 +17816,12 @@
             </a:r>
             <a:pPr indent="0" marL="0">
               <a:lnSpc>
-                <a:spcPct val="112000"/>
+                <a:spcPct val="110000"/>
               </a:lnSpc>
               <a:buNone/>
             </a:pPr>
             <a:r>
-              <a:rPr lang="en-US" sz="1300" dirty="0">
+              <a:rPr lang="en-US" sz="1200" dirty="0">
                 <a:solidFill>
                   <a:srgbClr val="00357A"/>
                 </a:solidFill>
@@ -17829,25 +17829,25 @@
                 <a:ea typeface="Poppins" pitchFamily="34" charset="-122"/>
                 <a:cs typeface="Poppins" pitchFamily="34" charset="-120"/>
               </a:rPr>
-              <a:t> is not backed up yet and is picked up automatically.</a:t>
+              <a:t> is not backed up yet, and is picked up automatically.</a:t>
             </a:r>
             <a:pPr indent="0" marL="0">
               <a:lnSpc>
-                <a:spcPct val="112000"/>
+                <a:spcPct val="110000"/>
               </a:lnSpc>
               <a:buNone/>
             </a:pPr>
-            <a:endParaRPr lang="en-US" sz="1300" dirty="0"/>
+            <a:endParaRPr lang="en-US" sz="1200" dirty="0"/>
           </a:p>
           <a:p>
             <a:pPr indent="0" marL="0">
               <a:lnSpc>
-                <a:spcPct val="112000"/>
+                <a:spcPct val="110000"/>
               </a:lnSpc>
               <a:buNone/>
             </a:pPr>
             <a:r>
-              <a:rPr lang="en-US" sz="1300" dirty="0">
+              <a:rPr lang="en-US" sz="1200" dirty="0">
                 <a:solidFill>
                   <a:srgbClr val="00357A"/>
                 </a:solidFill>
@@ -17855,19 +17855,19 @@
                 <a:ea typeface="Poppins" pitchFamily="34" charset="-122"/>
                 <a:cs typeface="Poppins" pitchFamily="34" charset="-120"/>
               </a:rPr>
-              <a:t>Every tar file gets a </a:t>
-            </a:r>
-            <a:endParaRPr lang="en-US" sz="1300" dirty="0"/>
+              <a:t>Every tar gets a </a:t>
+            </a:r>
+            <a:endParaRPr lang="en-US" sz="1200" dirty="0"/>
           </a:p>
           <a:p>
             <a:pPr indent="0" marL="0">
               <a:lnSpc>
-                <a:spcPct val="112000"/>
+                <a:spcPct val="110000"/>
               </a:lnSpc>
               <a:buNone/>
             </a:pPr>
             <a:r>
-              <a:rPr lang="en-US" sz="1300" b="1" dirty="0">
+              <a:rPr lang="en-US" sz="1200" b="1" dirty="0">
                 <a:solidFill>
                   <a:srgbClr val="0057C2"/>
                 </a:solidFill>
@@ -17879,12 +17879,12 @@
             </a:r>
             <a:pPr indent="0" marL="0">
               <a:lnSpc>
-                <a:spcPct val="112000"/>
+                <a:spcPct val="110000"/>
               </a:lnSpc>
               <a:buNone/>
             </a:pPr>
             <a:r>
-              <a:rPr lang="en-US" sz="1300" dirty="0">
+              <a:rPr lang="en-US" sz="1200" dirty="0">
                 <a:solidFill>
                   <a:srgbClr val="00357A"/>
                 </a:solidFill>
@@ -17896,21 +17896,21 @@
             </a:r>
             <a:pPr indent="0" marL="0">
               <a:lnSpc>
-                <a:spcPct val="112000"/>
+                <a:spcPct val="110000"/>
               </a:lnSpc>
               <a:buNone/>
             </a:pPr>
-            <a:endParaRPr lang="en-US" sz="1300" dirty="0"/>
+            <a:endParaRPr lang="en-US" sz="1200" dirty="0"/>
           </a:p>
           <a:p>
             <a:pPr indent="0" marL="0">
               <a:lnSpc>
-                <a:spcPct val="112000"/>
+                <a:spcPct val="110000"/>
               </a:lnSpc>
               <a:buNone/>
             </a:pPr>
             <a:r>
-              <a:rPr lang="en-US" sz="1300" dirty="0">
+              <a:rPr lang="en-US" sz="1200" dirty="0">
                 <a:solidFill>
                   <a:srgbClr val="00357A"/>
                 </a:solidFill>
@@ -17918,9 +17918,9 @@
                 <a:ea typeface="Poppins" pitchFamily="34" charset="-122"/>
                 <a:cs typeface="Poppins" pitchFamily="34" charset="-120"/>
               </a:rPr>
-              <a:t>Work is resumable: a run that stops leaves the pending records for the next run.</a:t>
-            </a:r>
-            <a:endParaRPr lang="en-US" sz="1300" dirty="0"/>
+              <a:t>Work is resumable: a run that stops leaves its pending records behind.</a:t>
+            </a:r>
+            <a:endParaRPr lang="en-US" sz="1200" dirty="0"/>
           </a:p>
         </p:txBody>
       </p:sp>
@@ -19318,8 +19318,8 @@
         </p:nvSpPr>
         <p:spPr>
           <a:xfrm>
-            <a:off x="640080" y="2926080"/>
-            <a:ext cx="2377440" cy="1371600"/>
+            <a:off x="640080" y="2907792"/>
+            <a:ext cx="2377440" cy="1417320"/>
           </a:xfrm>
           <a:prstGeom prst="rect">
             <a:avLst/>
@@ -19333,12 +19333,12 @@
           <a:p>
             <a:pPr indent="0" marL="0">
               <a:lnSpc>
-                <a:spcPct val="108000"/>
+                <a:spcPct val="105000"/>
               </a:lnSpc>
               <a:buNone/>
             </a:pPr>
             <a:r>
-              <a:rPr lang="en-US" sz="1100" dirty="0">
+              <a:rPr lang="en-US" sz="1050" dirty="0">
                 <a:solidFill>
                   <a:srgbClr val="53565A"/>
                 </a:solidFill>
@@ -19348,7 +19348,7 @@
               </a:rPr>
               <a:t>The dataset is locked before its files are gathered or its tars are built, and unlocked as soon as that dataset is finished.</a:t>
             </a:r>
-            <a:endParaRPr lang="en-US" sz="1100" dirty="0"/>
+            <a:endParaRPr lang="en-US" sz="1050" dirty="0"/>
           </a:p>
         </p:txBody>
       </p:sp>
@@ -19448,8 +19448,8 @@
         </p:nvSpPr>
         <p:spPr>
           <a:xfrm>
-            <a:off x="3483864" y="2926080"/>
-            <a:ext cx="2377440" cy="1371600"/>
+            <a:off x="3483864" y="2907792"/>
+            <a:ext cx="2377440" cy="1417320"/>
           </a:xfrm>
           <a:prstGeom prst="rect">
             <a:avLst/>
@@ -19463,12 +19463,12 @@
           <a:p>
             <a:pPr indent="0" marL="0">
               <a:lnSpc>
-                <a:spcPct val="108000"/>
+                <a:spcPct val="105000"/>
               </a:lnSpc>
               <a:buNone/>
             </a:pPr>
             <a:r>
-              <a:rPr lang="en-US" sz="1100" dirty="0">
+              <a:rPr lang="en-US" sz="1050" dirty="0">
                 <a:solidFill>
                   <a:srgbClr val="53565A"/>
                 </a:solidFill>
@@ -19478,7 +19478,7 @@
               </a:rPr>
               <a:t>Work is listed before the lock is held, so the list can be hours old. Each candidate is re-read under the lock — still status 'N'? — before a tar is spent on it.</a:t>
             </a:r>
-            <a:endParaRPr lang="en-US" sz="1100" dirty="0"/>
+            <a:endParaRPr lang="en-US" sz="1050" dirty="0"/>
           </a:p>
         </p:txBody>
       </p:sp>
@@ -19578,8 +19578,8 @@
         </p:nvSpPr>
         <p:spPr>
           <a:xfrm>
-            <a:off x="6327648" y="2926080"/>
-            <a:ext cx="2377440" cy="1371600"/>
+            <a:off x="6327648" y="2907792"/>
+            <a:ext cx="2377440" cy="1417320"/>
           </a:xfrm>
           <a:prstGeom prst="rect">
             <a:avLst/>
@@ -19593,12 +19593,12 @@
           <a:p>
             <a:pPr indent="0" marL="0">
               <a:lnSpc>
-                <a:spcPct val="108000"/>
+                <a:spcPct val="105000"/>
               </a:lnSpc>
               <a:buNone/>
             </a:pPr>
             <a:r>
-              <a:rPr lang="en-US" sz="1100" dirty="0">
+              <a:rPr lang="en-US" sz="1050" dirty="0">
                 <a:solidFill>
                   <a:srgbClr val="53565A"/>
                 </a:solidFill>
@@ -19606,9 +19606,9 @@
                 <a:ea typeface="Poppins" pitchFamily="34" charset="-122"/>
                 <a:cs typeface="Poppins" pitchFamily="34" charset="-120"/>
               </a:rPr>
-              <a:t>One tar file may hold files from many datasets. All of them are locked before tarring and released once the tar is dispatched; if any is held elsewhere, the tar waits for a later run.</a:t>
-            </a:r>
-            <a:endParaRPr lang="en-US" sz="1100" dirty="0"/>
+              <a:t>One tar may hold files from many datasets. All are locked before tarring and released once it is dispatched; if any is held elsewhere, the tar waits.</a:t>
+            </a:r>
+            <a:endParaRPr lang="en-US" sz="1050" dirty="0"/>
           </a:p>
         </p:txBody>
       </p:sp>
@@ -19708,8 +19708,8 @@
         </p:nvSpPr>
         <p:spPr>
           <a:xfrm>
-            <a:off x="9171432" y="2926080"/>
-            <a:ext cx="2377440" cy="1371600"/>
+            <a:off x="9171432" y="2907792"/>
+            <a:ext cx="2377440" cy="1417320"/>
           </a:xfrm>
           <a:prstGeom prst="rect">
             <a:avLst/>
@@ -19723,12 +19723,12 @@
           <a:p>
             <a:pPr indent="0" marL="0">
               <a:lnSpc>
-                <a:spcPct val="108000"/>
+                <a:spcPct val="105000"/>
               </a:lnSpc>
               <a:buNone/>
             </a:pPr>
             <a:r>
-              <a:rPr lang="en-US" sz="1100" dirty="0">
+              <a:rPr lang="en-US" sz="1050" dirty="0">
                 <a:solidFill>
                   <a:srgbClr val="53565A"/>
                 </a:solidFill>
@@ -19736,9 +19736,9 @@
                 <a:ea typeface="Poppins" pitchFamily="34" charset="-122"/>
                 <a:cs typeface="Poppins" pitchFamily="34" charset="-120"/>
               </a:rPr>
-              <a:t>The predicted bid is only a guess. The insert uses AUTOID and the tar is renamed if the database hands back a different id.</a:t>
-            </a:r>
-            <a:endParaRPr lang="en-US" sz="1100" dirty="0"/>
+              <a:t>The predicted bid is only a guess. The insert uses AUTOID and the tar is renamed if the database returns a different id.</a:t>
+            </a:r>
+            <a:endParaRPr lang="en-US" sz="1050" dirty="0"/>
           </a:p>
         </p:txBody>
       </p:sp>
@@ -26315,8 +26315,8 @@
         </p:nvSpPr>
         <p:spPr>
           <a:xfrm>
-            <a:off x="457200" y="6016752"/>
-            <a:ext cx="11292840" cy="274320"/>
+            <a:off x="457200" y="5961888"/>
+            <a:ext cx="11292840" cy="292608"/>
           </a:xfrm>
           <a:prstGeom prst="rect">
             <a:avLst/>
@@ -26340,7 +26340,7 @@
                 <a:ea typeface="Poppins" pitchFamily="34" charset="-122"/>
                 <a:cs typeface="Poppins" pitchFamily="34" charset="-120"/>
               </a:rPr>
-              <a:t>All three are installed by the rda_python_dsquasar package and share the rda_python_common configuration.   Backup flags are edited at </a:t>
+              <a:t>All three ship with rda_python_dsquasar.   Backup flags are edited at </a:t>
             </a:r>
             <a:pPr indent="0" marL="0">
               <a:buNone/>
@@ -26712,7 +26712,7 @@
                 <a:ea typeface="Poppins" pitchFamily="34" charset="-122"/>
                 <a:cs typeface="Poppins" pitchFamily="34" charset="-120"/>
               </a:rPr>
-              <a:t>The dataset or group backflag is not set, or the group flag is 'N'. Confirm with  dsquasar -t &lt;dsid&gt; -n  before digging further.</a:t>
+              <a:t>The dataset or group backflag is not set. Check with  dsquasar -t &lt;dsid&gt; -n  first.</a:t>
             </a:r>
             <a:endParaRPr lang="en-US" sz="1100" dirty="0"/>
           </a:p>
@@ -26837,7 +26837,7 @@
                 <a:ea typeface="Poppins" pitchFamily="34" charset="-122"/>
                 <a:cs typeface="Poppins" pitchFamily="34" charset="-120"/>
               </a:rPr>
-              <a:t>That is the duplicate check working — an identical command is already queued or running. Check the dscheck record before forcing anything.</a:t>
+              <a:t>The duplicate check working: an identical command is already queued or running.</a:t>
             </a:r>
             <a:endParaRPr lang="en-US" sz="1100" dirty="0"/>
           </a:p>
@@ -26962,7 +26962,7 @@
                 <a:ea typeface="Poppins" pitchFamily="34" charset="-122"/>
                 <a:cs typeface="Poppins" pitchFamily="34" charset="-120"/>
               </a:rPr>
-              <a:t>Tarring never reached them: the run hit the 23-hour guard, or the dataset was locked by another worker. Both resolve on the next run.</a:t>
+              <a:t>Tarring never reached them — the 23-hour guard, or the dataset was locked. Resolves next run.</a:t>
             </a:r>
             <a:endParaRPr lang="en-US" sz="1100" dirty="0"/>
           </a:p>
@@ -27087,7 +27087,7 @@
                 <a:ea typeface="Poppins" pitchFamily="34" charset="-122"/>
                 <a:cs typeface="Poppins" pitchFamily="34" charset="-120"/>
               </a:rPr>
-              <a:t>The tar was built but not transferred. Run  -A 4  for that dataset. If the local tar is gone, the record is reset to 'N' and rebuilt.</a:t>
+              <a:t>Built but not transferred. Run  -A 4 . If the local tar is gone the record resets to 'N'.</a:t>
             </a:r>
             <a:endParaRPr lang="en-US" sz="1100" dirty="0"/>
           </a:p>
@@ -27212,7 +27212,7 @@
                 <a:ea typeface="Poppins" pitchFamily="34" charset="-122"/>
                 <a:cs typeface="Poppins" pitchFamily="34" charset="-120"/>
               </a:rPr>
-              <a:t>Run  -A 8  — mismatched records are reset to 'N' and redone from the archive on the next gather.</a:t>
+              <a:t>Run  -A 8  — mismatched records reset to 'N' and are redone from the archive.</a:t>
             </a:r>
             <a:endParaRPr lang="en-US" sz="1100" dirty="0"/>
           </a:p>
@@ -27337,7 +27337,7 @@
                 <a:ea typeface="Poppins" pitchFamily="34" charset="-122"/>
                 <a:cs typeface="Poppins" pitchFamily="34" charset="-120"/>
               </a:rPr>
-              <a:t>Locks held by a dead process are taken over automatically. To clear them now:  dsquasar -t &lt;dsid&gt; -u</a:t>
+              <a:t>Dead-process locks are taken over automatically. To clear now:  dsquasar -t &lt;dsid&gt; -u</a:t>
             </a:r>
             <a:endParaRPr lang="en-US" sz="1100" dirty="0"/>
           </a:p>
@@ -27961,7 +27961,7 @@
         <p:spPr>
           <a:xfrm>
             <a:off x="6537960" y="2542032"/>
-            <a:ext cx="5029200" cy="548640"/>
+            <a:ext cx="5029200" cy="502920"/>
           </a:xfrm>
           <a:prstGeom prst="rect">
             <a:avLst/>
@@ -27980,7 +27980,7 @@
               <a:buNone/>
             </a:pPr>
             <a:r>
-              <a:rPr lang="en-US" sz="1150" dirty="0">
+              <a:rPr lang="en-US" sz="1100" dirty="0">
                 <a:solidFill>
                   <a:srgbClr val="53565A"/>
                 </a:solidFill>
@@ -27988,9 +27988,9 @@
                 <a:ea typeface="Poppins" pitchFamily="34" charset="-122"/>
                 <a:cs typeface="Poppins" pitchFamily="34" charset="-120"/>
               </a:rPr>
-              <a:t>Every tar goes to both end points by default. Drdata is written first, so a run interrupted midway still leaves the disaster-recovery copy complete.</a:t>
-            </a:r>
-            <a:endParaRPr lang="en-US" sz="1150" dirty="0"/>
+              <a:t>Every tar goes to both end points by default. Drdata is written first, so an interrupted run still leaves the DR copy complete.</a:t>
+            </a:r>
+            <a:endParaRPr lang="en-US" sz="1100" dirty="0"/>
           </a:p>
         </p:txBody>
       </p:sp>
@@ -28009,7 +28009,7 @@
           </p:nvPr>
         </p:nvGraphicFramePr>
         <p:xfrm>
-          <a:off x="6537960" y="3154680"/>
+          <a:off x="6537960" y="3127248"/>
           <a:ext cx="5029200" cy="914400"/>
         </p:xfrm>
         <a:graphic>
@@ -30098,7 +30098,7 @@
               <a:buNone/>
             </a:pPr>
             <a:r>
-              <a:rPr lang="en-US" sz="1400" dirty="0">
+              <a:rPr lang="en-US" sz="1400" b="1" dirty="0">
                 <a:solidFill>
                   <a:srgbClr val="42C0FF"/>
                 </a:solidFill>
@@ -30106,7 +30106,21 @@
                 <a:ea typeface="Courier New" pitchFamily="34" charset="-122"/>
                 <a:cs typeface="Courier New" pitchFamily="34" charset="-120"/>
               </a:rPr>
-              <a:t>dsquasar -h        for the full help document</a:t>
+              <a:t>dsquasar -h</a:t>
+            </a:r>
+            <a:pPr indent="0" marL="0">
+              <a:buNone/>
+            </a:pPr>
+            <a:r>
+              <a:rPr lang="en-US" sz="1400" dirty="0">
+                <a:solidFill>
+                  <a:srgbClr val="42C0FF"/>
+                </a:solidFill>
+                <a:latin typeface="Poppins" pitchFamily="34" charset="0"/>
+                <a:ea typeface="Poppins" pitchFamily="34" charset="-122"/>
+                <a:cs typeface="Poppins" pitchFamily="34" charset="-120"/>
+              </a:rPr>
+              <a:t>   •   for the full help document</a:t>
             </a:r>
             <a:endParaRPr lang="en-US" sz="1400" dirty="0"/>
           </a:p>
@@ -35456,11 +35470,11 @@
         <p:spPr>
           <a:xfrm>
             <a:off x="457200" y="1554480"/>
-            <a:ext cx="5532120" cy="1463040"/>
+            <a:ext cx="5532120" cy="1371600"/>
           </a:xfrm>
           <a:prstGeom prst="roundRect">
             <a:avLst>
-              <a:gd name="adj" fmla="val 5000"/>
+              <a:gd name="adj" fmla="val 5333"/>
             </a:avLst>
           </a:prstGeom>
           <a:solidFill>
@@ -35629,7 +35643,7 @@
         </p:nvSpPr>
         <p:spPr>
           <a:xfrm>
-            <a:off x="658368" y="2487168"/>
+            <a:off x="658368" y="2395728"/>
             <a:ext cx="5129784" cy="420624"/>
           </a:xfrm>
           <a:prstGeom prst="roundRect">
@@ -35651,7 +35665,7 @@
         </p:nvSpPr>
         <p:spPr>
           <a:xfrm>
-            <a:off x="786384" y="2487168"/>
+            <a:off x="786384" y="2395728"/>
             <a:ext cx="4873752" cy="420624"/>
           </a:xfrm>
           <a:prstGeom prst="rect">
@@ -35694,11 +35708,11 @@
         <p:spPr>
           <a:xfrm>
             <a:off x="6199632" y="1554480"/>
-            <a:ext cx="5532120" cy="1463040"/>
+            <a:ext cx="5532120" cy="1371600"/>
           </a:xfrm>
           <a:prstGeom prst="roundRect">
             <a:avLst>
-              <a:gd name="adj" fmla="val 5000"/>
+              <a:gd name="adj" fmla="val 5333"/>
             </a:avLst>
           </a:prstGeom>
           <a:solidFill>
@@ -35867,7 +35881,7 @@
         </p:nvSpPr>
         <p:spPr>
           <a:xfrm>
-            <a:off x="6400800" y="2487168"/>
+            <a:off x="6400800" y="2395728"/>
             <a:ext cx="5129784" cy="420624"/>
           </a:xfrm>
           <a:prstGeom prst="roundRect">
@@ -35889,7 +35903,7 @@
         </p:nvSpPr>
         <p:spPr>
           <a:xfrm>
-            <a:off x="6528816" y="2487168"/>
+            <a:off x="6528816" y="2395728"/>
             <a:ext cx="4873752" cy="420624"/>
           </a:xfrm>
           <a:prstGeom prst="rect">
@@ -35931,12 +35945,12 @@
         </p:nvSpPr>
         <p:spPr>
           <a:xfrm>
-            <a:off x="457200" y="3145536"/>
-            <a:ext cx="5532120" cy="1463040"/>
+            <a:off x="457200" y="3035808"/>
+            <a:ext cx="5532120" cy="1371600"/>
           </a:xfrm>
           <a:prstGeom prst="roundRect">
             <a:avLst>
-              <a:gd name="adj" fmla="val 5000"/>
+              <a:gd name="adj" fmla="val 5333"/>
             </a:avLst>
           </a:prstGeom>
           <a:solidFill>
@@ -35965,7 +35979,7 @@
         </p:nvSpPr>
         <p:spPr>
           <a:xfrm>
-            <a:off x="658368" y="3328416"/>
+            <a:off x="658368" y="3218688"/>
             <a:ext cx="457200" cy="457200"/>
           </a:xfrm>
           <a:prstGeom prst="ellipse">
@@ -35985,7 +35999,7 @@
         </p:nvSpPr>
         <p:spPr>
           <a:xfrm>
-            <a:off x="658368" y="3328416"/>
+            <a:off x="658368" y="3218688"/>
             <a:ext cx="457200" cy="457200"/>
           </a:xfrm>
           <a:prstGeom prst="rect">
@@ -36024,7 +36038,7 @@
         </p:nvSpPr>
         <p:spPr>
           <a:xfrm>
-            <a:off x="1234440" y="3291840"/>
+            <a:off x="1234440" y="3182112"/>
             <a:ext cx="4572000" cy="365760"/>
           </a:xfrm>
           <a:prstGeom prst="rect">
@@ -36063,7 +36077,7 @@
         </p:nvSpPr>
         <p:spPr>
           <a:xfrm>
-            <a:off x="1234440" y="3648456"/>
+            <a:off x="1234440" y="3538728"/>
             <a:ext cx="4572000" cy="365760"/>
           </a:xfrm>
           <a:prstGeom prst="rect">
@@ -36105,7 +36119,7 @@
         </p:nvSpPr>
         <p:spPr>
           <a:xfrm>
-            <a:off x="658368" y="4078224"/>
+            <a:off x="658368" y="3877056"/>
             <a:ext cx="5129784" cy="420624"/>
           </a:xfrm>
           <a:prstGeom prst="roundRect">
@@ -36127,7 +36141,7 @@
         </p:nvSpPr>
         <p:spPr>
           <a:xfrm>
-            <a:off x="786384" y="4078224"/>
+            <a:off x="786384" y="3877056"/>
             <a:ext cx="4873752" cy="420624"/>
           </a:xfrm>
           <a:prstGeom prst="rect">
@@ -36169,12 +36183,12 @@
         </p:nvSpPr>
         <p:spPr>
           <a:xfrm>
-            <a:off x="6199632" y="3145536"/>
-            <a:ext cx="5532120" cy="1463040"/>
+            <a:off x="6199632" y="3035808"/>
+            <a:ext cx="5532120" cy="1371600"/>
           </a:xfrm>
           <a:prstGeom prst="roundRect">
             <a:avLst>
-              <a:gd name="adj" fmla="val 5000"/>
+              <a:gd name="adj" fmla="val 5333"/>
             </a:avLst>
           </a:prstGeom>
           <a:solidFill>
@@ -36203,7 +36217,7 @@
         </p:nvSpPr>
         <p:spPr>
           <a:xfrm>
-            <a:off x="6400800" y="3328416"/>
+            <a:off x="6400800" y="3218688"/>
             <a:ext cx="457200" cy="457200"/>
           </a:xfrm>
           <a:prstGeom prst="ellipse">
@@ -36223,7 +36237,7 @@
         </p:nvSpPr>
         <p:spPr>
           <a:xfrm>
-            <a:off x="6400800" y="3328416"/>
+            <a:off x="6400800" y="3218688"/>
             <a:ext cx="457200" cy="457200"/>
           </a:xfrm>
           <a:prstGeom prst="rect">
@@ -36262,7 +36276,7 @@
         </p:nvSpPr>
         <p:spPr>
           <a:xfrm>
-            <a:off x="6976872" y="3291840"/>
+            <a:off x="6976872" y="3182112"/>
             <a:ext cx="4572000" cy="365760"/>
           </a:xfrm>
           <a:prstGeom prst="rect">
@@ -36301,7 +36315,7 @@
         </p:nvSpPr>
         <p:spPr>
           <a:xfrm>
-            <a:off x="6976872" y="3648456"/>
+            <a:off x="6976872" y="3538728"/>
             <a:ext cx="4572000" cy="365760"/>
           </a:xfrm>
           <a:prstGeom prst="rect">
@@ -36329,7 +36343,7 @@
                 <a:ea typeface="Poppins" pitchFamily="34" charset="-122"/>
                 <a:cs typeface="Poppins" pitchFamily="34" charset="-120"/>
               </a:rPr>
-              <a:t>All flagged datasets, in the background, as a PBS batch job with email.</a:t>
+              <a:t>All flagged datasets, as a PBS batch job with email.</a:t>
             </a:r>
             <a:endParaRPr lang="en-US" sz="1150" dirty="0"/>
           </a:p>
@@ -36343,7 +36357,7 @@
         </p:nvSpPr>
         <p:spPr>
           <a:xfrm>
-            <a:off x="6400800" y="4078224"/>
+            <a:off x="6400800" y="3877056"/>
             <a:ext cx="5129784" cy="420624"/>
           </a:xfrm>
           <a:prstGeom prst="roundRect">
@@ -36365,7 +36379,7 @@
         </p:nvSpPr>
         <p:spPr>
           <a:xfrm>
-            <a:off x="6528816" y="4078224"/>
+            <a:off x="6528816" y="3877056"/>
             <a:ext cx="4873752" cy="420624"/>
           </a:xfrm>
           <a:prstGeom prst="rect">
@@ -36407,12 +36421,12 @@
         </p:nvSpPr>
         <p:spPr>
           <a:xfrm>
-            <a:off x="457200" y="4736592"/>
-            <a:ext cx="5532120" cy="1463040"/>
+            <a:off x="457200" y="4517136"/>
+            <a:ext cx="5532120" cy="1371600"/>
           </a:xfrm>
           <a:prstGeom prst="roundRect">
             <a:avLst>
-              <a:gd name="adj" fmla="val 5000"/>
+              <a:gd name="adj" fmla="val 5333"/>
             </a:avLst>
           </a:prstGeom>
           <a:solidFill>
@@ -36441,7 +36455,7 @@
         </p:nvSpPr>
         <p:spPr>
           <a:xfrm>
-            <a:off x="658368" y="4919472"/>
+            <a:off x="658368" y="4700016"/>
             <a:ext cx="457200" cy="457200"/>
           </a:xfrm>
           <a:prstGeom prst="ellipse">
@@ -36461,7 +36475,7 @@
         </p:nvSpPr>
         <p:spPr>
           <a:xfrm>
-            <a:off x="658368" y="4919472"/>
+            <a:off x="658368" y="4700016"/>
             <a:ext cx="457200" cy="457200"/>
           </a:xfrm>
           <a:prstGeom prst="rect">
@@ -36500,7 +36514,7 @@
         </p:nvSpPr>
         <p:spPr>
           <a:xfrm>
-            <a:off x="1234440" y="4882896"/>
+            <a:off x="1234440" y="4663440"/>
             <a:ext cx="4572000" cy="365760"/>
           </a:xfrm>
           <a:prstGeom prst="rect">
@@ -36539,7 +36553,7 @@
         </p:nvSpPr>
         <p:spPr>
           <a:xfrm>
-            <a:off x="1234440" y="5239512"/>
+            <a:off x="1234440" y="5020056"/>
             <a:ext cx="4572000" cy="365760"/>
           </a:xfrm>
           <a:prstGeom prst="rect">
@@ -36581,7 +36595,7 @@
         </p:nvSpPr>
         <p:spPr>
           <a:xfrm>
-            <a:off x="658368" y="5669280"/>
+            <a:off x="658368" y="5358384"/>
             <a:ext cx="5129784" cy="420624"/>
           </a:xfrm>
           <a:prstGeom prst="roundRect">
@@ -36603,7 +36617,7 @@
         </p:nvSpPr>
         <p:spPr>
           <a:xfrm>
-            <a:off x="786384" y="5669280"/>
+            <a:off x="786384" y="5358384"/>
             <a:ext cx="4873752" cy="420624"/>
           </a:xfrm>
           <a:prstGeom prst="rect">
@@ -36645,12 +36659,12 @@
         </p:nvSpPr>
         <p:spPr>
           <a:xfrm>
-            <a:off x="6199632" y="4736592"/>
-            <a:ext cx="5532120" cy="1463040"/>
+            <a:off x="6199632" y="4517136"/>
+            <a:ext cx="5532120" cy="1371600"/>
           </a:xfrm>
           <a:prstGeom prst="roundRect">
             <a:avLst>
-              <a:gd name="adj" fmla="val 5000"/>
+              <a:gd name="adj" fmla="val 5333"/>
             </a:avLst>
           </a:prstGeom>
           <a:solidFill>
@@ -36679,7 +36693,7 @@
         </p:nvSpPr>
         <p:spPr>
           <a:xfrm>
-            <a:off x="6400800" y="4919472"/>
+            <a:off x="6400800" y="4700016"/>
             <a:ext cx="457200" cy="457200"/>
           </a:xfrm>
           <a:prstGeom prst="ellipse">
@@ -36699,7 +36713,7 @@
         </p:nvSpPr>
         <p:spPr>
           <a:xfrm>
-            <a:off x="6400800" y="4919472"/>
+            <a:off x="6400800" y="4700016"/>
             <a:ext cx="457200" cy="457200"/>
           </a:xfrm>
           <a:prstGeom prst="rect">
@@ -36738,7 +36752,7 @@
         </p:nvSpPr>
         <p:spPr>
           <a:xfrm>
-            <a:off x="6976872" y="4882896"/>
+            <a:off x="6976872" y="4663440"/>
             <a:ext cx="4572000" cy="365760"/>
           </a:xfrm>
           <a:prstGeom prst="rect">
@@ -36777,7 +36791,7 @@
         </p:nvSpPr>
         <p:spPr>
           <a:xfrm>
-            <a:off x="6976872" y="5239512"/>
+            <a:off x="6976872" y="5020056"/>
             <a:ext cx="4572000" cy="365760"/>
           </a:xfrm>
           <a:prstGeom prst="rect">
@@ -36819,7 +36833,7 @@
         </p:nvSpPr>
         <p:spPr>
           <a:xfrm>
-            <a:off x="6400800" y="5669280"/>
+            <a:off x="6400800" y="5358384"/>
             <a:ext cx="5129784" cy="420624"/>
           </a:xfrm>
           <a:prstGeom prst="roundRect">
@@ -36841,7 +36855,7 @@
         </p:nvSpPr>
         <p:spPr>
           <a:xfrm>
-            <a:off x="6528816" y="5669280"/>
+            <a:off x="6528816" y="5358384"/>
             <a:ext cx="4873752" cy="420624"/>
           </a:xfrm>
           <a:prstGeom prst="rect">
@@ -36883,8 +36897,8 @@
         </p:nvSpPr>
         <p:spPr>
           <a:xfrm>
-            <a:off x="457200" y="6053328"/>
-            <a:ext cx="11274552" cy="365760"/>
+            <a:off x="457200" y="5989320"/>
+            <a:ext cx="11274552" cy="320040"/>
           </a:xfrm>
           <a:prstGeom prst="rect">
             <a:avLst/>
@@ -36950,7 +36964,7 @@
                 <a:ea typeface="Poppins" pitchFamily="34" charset="-122"/>
                 <a:cs typeface="Poppins" pitchFamily="34" charset="-120"/>
               </a:rPr>
-              <a:t>, so re-running a command never re-backs up work that already succeeded.</a:t>
+              <a:t>, so re-running never redoes finished work.</a:t>
             </a:r>
             <a:endParaRPr lang="en-US" sz="1300" dirty="0"/>
           </a:p>
@@ -37176,8 +37190,8 @@
         </p:nvSpPr>
         <p:spPr>
           <a:xfrm>
-            <a:off x="457200" y="1463040"/>
-            <a:ext cx="5532120" cy="621792"/>
+            <a:off x="457200" y="1444752"/>
+            <a:ext cx="5532120" cy="548640"/>
           </a:xfrm>
           <a:prstGeom prst="rect">
             <a:avLst/>
@@ -37191,12 +37205,12 @@
           <a:p>
             <a:pPr indent="0" marL="0">
               <a:lnSpc>
-                <a:spcPct val="108000"/>
+                <a:spcPct val="106000"/>
               </a:lnSpc>
               <a:buNone/>
             </a:pPr>
             <a:r>
-              <a:rPr lang="en-US" sz="1300" dirty="0">
+              <a:rPr lang="en-US" sz="1250" dirty="0">
                 <a:solidFill>
                   <a:srgbClr val="00357A"/>
                 </a:solidFill>
@@ -37208,12 +37222,12 @@
             </a:r>
             <a:pPr indent="0" marL="0">
               <a:lnSpc>
-                <a:spcPct val="108000"/>
+                <a:spcPct val="106000"/>
               </a:lnSpc>
               <a:buNone/>
             </a:pPr>
             <a:r>
-              <a:rPr lang="en-US" sz="1300" b="1" dirty="0">
+              <a:rPr lang="en-US" sz="1250" b="1" dirty="0">
                 <a:solidFill>
                   <a:srgbClr val="0057C2"/>
                 </a:solidFill>
@@ -37225,12 +37239,12 @@
             </a:r>
             <a:pPr indent="0" marL="0">
               <a:lnSpc>
-                <a:spcPct val="108000"/>
+                <a:spcPct val="106000"/>
               </a:lnSpc>
               <a:buNone/>
             </a:pPr>
             <a:r>
-              <a:rPr lang="en-US" sz="1300" dirty="0">
+              <a:rPr lang="en-US" sz="1250" dirty="0">
                 <a:solidFill>
                   <a:srgbClr val="00357A"/>
                 </a:solidFill>
@@ -37238,9 +37252,9 @@
                 <a:ea typeface="Poppins" pitchFamily="34" charset="-122"/>
                 <a:cs typeface="Poppins" pitchFamily="34" charset="-120"/>
               </a:rPr>
-              <a:t>. That one field is the switch — dsquasar reads it for every dataset it visits, and nothing else enrolls a dataset.</a:t>
-            </a:r>
-            <a:endParaRPr lang="en-US" sz="1300" dirty="0"/>
+              <a:t> — that one field is the switch, nothing else enrolls a dataset.</a:t>
+            </a:r>
+            <a:endParaRPr lang="en-US" sz="1250" dirty="0"/>
           </a:p>
         </p:txBody>
       </p:sp>
@@ -37259,7 +37273,7 @@
           </p:nvPr>
         </p:nvGraphicFramePr>
         <p:xfrm>
-          <a:off x="457200" y="2121408"/>
+          <a:off x="457200" y="2057400"/>
           <a:ext cx="5532120" cy="914400"/>
         </p:xfrm>
         <a:graphic>
@@ -37972,8 +37986,8 @@
         </p:nvSpPr>
         <p:spPr>
           <a:xfrm>
-            <a:off x="457200" y="4023360"/>
-            <a:ext cx="5532120" cy="777240"/>
+            <a:off x="457200" y="3950208"/>
+            <a:ext cx="5532120" cy="731520"/>
           </a:xfrm>
           <a:prstGeom prst="rect">
             <a:avLst/>
@@ -38133,12 +38147,12 @@
         </p:nvSpPr>
         <p:spPr>
           <a:xfrm>
-            <a:off x="457200" y="4846320"/>
-            <a:ext cx="5532120" cy="713232"/>
+            <a:off x="457200" y="4754880"/>
+            <a:ext cx="5532120" cy="1298448"/>
           </a:xfrm>
           <a:prstGeom prst="roundRect">
             <a:avLst>
-              <a:gd name="adj" fmla="val 11538"/>
+              <a:gd name="adj" fmla="val 6338"/>
             </a:avLst>
           </a:prstGeom>
           <a:solidFill>
@@ -38160,8 +38174,8 @@
         </p:nvSpPr>
         <p:spPr>
           <a:xfrm>
-            <a:off x="658368" y="4846320"/>
-            <a:ext cx="5120640" cy="713232"/>
+            <a:off x="658368" y="4754880"/>
+            <a:ext cx="5120640" cy="1298448"/>
           </a:xfrm>
           <a:prstGeom prst="rect">
             <a:avLst/>
@@ -38175,7 +38189,7 @@
           <a:p>
             <a:pPr indent="0" marL="0">
               <a:lnSpc>
-                <a:spcPct val="105000"/>
+                <a:spcPct val="115000"/>
               </a:lnSpc>
               <a:buNone/>
             </a:pPr>
@@ -38188,11 +38202,29 @@
                 <a:ea typeface="Poppins" pitchFamily="34" charset="-122"/>
                 <a:cs typeface="Poppins" pitchFamily="34" charset="-120"/>
               </a:rPr>
-              <a:t>Set it in the web config tool:  </a:t>
+              <a:t>Set the flag in the web config tool</a:t>
             </a:r>
             <a:pPr indent="0" marL="0">
               <a:lnSpc>
-                <a:spcPct val="105000"/>
+                <a:spcPct val="115000"/>
+              </a:lnSpc>
+              <a:buNone/>
+            </a:pPr>
+            <a:r>
+              <a:rPr lang="en-US" sz="1100" dirty="0">
+                <a:solidFill>
+                  <a:srgbClr val="00357A"/>
+                </a:solidFill>
+                <a:latin typeface="Poppins" pitchFamily="34" charset="0"/>
+                <a:ea typeface="Poppins" pitchFamily="34" charset="-122"/>
+                <a:cs typeface="Poppins" pitchFamily="34" charset="-120"/>
+              </a:rPr>
+              <a:t>
+</a:t>
+            </a:r>
+            <a:pPr indent="0" marL="0">
+              <a:lnSpc>
+                <a:spcPct val="115000"/>
               </a:lnSpc>
               <a:buNone/>
             </a:pPr>
@@ -38216,138 +38248,75 @@
             </a:r>
             <a:pPr indent="0" marL="0">
               <a:lnSpc>
-                <a:spcPct val="105000"/>
+                <a:spcPct val="115000"/>
               </a:lnSpc>
               <a:buNone/>
             </a:pPr>
+            <a:r>
+              <a:rPr lang="en-US" sz="1100" dirty="0">
+                <a:solidFill>
+                  <a:srgbClr val="00357A"/>
+                </a:solidFill>
+                <a:latin typeface="Poppins" pitchFamily="34" charset="0"/>
+                <a:ea typeface="Poppins" pitchFamily="34" charset="-122"/>
+                <a:cs typeface="Poppins" pitchFamily="34" charset="-120"/>
+              </a:rPr>
+              <a:t>   under   </a:t>
+            </a:r>
+            <a:pPr indent="0" marL="0">
+              <a:lnSpc>
+                <a:spcPct val="115000"/>
+              </a:lnSpc>
+              <a:buNone/>
+            </a:pPr>
+            <a:r>
+              <a:rPr lang="en-US" sz="1100" b="1" dirty="0">
+                <a:solidFill>
+                  <a:srgbClr val="00357A"/>
+                </a:solidFill>
+                <a:latin typeface="Poppins" pitchFamily="34" charset="0"/>
+                <a:ea typeface="Poppins" pitchFamily="34" charset="-122"/>
+                <a:cs typeface="Poppins" pitchFamily="34" charset="-120"/>
+              </a:rPr>
+              <a:t>DSARCH → Dataset Information</a:t>
+            </a:r>
+            <a:pPr indent="0" marL="0">
+              <a:lnSpc>
+                <a:spcPct val="115000"/>
+              </a:lnSpc>
+              <a:buNone/>
+            </a:pPr>
             <a:endParaRPr lang="en-US" sz="1100" dirty="0"/>
           </a:p>
           <a:p>
             <a:pPr indent="0" marL="0">
               <a:lnSpc>
-                <a:spcPct val="105000"/>
+                <a:spcPct val="115000"/>
               </a:lnSpc>
               <a:buNone/>
             </a:pPr>
             <a:r>
-              <a:rPr lang="en-US" sz="1100" dirty="0">
-                <a:solidFill>
-                  <a:srgbClr val="00357A"/>
-                </a:solidFill>
-                <a:latin typeface="Poppins" pitchFamily="34" charset="0"/>
-                <a:ea typeface="Poppins" pitchFamily="34" charset="-122"/>
-                <a:cs typeface="Poppins" pitchFamily="34" charset="-120"/>
-              </a:rPr>
-              <a:t>under </a:t>
+              <a:rPr lang="en-US" sz="1100" b="1" dirty="0">
+                <a:solidFill>
+                  <a:srgbClr val="0057C2"/>
+                </a:solidFill>
+                <a:latin typeface="Poppins" pitchFamily="34" charset="0"/>
+                <a:ea typeface="Poppins" pitchFamily="34" charset="-122"/>
+                <a:cs typeface="Poppins" pitchFamily="34" charset="-120"/>
+              </a:rPr>
+              <a:t>Per-run override: </a:t>
             </a:r>
             <a:endParaRPr lang="en-US" sz="1100" dirty="0"/>
           </a:p>
           <a:p>
             <a:pPr indent="0" marL="0">
               <a:lnSpc>
-                <a:spcPct val="105000"/>
+                <a:spcPct val="115000"/>
               </a:lnSpc>
               <a:buNone/>
             </a:pPr>
             <a:r>
               <a:rPr lang="en-US" sz="1100" b="1" dirty="0">
-                <a:solidFill>
-                  <a:srgbClr val="00357A"/>
-                </a:solidFill>
-                <a:latin typeface="Poppins" pitchFamily="34" charset="0"/>
-                <a:ea typeface="Poppins" pitchFamily="34" charset="-122"/>
-                <a:cs typeface="Poppins" pitchFamily="34" charset="-120"/>
-              </a:rPr>
-              <a:t>DSARCH → Dataset Information</a:t>
-            </a:r>
-            <a:pPr indent="0" marL="0">
-              <a:lnSpc>
-                <a:spcPct val="105000"/>
-              </a:lnSpc>
-              <a:buNone/>
-            </a:pPr>
-            <a:r>
-              <a:rPr lang="en-US" sz="1100" dirty="0">
-                <a:solidFill>
-                  <a:srgbClr val="00357A"/>
-                </a:solidFill>
-                <a:latin typeface="Poppins" pitchFamily="34" charset="0"/>
-                <a:ea typeface="Poppins" pitchFamily="34" charset="-122"/>
-                <a:cs typeface="Poppins" pitchFamily="34" charset="-120"/>
-              </a:rPr>
-              <a:t>, where backflag is set or changed per dataset.</a:t>
-            </a:r>
-            <a:endParaRPr lang="en-US" sz="1100" dirty="0"/>
-          </a:p>
-        </p:txBody>
-      </p:sp>
-      <p:sp>
-        <p:nvSpPr>
-          <p:cNvPr id="9" name="Shape 6"/>
-          <p:cNvSpPr/>
-          <p:nvPr/>
-        </p:nvSpPr>
-        <p:spPr>
-          <a:xfrm>
-            <a:off x="457200" y="5614416"/>
-            <a:ext cx="5532120" cy="457200"/>
-          </a:xfrm>
-          <a:prstGeom prst="roundRect">
-            <a:avLst>
-              <a:gd name="adj" fmla="val 16000"/>
-            </a:avLst>
-          </a:prstGeom>
-          <a:solidFill>
-            <a:srgbClr val="C7E4F5"/>
-          </a:solidFill>
-          <a:ln w="12700">
-            <a:solidFill>
-              <a:srgbClr val="A9D6F2"/>
-            </a:solidFill>
-            <a:prstDash val="solid"/>
-          </a:ln>
-        </p:spPr>
-      </p:sp>
-      <p:sp>
-        <p:nvSpPr>
-          <p:cNvPr id="10" name="Text 7"/>
-          <p:cNvSpPr/>
-          <p:nvPr/>
-        </p:nvSpPr>
-        <p:spPr>
-          <a:xfrm>
-            <a:off x="658368" y="5614416"/>
-            <a:ext cx="5120640" cy="457200"/>
-          </a:xfrm>
-          <a:prstGeom prst="rect">
-            <a:avLst/>
-          </a:prstGeom>
-          <a:noFill/>
-          <a:ln/>
-        </p:spPr>
-        <p:txBody>
-          <a:bodyPr wrap="square" lIns="0" tIns="0" rIns="0" bIns="0" rtlCol="0" anchor="ctr"/>
-          <a:lstStyle/>
-          <a:p>
-            <a:pPr indent="0" marL="0">
-              <a:buNone/>
-            </a:pPr>
-            <a:r>
-              <a:rPr lang="en-US" sz="1050" b="1" dirty="0">
-                <a:solidFill>
-                  <a:srgbClr val="0057C2"/>
-                </a:solidFill>
-                <a:latin typeface="Poppins" pitchFamily="34" charset="0"/>
-                <a:ea typeface="Poppins" pitchFamily="34" charset="-122"/>
-                <a:cs typeface="Poppins" pitchFamily="34" charset="-120"/>
-              </a:rPr>
-              <a:t>Per-run override:  </a:t>
-            </a:r>
-            <a:pPr indent="0" marL="0">
-              <a:buNone/>
-            </a:pPr>
-            <a:r>
-              <a:rPr lang="en-US" sz="1050" b="1" dirty="0">
                 <a:solidFill>
                   <a:srgbClr val="00357A"/>
                 </a:solidFill>
@@ -38358,10 +38327,13 @@
               <a:t>-B</a:t>
             </a:r>
             <a:pPr indent="0" marL="0">
-              <a:buNone/>
-            </a:pPr>
-            <a:r>
-              <a:rPr lang="en-US" sz="1050" dirty="0">
+              <a:lnSpc>
+                <a:spcPct val="115000"/>
+              </a:lnSpc>
+              <a:buNone/>
+            </a:pPr>
+            <a:r>
+              <a:rPr lang="en-US" sz="1100" dirty="0">
                 <a:solidFill>
                   <a:srgbClr val="00357A"/>
                 </a:solidFill>
@@ -38372,10 +38344,13 @@
               <a:t> or </a:t>
             </a:r>
             <a:pPr indent="0" marL="0">
-              <a:buNone/>
-            </a:pPr>
-            <a:r>
-              <a:rPr lang="en-US" sz="1050" b="1" dirty="0">
+              <a:lnSpc>
+                <a:spcPct val="115000"/>
+              </a:lnSpc>
+              <a:buNone/>
+            </a:pPr>
+            <a:r>
+              <a:rPr lang="en-US" sz="1100" b="1" dirty="0">
                 <a:solidFill>
                   <a:srgbClr val="00357A"/>
                 </a:solidFill>
@@ -38386,10 +38361,13 @@
               <a:t>-D</a:t>
             </a:r>
             <a:pPr indent="0" marL="0">
-              <a:buNone/>
-            </a:pPr>
-            <a:r>
-              <a:rPr lang="en-US" sz="1050" dirty="0">
+              <a:lnSpc>
+                <a:spcPct val="115000"/>
+              </a:lnSpc>
+              <a:buNone/>
+            </a:pPr>
+            <a:r>
+              <a:rPr lang="en-US" sz="1100" dirty="0">
                 <a:solidFill>
                   <a:srgbClr val="00357A"/>
                 </a:solidFill>
@@ -38397,15 +38375,15 @@
                 <a:ea typeface="Poppins" pitchFamily="34" charset="-122"/>
                 <a:cs typeface="Poppins" pitchFamily="34" charset="-120"/>
               </a:rPr>
-              <a:t> narrows a run to one copy — mutually exclusive; neither means both.</a:t>
-            </a:r>
-            <a:endParaRPr lang="en-US" sz="1050" dirty="0"/>
-          </a:p>
-        </p:txBody>
-      </p:sp>
-      <p:sp>
-        <p:nvSpPr>
-          <p:cNvPr id="11" name="Shape 8"/>
+              <a:t> narrows a run to one copy; neither means both.</a:t>
+            </a:r>
+            <a:endParaRPr lang="en-US" sz="1100" dirty="0"/>
+          </a:p>
+        </p:txBody>
+      </p:sp>
+      <p:sp>
+        <p:nvSpPr>
+          <p:cNvPr id="9" name="Shape 6"/>
           <p:cNvSpPr/>
           <p:nvPr/>
         </p:nvSpPr>
@@ -38432,7 +38410,7 @@
       </p:sp>
       <p:sp>
         <p:nvSpPr>
-          <p:cNvPr id="12" name="Text 9"/>
+          <p:cNvPr id="10" name="Text 7"/>
           <p:cNvSpPr/>
           <p:nvPr/>
         </p:nvSpPr>
@@ -38471,7 +38449,7 @@
       </p:sp>
       <p:sp>
         <p:nvSpPr>
-          <p:cNvPr id="13" name="Shape 10"/>
+          <p:cNvPr id="11" name="Shape 8"/>
           <p:cNvSpPr/>
           <p:nvPr/>
         </p:nvSpPr>
@@ -38493,7 +38471,7 @@
       </p:sp>
       <p:sp>
         <p:nvSpPr>
-          <p:cNvPr id="14" name="Text 11"/>
+          <p:cNvPr id="12" name="Text 9"/>
           <p:cNvSpPr/>
           <p:nvPr/>
         </p:nvSpPr>
@@ -38547,7 +38525,7 @@
       </p:sp>
       <p:sp>
         <p:nvSpPr>
-          <p:cNvPr id="15" name="Text 12"/>
+          <p:cNvPr id="13" name="Text 10"/>
           <p:cNvSpPr/>
           <p:nvPr/>
         </p:nvSpPr>
@@ -38586,18 +38564,18 @@
       </p:sp>
       <p:sp>
         <p:nvSpPr>
-          <p:cNvPr id="16" name="Shape 13"/>
-          <p:cNvSpPr/>
-          <p:nvPr/>
-        </p:nvSpPr>
-        <p:spPr>
-          <a:xfrm>
-            <a:off x="6537960" y="3584448"/>
-            <a:ext cx="4846320" cy="960120"/>
+          <p:cNvPr id="14" name="Shape 11"/>
+          <p:cNvSpPr/>
+          <p:nvPr/>
+        </p:nvSpPr>
+        <p:spPr>
+          <a:xfrm>
+            <a:off x="6537960" y="3520440"/>
+            <a:ext cx="4846320" cy="914400"/>
           </a:xfrm>
           <a:prstGeom prst="roundRect">
             <a:avLst>
-              <a:gd name="adj" fmla="val 7619"/>
+              <a:gd name="adj" fmla="val 8000"/>
             </a:avLst>
           </a:prstGeom>
           <a:solidFill>
@@ -38613,13 +38591,13 @@
       </p:sp>
       <p:sp>
         <p:nvSpPr>
-          <p:cNvPr id="17" name="Text 14"/>
-          <p:cNvSpPr/>
-          <p:nvPr/>
-        </p:nvSpPr>
-        <p:spPr>
-          <a:xfrm>
-            <a:off x="6766560" y="3694176"/>
+          <p:cNvPr id="15" name="Text 12"/>
+          <p:cNvSpPr/>
+          <p:nvPr/>
+        </p:nvSpPr>
+        <p:spPr>
+          <a:xfrm>
+            <a:off x="6766560" y="3611880"/>
             <a:ext cx="4480560" cy="365760"/>
           </a:xfrm>
           <a:prstGeom prst="rect">
@@ -38652,13 +38630,13 @@
       </p:sp>
       <p:sp>
         <p:nvSpPr>
-          <p:cNvPr id="18" name="Text 15"/>
-          <p:cNvSpPr/>
-          <p:nvPr/>
-        </p:nvSpPr>
-        <p:spPr>
-          <a:xfrm>
-            <a:off x="6766560" y="4059936"/>
+          <p:cNvPr id="16" name="Text 13"/>
+          <p:cNvSpPr/>
+          <p:nvPr/>
+        </p:nvSpPr>
+        <p:spPr>
+          <a:xfrm>
+            <a:off x="6766560" y="3977640"/>
             <a:ext cx="4480560" cy="365760"/>
           </a:xfrm>
           <a:prstGeom prst="rect">
@@ -38691,18 +38669,18 @@
       </p:sp>
       <p:sp>
         <p:nvSpPr>
-          <p:cNvPr id="19" name="Shape 16"/>
-          <p:cNvSpPr/>
-          <p:nvPr/>
-        </p:nvSpPr>
-        <p:spPr>
-          <a:xfrm>
-            <a:off x="6537960" y="4681728"/>
-            <a:ext cx="4846320" cy="960120"/>
+          <p:cNvPr id="17" name="Shape 14"/>
+          <p:cNvSpPr/>
+          <p:nvPr/>
+        </p:nvSpPr>
+        <p:spPr>
+          <a:xfrm>
+            <a:off x="6537960" y="4544568"/>
+            <a:ext cx="4846320" cy="914400"/>
           </a:xfrm>
           <a:prstGeom prst="roundRect">
             <a:avLst>
-              <a:gd name="adj" fmla="val 7619"/>
+              <a:gd name="adj" fmla="val 8000"/>
             </a:avLst>
           </a:prstGeom>
           <a:solidFill>
@@ -38718,13 +38696,13 @@
       </p:sp>
       <p:sp>
         <p:nvSpPr>
-          <p:cNvPr id="20" name="Text 17"/>
-          <p:cNvSpPr/>
-          <p:nvPr/>
-        </p:nvSpPr>
-        <p:spPr>
-          <a:xfrm>
-            <a:off x="6766560" y="4791456"/>
+          <p:cNvPr id="18" name="Text 15"/>
+          <p:cNvSpPr/>
+          <p:nvPr/>
+        </p:nvSpPr>
+        <p:spPr>
+          <a:xfrm>
+            <a:off x="6766560" y="4636008"/>
             <a:ext cx="4480560" cy="365760"/>
           </a:xfrm>
           <a:prstGeom prst="rect">
@@ -38757,13 +38735,13 @@
       </p:sp>
       <p:sp>
         <p:nvSpPr>
-          <p:cNvPr id="21" name="Text 18"/>
-          <p:cNvSpPr/>
-          <p:nvPr/>
-        </p:nvSpPr>
-        <p:spPr>
-          <a:xfrm>
-            <a:off x="6766560" y="5157216"/>
+          <p:cNvPr id="19" name="Text 16"/>
+          <p:cNvSpPr/>
+          <p:nvPr/>
+        </p:nvSpPr>
+        <p:spPr>
+          <a:xfrm>
+            <a:off x="6766560" y="5001768"/>
             <a:ext cx="4480560" cy="365760"/>
           </a:xfrm>
           <a:prstGeom prst="rect">
@@ -38796,14 +38774,14 @@
       </p:sp>
       <p:sp>
         <p:nvSpPr>
-          <p:cNvPr id="22" name="Text 19"/>
-          <p:cNvSpPr/>
-          <p:nvPr/>
-        </p:nvSpPr>
-        <p:spPr>
-          <a:xfrm>
-            <a:off x="6537960" y="5623560"/>
-            <a:ext cx="4846320" cy="411480"/>
+          <p:cNvPr id="20" name="Text 17"/>
+          <p:cNvSpPr/>
+          <p:nvPr/>
+        </p:nvSpPr>
+        <p:spPr>
+          <a:xfrm>
+            <a:off x="6537960" y="5532120"/>
+            <a:ext cx="4846320" cy="457200"/>
           </a:xfrm>
           <a:prstGeom prst="rect">
             <a:avLst/>
@@ -38822,7 +38800,7 @@
               <a:buNone/>
             </a:pPr>
             <a:r>
-              <a:rPr lang="en-US" sz="1150" dirty="0">
+              <a:rPr lang="en-US" sz="1100" dirty="0">
                 <a:solidFill>
                   <a:srgbClr val="53565A"/>
                 </a:solidFill>
@@ -38830,15 +38808,15 @@
                 <a:ea typeface="Poppins" pitchFamily="34" charset="-122"/>
                 <a:cs typeface="Poppins" pitchFamily="34" charset="-120"/>
               </a:rPr>
-              <a:t>A 'D' backup writes the Drdata copy first, then the Backup copy; both must succeed before the local tar is deleted and the record is marked 'A'.</a:t>
-            </a:r>
-            <a:endParaRPr lang="en-US" sz="1150" dirty="0"/>
+              <a:t>A 'D' backup writes Drdata first, then Backup; both must succeed before the local tar is deleted.</a:t>
+            </a:r>
+            <a:endParaRPr lang="en-US" sz="1100" dirty="0"/>
           </a:p>
         </p:txBody>
       </p:sp>
       <p:pic>
         <p:nvPicPr>
-          <p:cNvPr id="23" name="Image 0" descr="nsf_ncar_logo_color.png">    </p:cNvPr>
+          <p:cNvPr id="21" name="Image 0" descr="nsf_ncar_logo_color.png">    </p:cNvPr>
           <p:cNvPicPr>
             <a:picLocks noChangeAspect="1"/>
           </p:cNvPicPr>
@@ -38862,7 +38840,7 @@
       </p:pic>
       <p:sp>
         <p:nvSpPr>
-          <p:cNvPr id="24" name="Text 20"/>
+          <p:cNvPr id="22" name="Text 18"/>
           <p:cNvSpPr/>
           <p:nvPr/>
         </p:nvSpPr>
@@ -38901,7 +38879,7 @@
       </p:sp>
       <p:sp>
         <p:nvSpPr>
-          <p:cNvPr id="25" name="Text 21"/>
+          <p:cNvPr id="23" name="Text 19"/>
           <p:cNvSpPr/>
           <p:nvPr/>
         </p:nvSpPr>

</xml_diff>

<commit_message>
name both web config pages that set the backup flag, keep slide 3 links unwrapped
Slide 8 now says where each flag lives: DSARCH -> Dataset Information sets
dataset.backflag and DSARCH -> Group Information sets dsgroup.backflag.
Slide 3's repository links sat within 0.05 in of the card edge, so they
wrapped under PowerPoint's metrics; shrunk and widened to keep them on one
line.

Co-Authored-By: Claude Opus 4.6 <noreply@anthropic.com>
</commit_message>
<xml_diff>
--- a/docs/slides/dsquasar_guide.pptx
+++ b/docs/slides/dsquasar_guide.pptx
@@ -30599,7 +30599,7 @@
         <p:spPr>
           <a:xfrm>
             <a:off x="731520" y="4855464"/>
-            <a:ext cx="3054096" cy="310896"/>
+            <a:ext cx="3218688" cy="310896"/>
           </a:xfrm>
           <a:prstGeom prst="rect">
             <a:avLst/>
@@ -30615,7 +30615,7 @@
               <a:buNone/>
             </a:pPr>
             <a:r>
-              <a:rPr lang="en-US" sz="1050" b="1" dirty="0">
+              <a:rPr lang="en-US" sz="950" b="1" dirty="0">
                 <a:solidFill>
                   <a:srgbClr val="0057C2"/>
                 </a:solidFill>
@@ -30629,7 +30629,7 @@
               <a:buNone/>
             </a:pPr>
             <a:r>
-              <a:rPr lang="en-US" sz="1050" b="1" u="sng" dirty="0">
+              <a:rPr lang="en-US" sz="950" b="1" u="sng" dirty="0">
                 <a:solidFill>
                   <a:srgbClr val="0057C2"/>
                 </a:solidFill>
@@ -30646,7 +30646,7 @@
               </a:rPr>
               <a:t>github.com/NCAR/rda-python-dsquasar</a:t>
             </a:r>
-            <a:endParaRPr lang="en-US" sz="1050" dirty="0"/>
+            <a:endParaRPr lang="en-US" sz="950" dirty="0"/>
           </a:p>
         </p:txBody>
       </p:sp>
@@ -30940,7 +30940,7 @@
         <p:spPr>
           <a:xfrm>
             <a:off x="4572000" y="4855464"/>
-            <a:ext cx="3054096" cy="310896"/>
+            <a:ext cx="3218688" cy="310896"/>
           </a:xfrm>
           <a:prstGeom prst="rect">
             <a:avLst/>
@@ -30956,7 +30956,7 @@
               <a:buNone/>
             </a:pPr>
             <a:r>
-              <a:rPr lang="en-US" sz="1050" b="1" dirty="0">
+              <a:rPr lang="en-US" sz="950" b="1" dirty="0">
                 <a:solidFill>
                   <a:srgbClr val="0097A7"/>
                 </a:solidFill>
@@ -30970,7 +30970,7 @@
               <a:buNone/>
             </a:pPr>
             <a:r>
-              <a:rPr lang="en-US" sz="1050" b="1" u="sng" dirty="0">
+              <a:rPr lang="en-US" sz="950" b="1" u="sng" dirty="0">
                 <a:solidFill>
                   <a:srgbClr val="0057C2"/>
                 </a:solidFill>
@@ -30987,7 +30987,7 @@
               </a:rPr>
               <a:t>pypi.org/project/rda-python-dsquasar</a:t>
             </a:r>
-            <a:endParaRPr lang="en-US" sz="1050" dirty="0"/>
+            <a:endParaRPr lang="en-US" sz="950" dirty="0"/>
           </a:p>
         </p:txBody>
       </p:sp>
@@ -31301,7 +31301,7 @@
         <p:spPr>
           <a:xfrm>
             <a:off x="8412480" y="4855464"/>
-            <a:ext cx="3054096" cy="310896"/>
+            <a:ext cx="3218688" cy="310896"/>
           </a:xfrm>
           <a:prstGeom prst="rect">
             <a:avLst/>
@@ -31317,7 +31317,7 @@
               <a:buNone/>
             </a:pPr>
             <a:r>
-              <a:rPr lang="en-US" sz="1050" b="1" dirty="0">
+              <a:rPr lang="en-US" sz="950" b="1" dirty="0">
                 <a:solidFill>
                   <a:srgbClr val="C25E00"/>
                 </a:solidFill>
@@ -31331,7 +31331,7 @@
               <a:buNone/>
             </a:pPr>
             <a:r>
-              <a:rPr lang="en-US" sz="1050" b="1" u="sng" dirty="0">
+              <a:rPr lang="en-US" sz="950" b="1" u="sng" dirty="0">
                 <a:solidFill>
                   <a:srgbClr val="0057C2"/>
                 </a:solidFill>
@@ -31348,7 +31348,7 @@
               </a:rPr>
               <a:t>src/rda_python_dsquasar/dsquasar.usg</a:t>
             </a:r>
-            <a:endParaRPr lang="en-US" sz="1050" dirty="0"/>
+            <a:endParaRPr lang="en-US" sz="950" dirty="0"/>
           </a:p>
         </p:txBody>
       </p:sp>
@@ -37986,8 +37986,8 @@
         </p:nvSpPr>
         <p:spPr>
           <a:xfrm>
-            <a:off x="457200" y="3950208"/>
-            <a:ext cx="5532120" cy="731520"/>
+            <a:off x="457200" y="3968496"/>
+            <a:ext cx="5532120" cy="502920"/>
           </a:xfrm>
           <a:prstGeom prst="rect">
             <a:avLst/>
@@ -38065,75 +38065,7 @@
                 <a:ea typeface="Poppins" pitchFamily="34" charset="-122"/>
                 <a:cs typeface="Poppins" pitchFamily="34" charset="-120"/>
               </a:rPr>
-              <a:t> with its own flag is applied group by group — </a:t>
-            </a:r>
-            <a:pPr indent="0" marL="0">
-              <a:lnSpc>
-                <a:spcPct val="106000"/>
-              </a:lnSpc>
-              <a:buNone/>
-            </a:pPr>
-            <a:r>
-              <a:rPr lang="en-US" sz="1200" b="1" dirty="0">
-                <a:solidFill>
-                  <a:srgbClr val="00357A"/>
-                </a:solidFill>
-                <a:latin typeface="Courier New" pitchFamily="34" charset="0"/>
-                <a:ea typeface="Courier New" pitchFamily="34" charset="-122"/>
-                <a:cs typeface="Courier New" pitchFamily="34" charset="-120"/>
-              </a:rPr>
-              <a:t>'P'</a:t>
-            </a:r>
-            <a:pPr indent="0" marL="0">
-              <a:lnSpc>
-                <a:spcPct val="106000"/>
-              </a:lnSpc>
-              <a:buNone/>
-            </a:pPr>
-            <a:r>
-              <a:rPr lang="en-US" sz="1200" dirty="0">
-                <a:solidFill>
-                  <a:srgbClr val="00357A"/>
-                </a:solidFill>
-                <a:latin typeface="Poppins" pitchFamily="34" charset="0"/>
-                <a:ea typeface="Poppins" pitchFamily="34" charset="-122"/>
-                <a:cs typeface="Poppins" pitchFamily="34" charset="-120"/>
-              </a:rPr>
-              <a:t> inherits, </a:t>
-            </a:r>
-            <a:pPr indent="0" marL="0">
-              <a:lnSpc>
-                <a:spcPct val="106000"/>
-              </a:lnSpc>
-              <a:buNone/>
-            </a:pPr>
-            <a:r>
-              <a:rPr lang="en-US" sz="1200" b="1" dirty="0">
-                <a:solidFill>
-                  <a:srgbClr val="00357A"/>
-                </a:solidFill>
-                <a:latin typeface="Courier New" pitchFamily="34" charset="0"/>
-                <a:ea typeface="Courier New" pitchFamily="34" charset="-122"/>
-                <a:cs typeface="Courier New" pitchFamily="34" charset="-120"/>
-              </a:rPr>
-              <a:t>'N'</a:t>
-            </a:r>
-            <a:pPr indent="0" marL="0">
-              <a:lnSpc>
-                <a:spcPct val="106000"/>
-              </a:lnSpc>
-              <a:buNone/>
-            </a:pPr>
-            <a:r>
-              <a:rPr lang="en-US" sz="1200" dirty="0">
-                <a:solidFill>
-                  <a:srgbClr val="00357A"/>
-                </a:solidFill>
-                <a:latin typeface="Poppins" pitchFamily="34" charset="0"/>
-                <a:ea typeface="Poppins" pitchFamily="34" charset="-122"/>
-                <a:cs typeface="Poppins" pitchFamily="34" charset="-120"/>
-              </a:rPr>
-              <a:t> excludes.</a:t>
+              <a:t> flag is applied group by group.</a:t>
             </a:r>
             <a:endParaRPr lang="en-US" sz="1200" dirty="0"/>
           </a:p>
@@ -38147,12 +38079,12 @@
         </p:nvSpPr>
         <p:spPr>
           <a:xfrm>
-            <a:off x="457200" y="4754880"/>
-            <a:ext cx="5532120" cy="1298448"/>
+            <a:off x="457200" y="4498848"/>
+            <a:ext cx="5532120" cy="1554480"/>
           </a:xfrm>
           <a:prstGeom prst="roundRect">
             <a:avLst>
-              <a:gd name="adj" fmla="val 6338"/>
+              <a:gd name="adj" fmla="val 5294"/>
             </a:avLst>
           </a:prstGeom>
           <a:solidFill>
@@ -38174,8 +38106,8 @@
         </p:nvSpPr>
         <p:spPr>
           <a:xfrm>
-            <a:off x="658368" y="4754880"/>
-            <a:ext cx="5120640" cy="1298448"/>
+            <a:off x="658368" y="4498848"/>
+            <a:ext cx="5166360" cy="1554480"/>
           </a:xfrm>
           <a:prstGeom prst="rect">
             <a:avLst/>
@@ -38189,12 +38121,12 @@
           <a:p>
             <a:pPr indent="0" marL="0">
               <a:lnSpc>
-                <a:spcPct val="115000"/>
+                <a:spcPct val="118000"/>
               </a:lnSpc>
               <a:buNone/>
             </a:pPr>
             <a:r>
-              <a:rPr lang="en-US" sz="1100" b="1" dirty="0">
+              <a:rPr lang="en-US" sz="1050" b="1" dirty="0">
                 <a:solidFill>
                   <a:srgbClr val="0057C2"/>
                 </a:solidFill>
@@ -38202,34 +38134,16 @@
                 <a:ea typeface="Poppins" pitchFamily="34" charset="-122"/>
                 <a:cs typeface="Poppins" pitchFamily="34" charset="-120"/>
               </a:rPr>
-              <a:t>Set the flag in the web config tool</a:t>
+              <a:t>Set Backup Flag in the web config tool   </a:t>
             </a:r>
             <a:pPr indent="0" marL="0">
               <a:lnSpc>
-                <a:spcPct val="115000"/>
+                <a:spcPct val="118000"/>
               </a:lnSpc>
               <a:buNone/>
             </a:pPr>
             <a:r>
-              <a:rPr lang="en-US" sz="1100" dirty="0">
-                <a:solidFill>
-                  <a:srgbClr val="00357A"/>
-                </a:solidFill>
-                <a:latin typeface="Poppins" pitchFamily="34" charset="0"/>
-                <a:ea typeface="Poppins" pitchFamily="34" charset="-122"/>
-                <a:cs typeface="Poppins" pitchFamily="34" charset="-120"/>
-              </a:rPr>
-              <a:t>
-</a:t>
-            </a:r>
-            <a:pPr indent="0" marL="0">
-              <a:lnSpc>
-                <a:spcPct val="115000"/>
-              </a:lnSpc>
-              <a:buNone/>
-            </a:pPr>
-            <a:r>
-              <a:rPr lang="en-US" sz="1100" b="1" u="sng" dirty="0">
+              <a:rPr lang="en-US" sz="1050" b="1" u="sng" dirty="0">
                 <a:solidFill>
                   <a:srgbClr val="0057C2"/>
                 </a:solidFill>
@@ -38248,12 +38162,21 @@
             </a:r>
             <a:pPr indent="0" marL="0">
               <a:lnSpc>
-                <a:spcPct val="115000"/>
+                <a:spcPct val="118000"/>
               </a:lnSpc>
               <a:buNone/>
             </a:pPr>
-            <a:r>
-              <a:rPr lang="en-US" sz="1100" dirty="0">
+            <a:endParaRPr lang="en-US" sz="1050" dirty="0"/>
+          </a:p>
+          <a:p>
+            <a:pPr indent="0" marL="0">
+              <a:lnSpc>
+                <a:spcPct val="118000"/>
+              </a:lnSpc>
+              <a:buNone/>
+            </a:pPr>
+            <a:r>
+              <a:rPr lang="en-US" sz="1050" b="1" dirty="0">
                 <a:solidFill>
                   <a:srgbClr val="00357A"/>
                 </a:solidFill>
@@ -38261,16 +38184,19 @@
                 <a:ea typeface="Poppins" pitchFamily="34" charset="-122"/>
                 <a:cs typeface="Poppins" pitchFamily="34" charset="-120"/>
               </a:rPr>
-              <a:t>   under   </a:t>
-            </a:r>
+              <a:t>DSARCH → Dataset Information</a:t>
+            </a:r>
+            <a:endParaRPr lang="en-US" sz="1050" dirty="0"/>
+          </a:p>
+          <a:p>
             <a:pPr indent="0" marL="0">
               <a:lnSpc>
-                <a:spcPct val="115000"/>
+                <a:spcPct val="118000"/>
               </a:lnSpc>
               <a:buNone/>
             </a:pPr>
             <a:r>
-              <a:rPr lang="en-US" sz="1100" b="1" dirty="0">
+              <a:rPr lang="en-US" sz="1050" dirty="0">
                 <a:solidFill>
                   <a:srgbClr val="00357A"/>
                 </a:solidFill>
@@ -38278,45 +38204,16 @@
                 <a:ea typeface="Poppins" pitchFamily="34" charset="-122"/>
                 <a:cs typeface="Poppins" pitchFamily="34" charset="-120"/>
               </a:rPr>
-              <a:t>DSARCH → Dataset Information</a:t>
+              <a:t>  sets </a:t>
             </a:r>
             <a:pPr indent="0" marL="0">
               <a:lnSpc>
-                <a:spcPct val="115000"/>
+                <a:spcPct val="118000"/>
               </a:lnSpc>
               <a:buNone/>
             </a:pPr>
-            <a:endParaRPr lang="en-US" sz="1100" dirty="0"/>
-          </a:p>
-          <a:p>
-            <a:pPr indent="0" marL="0">
-              <a:lnSpc>
-                <a:spcPct val="115000"/>
-              </a:lnSpc>
-              <a:buNone/>
-            </a:pPr>
-            <a:r>
-              <a:rPr lang="en-US" sz="1100" b="1" dirty="0">
-                <a:solidFill>
-                  <a:srgbClr val="0057C2"/>
-                </a:solidFill>
-                <a:latin typeface="Poppins" pitchFamily="34" charset="0"/>
-                <a:ea typeface="Poppins" pitchFamily="34" charset="-122"/>
-                <a:cs typeface="Poppins" pitchFamily="34" charset="-120"/>
-              </a:rPr>
-              <a:t>Per-run override: </a:t>
-            </a:r>
-            <a:endParaRPr lang="en-US" sz="1100" dirty="0"/>
-          </a:p>
-          <a:p>
-            <a:pPr indent="0" marL="0">
-              <a:lnSpc>
-                <a:spcPct val="115000"/>
-              </a:lnSpc>
-              <a:buNone/>
-            </a:pPr>
-            <a:r>
-              <a:rPr lang="en-US" sz="1100" b="1" dirty="0">
+            <a:r>
+              <a:rPr lang="en-US" sz="1050" b="1" dirty="0">
                 <a:solidFill>
                   <a:srgbClr val="00357A"/>
                 </a:solidFill>
@@ -38324,16 +38221,16 @@
                 <a:ea typeface="Courier New" pitchFamily="34" charset="-122"/>
                 <a:cs typeface="Courier New" pitchFamily="34" charset="-120"/>
               </a:rPr>
-              <a:t>-B</a:t>
+              <a:t>dataset.backflag</a:t>
             </a:r>
             <a:pPr indent="0" marL="0">
               <a:lnSpc>
-                <a:spcPct val="115000"/>
+                <a:spcPct val="118000"/>
               </a:lnSpc>
               <a:buNone/>
             </a:pPr>
             <a:r>
-              <a:rPr lang="en-US" sz="1100" dirty="0">
+              <a:rPr lang="en-US" sz="1050" dirty="0">
                 <a:solidFill>
                   <a:srgbClr val="00357A"/>
                 </a:solidFill>
@@ -38341,16 +38238,62 @@
                 <a:ea typeface="Poppins" pitchFamily="34" charset="-122"/>
                 <a:cs typeface="Poppins" pitchFamily="34" charset="-120"/>
               </a:rPr>
-              <a:t> or </a:t>
+              <a:t> for the whole dataset</a:t>
             </a:r>
             <a:pPr indent="0" marL="0">
               <a:lnSpc>
-                <a:spcPct val="115000"/>
+                <a:spcPct val="118000"/>
               </a:lnSpc>
               <a:buNone/>
             </a:pPr>
-            <a:r>
-              <a:rPr lang="en-US" sz="1100" b="1" dirty="0">
+            <a:endParaRPr lang="en-US" sz="1050" dirty="0"/>
+          </a:p>
+          <a:p>
+            <a:pPr indent="0" marL="0">
+              <a:lnSpc>
+                <a:spcPct val="118000"/>
+              </a:lnSpc>
+              <a:buNone/>
+            </a:pPr>
+            <a:r>
+              <a:rPr lang="en-US" sz="1050" b="1" dirty="0">
+                <a:solidFill>
+                  <a:srgbClr val="00357A"/>
+                </a:solidFill>
+                <a:latin typeface="Poppins" pitchFamily="34" charset="0"/>
+                <a:ea typeface="Poppins" pitchFamily="34" charset="-122"/>
+                <a:cs typeface="Poppins" pitchFamily="34" charset="-120"/>
+              </a:rPr>
+              <a:t>DSARCH → Group Information</a:t>
+            </a:r>
+            <a:endParaRPr lang="en-US" sz="1050" dirty="0"/>
+          </a:p>
+          <a:p>
+            <a:pPr indent="0" marL="0">
+              <a:lnSpc>
+                <a:spcPct val="118000"/>
+              </a:lnSpc>
+              <a:buNone/>
+            </a:pPr>
+            <a:r>
+              <a:rPr lang="en-US" sz="1050" dirty="0">
+                <a:solidFill>
+                  <a:srgbClr val="00357A"/>
+                </a:solidFill>
+                <a:latin typeface="Poppins" pitchFamily="34" charset="0"/>
+                <a:ea typeface="Poppins" pitchFamily="34" charset="-122"/>
+                <a:cs typeface="Poppins" pitchFamily="34" charset="-120"/>
+              </a:rPr>
+              <a:t>  sets </a:t>
+            </a:r>
+            <a:pPr indent="0" marL="0">
+              <a:lnSpc>
+                <a:spcPct val="118000"/>
+              </a:lnSpc>
+              <a:buNone/>
+            </a:pPr>
+            <a:r>
+              <a:rPr lang="en-US" sz="1050" b="1" dirty="0">
                 <a:solidFill>
                   <a:srgbClr val="00357A"/>
                 </a:solidFill>
@@ -38358,16 +38301,113 @@
                 <a:ea typeface="Courier New" pitchFamily="34" charset="-122"/>
                 <a:cs typeface="Courier New" pitchFamily="34" charset="-120"/>
               </a:rPr>
+              <a:t>dsgroup.backflag</a:t>
+            </a:r>
+            <a:pPr indent="0" marL="0">
+              <a:lnSpc>
+                <a:spcPct val="118000"/>
+              </a:lnSpc>
+              <a:buNone/>
+            </a:pPr>
+            <a:r>
+              <a:rPr lang="en-US" sz="1050" dirty="0">
+                <a:solidFill>
+                  <a:srgbClr val="00357A"/>
+                </a:solidFill>
+                <a:latin typeface="Poppins" pitchFamily="34" charset="0"/>
+                <a:ea typeface="Poppins" pitchFamily="34" charset="-122"/>
+                <a:cs typeface="Poppins" pitchFamily="34" charset="-120"/>
+              </a:rPr>
+              <a:t> for one group</a:t>
+            </a:r>
+            <a:pPr indent="0" marL="0">
+              <a:lnSpc>
+                <a:spcPct val="118000"/>
+              </a:lnSpc>
+              <a:buNone/>
+            </a:pPr>
+            <a:endParaRPr lang="en-US" sz="1050" dirty="0"/>
+          </a:p>
+          <a:p>
+            <a:pPr indent="0" marL="0">
+              <a:lnSpc>
+                <a:spcPct val="118000"/>
+              </a:lnSpc>
+              <a:buNone/>
+            </a:pPr>
+            <a:r>
+              <a:rPr lang="en-US" sz="1050" b="1" dirty="0">
+                <a:solidFill>
+                  <a:srgbClr val="0057C2"/>
+                </a:solidFill>
+                <a:latin typeface="Poppins" pitchFamily="34" charset="0"/>
+                <a:ea typeface="Poppins" pitchFamily="34" charset="-122"/>
+                <a:cs typeface="Poppins" pitchFamily="34" charset="-120"/>
+              </a:rPr>
+              <a:t>Per-run override: </a:t>
+            </a:r>
+            <a:endParaRPr lang="en-US" sz="1050" dirty="0"/>
+          </a:p>
+          <a:p>
+            <a:pPr indent="0" marL="0">
+              <a:lnSpc>
+                <a:spcPct val="118000"/>
+              </a:lnSpc>
+              <a:buNone/>
+            </a:pPr>
+            <a:r>
+              <a:rPr lang="en-US" sz="1050" b="1" dirty="0">
+                <a:solidFill>
+                  <a:srgbClr val="00357A"/>
+                </a:solidFill>
+                <a:latin typeface="Courier New" pitchFamily="34" charset="0"/>
+                <a:ea typeface="Courier New" pitchFamily="34" charset="-122"/>
+                <a:cs typeface="Courier New" pitchFamily="34" charset="-120"/>
+              </a:rPr>
+              <a:t>-B</a:t>
+            </a:r>
+            <a:pPr indent="0" marL="0">
+              <a:lnSpc>
+                <a:spcPct val="118000"/>
+              </a:lnSpc>
+              <a:buNone/>
+            </a:pPr>
+            <a:r>
+              <a:rPr lang="en-US" sz="1050" dirty="0">
+                <a:solidFill>
+                  <a:srgbClr val="00357A"/>
+                </a:solidFill>
+                <a:latin typeface="Poppins" pitchFamily="34" charset="0"/>
+                <a:ea typeface="Poppins" pitchFamily="34" charset="-122"/>
+                <a:cs typeface="Poppins" pitchFamily="34" charset="-120"/>
+              </a:rPr>
+              <a:t> or </a:t>
+            </a:r>
+            <a:pPr indent="0" marL="0">
+              <a:lnSpc>
+                <a:spcPct val="118000"/>
+              </a:lnSpc>
+              <a:buNone/>
+            </a:pPr>
+            <a:r>
+              <a:rPr lang="en-US" sz="1050" b="1" dirty="0">
+                <a:solidFill>
+                  <a:srgbClr val="00357A"/>
+                </a:solidFill>
+                <a:latin typeface="Courier New" pitchFamily="34" charset="0"/>
+                <a:ea typeface="Courier New" pitchFamily="34" charset="-122"/>
+                <a:cs typeface="Courier New" pitchFamily="34" charset="-120"/>
+              </a:rPr>
               <a:t>-D</a:t>
             </a:r>
             <a:pPr indent="0" marL="0">
               <a:lnSpc>
-                <a:spcPct val="115000"/>
+                <a:spcPct val="118000"/>
               </a:lnSpc>
               <a:buNone/>
             </a:pPr>
             <a:r>
-              <a:rPr lang="en-US" sz="1100" dirty="0">
+              <a:rPr lang="en-US" sz="1050" dirty="0">
                 <a:solidFill>
                   <a:srgbClr val="00357A"/>
                 </a:solidFill>
@@ -38377,7 +38417,7 @@
               </a:rPr>
               <a:t> narrows a run to one copy; neither means both.</a:t>
             </a:r>
-            <a:endParaRPr lang="en-US" sz="1100" dirty="0"/>
+            <a:endParaRPr lang="en-US" sz="1050" dirty="0"/>
           </a:p>
         </p:txBody>
       </p:sp>

</xml_diff>

<commit_message>
correct guide deck facts and add a dsarch restore walkthrough
Five statements in the deck no longer matched dsquasar.py: the upload
process divisor, the claim that -m is ignored on a delayed run, the
-B/-D default, the two-copy default, and the batch sizing input. Adds a
high level slide on recovering files through the dsarch -RQ action, kept
deliberately brief since a dsarch guide will cover it in full.

Co-Authored-By: Claude Opus 4.6 <noreply@anthropic.com>
</commit_message>
<xml_diff>
--- a/docs/slides/dsquasar_guide.pptx
+++ b/docs/slides/dsquasar_guide.pptx
@@ -32,9 +32,10 @@
     <p:sldId id="280" r:id="rId26"/>
     <p:sldId id="281" r:id="rId27"/>
     <p:sldId id="282" r:id="rId28"/>
+    <p:sldId id="283" r:id="rId29"/>
   </p:sldIdLst>
   <p:notesMasterIdLst>
-    <p:notesMasterId r:id="rId29"/>
+    <p:notesMasterId r:id="rId30"/>
   </p:notesMasterIdLst>
   <p:sldSz cx="12192000" cy="6858000"/>
   <p:notesSz cx="6858000" cy="12192000"/>
@@ -2224,6 +2225,94 @@
             <a:fld id="{F7021451-1387-4CA6-816F-3879F97B5CBC}" type="slidenum">
               <a:rPr lang="en-US"/>
               <a:t>27</a:t>
+            </a:fld>
+            <a:endParaRPr lang="en-US"/>
+          </a:p>
+        </p:txBody>
+      </p:sp>
+    </p:spTree>
+    <p:extLst>
+      <p:ext uri="{BB962C8B-B14F-4D97-AF65-F5344CB8AC3E}">
+        <p14:creationId xmlns:p14="http://schemas.microsoft.com/office/powerpoint/2010/main" val="1024086991"/>
+      </p:ext>
+    </p:extLst>
+  </p:cSld>
+  <p:clrMapOvr>
+    <a:masterClrMapping/>
+  </p:clrMapOvr>
+</p:notes>
+</file>
+
+<file path=ppt/notesSlides/notesSlide28.xml><?xml version="1.0" encoding="utf-8"?>
+<p:notes xmlns:a="http://schemas.openxmlformats.org/drawingml/2006/main" xmlns:r="http://schemas.openxmlformats.org/officeDocument/2006/relationships" xmlns:p="http://schemas.openxmlformats.org/presentationml/2006/main">
+  <p:cSld>
+    <p:spTree>
+      <p:nvGrpSpPr>
+        <p:cNvPr id="1" name=""/>
+        <p:cNvGrpSpPr/>
+        <p:nvPr/>
+      </p:nvGrpSpPr>
+      <p:grpSpPr>
+        <a:xfrm>
+          <a:off x="0" y="0"/>
+          <a:ext cx="0" cy="0"/>
+          <a:chOff x="0" y="0"/>
+          <a:chExt cx="0" cy="0"/>
+        </a:xfrm>
+      </p:grpSpPr>
+      <p:sp>
+        <p:nvSpPr>
+          <p:cNvPr id="2" name="Slide Image Placeholder 1"/>
+          <p:cNvSpPr>
+            <a:spLocks noGrp="1" noRot="1" noChangeAspect="1"/>
+          </p:cNvSpPr>
+          <p:nvPr>
+            <p:ph type="sldImg"/>
+          </p:nvPr>
+        </p:nvSpPr>
+        <p:spPr/>
+      </p:sp>
+      <p:sp>
+        <p:nvSpPr>
+          <p:cNvPr id="3" name="Notes Placeholder 2"/>
+          <p:cNvSpPr>
+            <a:spLocks noGrp="1"/>
+          </p:cNvSpPr>
+          <p:nvPr>
+            <p:ph type="body" idx="1"/>
+          </p:nvPr>
+        </p:nvSpPr>
+        <p:spPr/>
+        <p:txBody>
+          <a:bodyPr/>
+          <a:lstStyle/>
+          <a:p>
+            <a:r>
+              <a:rPr lang="en-US" dirty="0"/>
+              <a:t/>
+            </a:r>
+            <a:endParaRPr lang="en-US" dirty="0"/>
+          </a:p>
+        </p:txBody>
+      </p:sp>
+      <p:sp>
+        <p:nvSpPr>
+          <p:cNvPr id="4" name="Slide Number Placeholder 3"/>
+          <p:cNvSpPr>
+            <a:spLocks noGrp="1"/>
+          </p:cNvSpPr>
+          <p:nvPr>
+            <p:ph type="sldNum" sz="quarter" idx="10"/>
+          </p:nvPr>
+        </p:nvSpPr>
+        <p:spPr/>
+        <p:txBody>
+          <a:bodyPr/>
+          <a:lstStyle/>
+          <a:p>
+            <a:fld id="{F7021451-1387-4CA6-816F-3879F97B5CBC}" type="slidenum">
+              <a:rPr lang="en-US"/>
+              <a:t>28</a:t>
             </a:fld>
             <a:endParaRPr lang="en-US"/>
           </a:p>
@@ -13489,7 +13578,7 @@
                 <a:ea typeface="Poppins" pitchFamily="34" charset="-122"/>
                 <a:cs typeface="Poppins" pitchFamily="34" charset="-120"/>
               </a:rPr>
-              <a:t>The detail file count is turned into a cpu count, and PBS qoptions are written:</a:t>
+              <a:t>The pending tar count is turned into a cpu count, and PBS qoptions are written:</a:t>
             </a:r>
             <a:endParaRPr lang="en-US" sz="1050" dirty="0"/>
           </a:p>
@@ -14690,7 +14779,7 @@
                 <a:ea typeface="Courier New" pitchFamily="34" charset="-122"/>
                 <a:cs typeface="Courier New" pitchFamily="34" charset="-120"/>
               </a:rPr>
-              <a:t>MPBLIMIT = 900   tar files per process</a:t>
+              <a:t>MPBLIMIT = 5000  tar files per process</a:t>
             </a:r>
             <a:endParaRPr lang="en-US" sz="1150" dirty="0"/>
           </a:p>
@@ -14710,7 +14799,7 @@
                 <a:ea typeface="Courier New" pitchFamily="34" charset="-122"/>
                 <a:cs typeface="Courier New" pitchFamily="34" charset="-120"/>
               </a:rPr>
-              <a:t>MPBMAX   =   4   process ceiling</a:t>
+              <a:t>MPBMAX   =    4  process ceiling</a:t>
             </a:r>
             <a:endParaRPr lang="en-US" sz="1150" dirty="0"/>
           </a:p>
@@ -14910,7 +14999,7 @@
                 <a:ea typeface="Poppins" pitchFamily="34" charset="-122"/>
                 <a:cs typeface="Poppins" pitchFamily="34" charset="-120"/>
               </a:rPr>
-              <a:t>Interactively it is whatever you pass (default 1). In delay mode the count travels through the reserved PBS ncpus instead of the command line, so -m on a -d run is ignored.</a:t>
+              <a:t>With no -m, a delayed run sizes itself and reads the count back from the reserved PBS ncpus. An explicit -m always wins — including -m 1 to force a single process.</a:t>
             </a:r>
             <a:endParaRPr lang="en-US" sz="1150" dirty="0"/>
           </a:p>
@@ -27565,7 +27654,7 @@
                 <a:ea typeface="Poppins" pitchFamily="34" charset="-122"/>
                 <a:cs typeface="Poppins" pitchFamily="34" charset="-120"/>
               </a:rPr>
-              <a:t>Every tar goes to both end points by default. Drdata is written first, so an interrupted run still leaves the DR copy complete.</a:t>
+              <a:t>A dataset flagged D is written to both end points, Drdata first, so an interrupted run still leaves the DR copy complete.</a:t>
             </a:r>
             <a:endParaRPr lang="en-US" sz="1100" dirty="0"/>
           </a:p>
@@ -28265,13 +28354,6 @@
 <file path=ppt/slides/slide26.xml><?xml version="1.0" encoding="utf-8"?>
 <p:sld xmlns:a="http://schemas.openxmlformats.org/drawingml/2006/main" xmlns:r="http://schemas.openxmlformats.org/officeDocument/2006/relationships" xmlns:p="http://schemas.openxmlformats.org/presentationml/2006/main">
   <p:cSld name="Slide 26">
-    <p:bg>
-      <p:bgPr>
-        <a:solidFill>
-          <a:srgbClr val="0057C2"/>
-        </a:solidFill>
-      </p:bgPr>
-    </p:bg>
     <p:spTree>
       <p:nvGrpSpPr>
         <p:cNvPr id="1" name=""/>
@@ -28286,81 +28368,1098 @@
           <a:chExt cx="0" cy="0"/>
         </a:xfrm>
       </p:grpSpPr>
-      <p:pic>
-        <p:nvPicPr>
-          <p:cNvPr id="2" name="Image 0" descr="interior_bg.png">    </p:cNvPr>
-          <p:cNvPicPr>
-            <a:picLocks noChangeAspect="1"/>
-          </p:cNvPicPr>
-          <p:nvPr/>
-        </p:nvPicPr>
-        <p:blipFill>
-          <a:blip r:embed="rId1"/>
-          <a:stretch>
-            <a:fillRect/>
-          </a:stretch>
-        </p:blipFill>
-        <p:spPr>
-          <a:xfrm>
-            <a:off x="0" y="0"/>
-            <a:ext cx="12191695" cy="6858000"/>
-          </a:xfrm>
-          <a:prstGeom prst="rect">
-            <a:avLst/>
-          </a:prstGeom>
-        </p:spPr>
-      </p:pic>
-      <p:pic>
-        <p:nvPicPr>
-          <p:cNvPr id="3" name="Image 1" descr="gdex_lockup_white.png">    </p:cNvPr>
-          <p:cNvPicPr>
-            <a:picLocks noChangeAspect="1"/>
-          </p:cNvPicPr>
-          <p:nvPr/>
-        </p:nvPicPr>
-        <p:blipFill>
-          <a:blip r:embed="rId2"/>
-          <a:stretch>
-            <a:fillRect/>
-          </a:stretch>
-        </p:blipFill>
-        <p:spPr>
-          <a:xfrm>
-            <a:off x="612648" y="365760"/>
-            <a:ext cx="1024128" cy="521208"/>
-          </a:xfrm>
-          <a:prstGeom prst="rect">
-            <a:avLst/>
-          </a:prstGeom>
-        </p:spPr>
-      </p:pic>
-      <p:pic>
-        <p:nvPicPr>
-          <p:cNvPr id="4" name="Image 2" descr="nsf_ncar_logo_white.png">    </p:cNvPr>
-          <p:cNvPicPr>
-            <a:picLocks noChangeAspect="1"/>
-          </p:cNvPicPr>
-          <p:nvPr/>
-        </p:nvPicPr>
-        <p:blipFill>
-          <a:blip r:embed="rId3"/>
-          <a:stretch>
-            <a:fillRect/>
-          </a:stretch>
-        </p:blipFill>
-        <p:spPr>
-          <a:xfrm>
-            <a:off x="9683496" y="393192"/>
-            <a:ext cx="1892808" cy="521208"/>
-          </a:xfrm>
-          <a:prstGeom prst="rect">
-            <a:avLst/>
-          </a:prstGeom>
-        </p:spPr>
-      </p:pic>
-      <p:sp>
-        <p:nvSpPr>
-          <p:cNvPr id="5" name="Text 0"/>
+      <p:sp>
+        <p:nvSpPr>
+          <p:cNvPr id="2" name="Text 0"/>
+          <p:cNvSpPr/>
+          <p:nvPr/>
+        </p:nvSpPr>
+        <p:spPr>
+          <a:xfrm>
+            <a:off x="457200" y="384048"/>
+            <a:ext cx="8229600" cy="274320"/>
+          </a:xfrm>
+          <a:prstGeom prst="rect">
+            <a:avLst/>
+          </a:prstGeom>
+          <a:noFill/>
+          <a:ln/>
+        </p:spPr>
+        <p:txBody>
+          <a:bodyPr wrap="square" lIns="0" tIns="0" rIns="0" bIns="0" rtlCol="0" anchor="ctr"/>
+          <a:lstStyle/>
+          <a:p>
+            <a:pPr indent="0" marL="0">
+              <a:buNone/>
+            </a:pPr>
+            <a:r>
+              <a:rPr lang="en-US" sz="1200" b="1" spc="200" kern="0" dirty="0">
+                <a:solidFill>
+                  <a:srgbClr val="0097A7"/>
+                </a:solidFill>
+                <a:latin typeface="Poppins" pitchFamily="34" charset="0"/>
+                <a:ea typeface="Poppins" pitchFamily="34" charset="-122"/>
+                <a:cs typeface="Poppins" pitchFamily="34" charset="-120"/>
+              </a:rPr>
+              <a:t>RECOVERY</a:t>
+            </a:r>
+            <a:endParaRPr lang="en-US" sz="1200" dirty="0"/>
+          </a:p>
+        </p:txBody>
+      </p:sp>
+      <p:sp>
+        <p:nvSpPr>
+          <p:cNvPr id="3" name="Text 1"/>
+          <p:cNvSpPr/>
+          <p:nvPr/>
+        </p:nvSpPr>
+        <p:spPr>
+          <a:xfrm>
+            <a:off x="457200" y="658368"/>
+            <a:ext cx="9326880" cy="640080"/>
+          </a:xfrm>
+          <a:prstGeom prst="rect">
+            <a:avLst/>
+          </a:prstGeom>
+          <a:noFill/>
+          <a:ln/>
+        </p:spPr>
+        <p:txBody>
+          <a:bodyPr wrap="square" lIns="0" tIns="0" rIns="0" bIns="0" rtlCol="0" anchor="ctr"/>
+          <a:lstStyle/>
+          <a:p>
+            <a:pPr indent="0" marL="0">
+              <a:buNone/>
+            </a:pPr>
+            <a:r>
+              <a:rPr lang="en-US" sz="3200" b="1" dirty="0">
+                <a:solidFill>
+                  <a:srgbClr val="00357A"/>
+                </a:solidFill>
+                <a:latin typeface="Poppins" pitchFamily="34" charset="0"/>
+                <a:ea typeface="Poppins" pitchFamily="34" charset="-122"/>
+                <a:cs typeface="Poppins" pitchFamily="34" charset="-120"/>
+              </a:rPr>
+              <a:t>dsarch -RQ  —  How a File Comes Back</a:t>
+            </a:r>
+            <a:endParaRPr lang="en-US" sz="3200" dirty="0"/>
+          </a:p>
+        </p:txBody>
+      </p:sp>
+      <p:sp>
+        <p:nvSpPr>
+          <p:cNvPr id="4" name="Text 2"/>
+          <p:cNvSpPr/>
+          <p:nvPr/>
+        </p:nvSpPr>
+        <p:spPr>
+          <a:xfrm>
+            <a:off x="457200" y="1463040"/>
+            <a:ext cx="11292840" cy="457200"/>
+          </a:xfrm>
+          <a:prstGeom prst="rect">
+            <a:avLst/>
+          </a:prstGeom>
+          <a:noFill/>
+          <a:ln/>
+        </p:spPr>
+        <p:txBody>
+          <a:bodyPr wrap="square" lIns="0" tIns="0" rIns="0" bIns="0" rtlCol="0" anchor="t"/>
+          <a:lstStyle/>
+          <a:p>
+            <a:pPr indent="0" marL="0">
+              <a:lnSpc>
+                <a:spcPct val="110000"/>
+              </a:lnSpc>
+              <a:buNone/>
+            </a:pPr>
+            <a:r>
+              <a:rPr lang="en-US" sz="1450" dirty="0">
+                <a:solidFill>
+                  <a:srgbClr val="00357A"/>
+                </a:solidFill>
+                <a:latin typeface="Poppins" pitchFamily="34" charset="0"/>
+                <a:ea typeface="Poppins" pitchFamily="34" charset="-122"/>
+                <a:cs typeface="Poppins" pitchFamily="34" charset="-120"/>
+              </a:rPr>
+              <a:t>Name the files you want back and dsarch does the rest. The outline below is enough to run a restore; the dsarch guide covers the options in full.</a:t>
+            </a:r>
+            <a:endParaRPr lang="en-US" sz="1450" dirty="0"/>
+          </a:p>
+        </p:txBody>
+      </p:sp>
+      <p:sp>
+        <p:nvSpPr>
+          <p:cNvPr id="5" name="Shape 3"/>
+          <p:cNvSpPr/>
+          <p:nvPr/>
+        </p:nvSpPr>
+        <p:spPr>
+          <a:xfrm>
+            <a:off x="457200" y="2029968"/>
+            <a:ext cx="11292840" cy="566928"/>
+          </a:xfrm>
+          <a:prstGeom prst="roundRect">
+            <a:avLst>
+              <a:gd name="adj" fmla="val 8065"/>
+            </a:avLst>
+          </a:prstGeom>
+          <a:solidFill>
+            <a:srgbClr val="011837"/>
+          </a:solidFill>
+          <a:ln/>
+        </p:spPr>
+      </p:sp>
+      <p:sp>
+        <p:nvSpPr>
+          <p:cNvPr id="6" name="Text 4"/>
+          <p:cNvSpPr/>
+          <p:nvPr/>
+        </p:nvSpPr>
+        <p:spPr>
+          <a:xfrm>
+            <a:off x="585216" y="2029968"/>
+            <a:ext cx="11036808" cy="566928"/>
+          </a:xfrm>
+          <a:prstGeom prst="rect">
+            <a:avLst/>
+          </a:prstGeom>
+          <a:noFill/>
+          <a:ln/>
+        </p:spPr>
+        <p:txBody>
+          <a:bodyPr wrap="square" lIns="0" tIns="0" rIns="0" bIns="0" rtlCol="0" anchor="ctr"/>
+          <a:lstStyle/>
+          <a:p>
+            <a:pPr indent="0" marL="0">
+              <a:lnSpc>
+                <a:spcPct val="100000"/>
+              </a:lnSpc>
+              <a:buNone/>
+            </a:pPr>
+            <a:r>
+              <a:rPr lang="en-US" sz="1250" dirty="0">
+                <a:solidFill>
+                  <a:srgbClr val="0097A7"/>
+                </a:solidFill>
+                <a:latin typeface="Courier New" pitchFamily="34" charset="0"/>
+                <a:ea typeface="Courier New" pitchFamily="34" charset="-122"/>
+                <a:cs typeface="Courier New" pitchFamily="34" charset="-120"/>
+              </a:rPr>
+              <a:t>dsarch &lt;dsid&gt; -RQ -WF &lt;web files&gt;   [-WT &lt;types&gt;]</a:t>
+            </a:r>
+            <a:endParaRPr lang="en-US" sz="1250" dirty="0"/>
+          </a:p>
+          <a:p>
+            <a:pPr indent="0" marL="0">
+              <a:lnSpc>
+                <a:spcPct val="100000"/>
+              </a:lnSpc>
+              <a:buNone/>
+            </a:pPr>
+            <a:r>
+              <a:rPr lang="en-US" sz="1250" dirty="0">
+                <a:solidFill>
+                  <a:srgbClr val="0097A7"/>
+                </a:solidFill>
+                <a:latin typeface="Courier New" pitchFamily="34" charset="0"/>
+                <a:ea typeface="Courier New" pitchFamily="34" charset="-122"/>
+                <a:cs typeface="Courier New" pitchFamily="34" charset="-120"/>
+              </a:rPr>
+              <a:t>dsarch &lt;dsid&gt; -RQ -SF &lt;saved files&gt;  -ST &lt;types&gt;     # or -QF &lt;tar&gt; for a whole tar</a:t>
+            </a:r>
+            <a:endParaRPr lang="en-US" sz="1250" dirty="0"/>
+          </a:p>
+        </p:txBody>
+      </p:sp>
+      <p:sp>
+        <p:nvSpPr>
+          <p:cNvPr id="7" name="Shape 5"/>
+          <p:cNvSpPr/>
+          <p:nvPr/>
+        </p:nvSpPr>
+        <p:spPr>
+          <a:xfrm>
+            <a:off x="457200" y="2761488"/>
+            <a:ext cx="11292840" cy="548640"/>
+          </a:xfrm>
+          <a:prstGeom prst="roundRect">
+            <a:avLst>
+              <a:gd name="adj" fmla="val 11667"/>
+            </a:avLst>
+          </a:prstGeom>
+          <a:solidFill>
+            <a:srgbClr val="DCEBF7"/>
+          </a:solidFill>
+          <a:ln/>
+        </p:spPr>
+      </p:sp>
+      <p:sp>
+        <p:nvSpPr>
+          <p:cNvPr id="8" name="Shape 6"/>
+          <p:cNvSpPr/>
+          <p:nvPr/>
+        </p:nvSpPr>
+        <p:spPr>
+          <a:xfrm>
+            <a:off x="621792" y="2834640"/>
+            <a:ext cx="402336" cy="402336"/>
+          </a:xfrm>
+          <a:prstGeom prst="ellipse">
+            <a:avLst/>
+          </a:prstGeom>
+          <a:solidFill>
+            <a:srgbClr val="0057C2"/>
+          </a:solidFill>
+          <a:ln/>
+        </p:spPr>
+      </p:sp>
+      <p:sp>
+        <p:nvSpPr>
+          <p:cNvPr id="9" name="Text 7"/>
+          <p:cNvSpPr/>
+          <p:nvPr/>
+        </p:nvSpPr>
+        <p:spPr>
+          <a:xfrm>
+            <a:off x="621792" y="2834640"/>
+            <a:ext cx="402336" cy="402336"/>
+          </a:xfrm>
+          <a:prstGeom prst="rect">
+            <a:avLst/>
+          </a:prstGeom>
+          <a:noFill/>
+          <a:ln/>
+        </p:spPr>
+        <p:txBody>
+          <a:bodyPr wrap="square" lIns="0" tIns="0" rIns="0" bIns="0" rtlCol="0" anchor="ctr"/>
+          <a:lstStyle/>
+          <a:p>
+            <a:pPr algn="ctr" indent="0" marL="0">
+              <a:buNone/>
+            </a:pPr>
+            <a:r>
+              <a:rPr lang="en-US" sz="1300" b="1" dirty="0">
+                <a:solidFill>
+                  <a:srgbClr val="FFFFFF"/>
+                </a:solidFill>
+                <a:latin typeface="Poppins" pitchFamily="34" charset="0"/>
+                <a:ea typeface="Poppins" pitchFamily="34" charset="-122"/>
+                <a:cs typeface="Poppins" pitchFamily="34" charset="-120"/>
+              </a:rPr>
+              <a:t>1</a:t>
+            </a:r>
+            <a:endParaRPr lang="en-US" sz="1300" dirty="0"/>
+          </a:p>
+        </p:txBody>
+      </p:sp>
+      <p:sp>
+        <p:nvSpPr>
+          <p:cNvPr id="10" name="Text 8"/>
+          <p:cNvSpPr/>
+          <p:nvPr/>
+        </p:nvSpPr>
+        <p:spPr>
+          <a:xfrm>
+            <a:off x="1170432" y="2761488"/>
+            <a:ext cx="1874520" cy="548640"/>
+          </a:xfrm>
+          <a:prstGeom prst="rect">
+            <a:avLst/>
+          </a:prstGeom>
+          <a:noFill/>
+          <a:ln/>
+        </p:spPr>
+        <p:txBody>
+          <a:bodyPr wrap="square" lIns="0" tIns="0" rIns="0" bIns="0" rtlCol="0" anchor="ctr"/>
+          <a:lstStyle/>
+          <a:p>
+            <a:pPr indent="0" marL="0">
+              <a:buNone/>
+            </a:pPr>
+            <a:r>
+              <a:rPr lang="en-US" sz="1250" b="1" dirty="0">
+                <a:solidFill>
+                  <a:srgbClr val="00357A"/>
+                </a:solidFill>
+                <a:latin typeface="Poppins" pitchFamily="34" charset="0"/>
+                <a:ea typeface="Poppins" pitchFamily="34" charset="-122"/>
+                <a:cs typeface="Poppins" pitchFamily="34" charset="-120"/>
+              </a:rPr>
+              <a:t>Name the files</a:t>
+            </a:r>
+            <a:endParaRPr lang="en-US" sz="1250" dirty="0"/>
+          </a:p>
+        </p:txBody>
+      </p:sp>
+      <p:sp>
+        <p:nvSpPr>
+          <p:cNvPr id="11" name="Text 9"/>
+          <p:cNvSpPr/>
+          <p:nvPr/>
+        </p:nvSpPr>
+        <p:spPr>
+          <a:xfrm>
+            <a:off x="3063240" y="2761488"/>
+            <a:ext cx="8503920" cy="548640"/>
+          </a:xfrm>
+          <a:prstGeom prst="rect">
+            <a:avLst/>
+          </a:prstGeom>
+          <a:noFill/>
+          <a:ln/>
+        </p:spPr>
+        <p:txBody>
+          <a:bodyPr wrap="square" lIns="0" tIns="0" rIns="0" bIns="0" rtlCol="0" anchor="ctr"/>
+          <a:lstStyle/>
+          <a:p>
+            <a:pPr indent="0" marL="0">
+              <a:lnSpc>
+                <a:spcPct val="95000"/>
+              </a:lnSpc>
+              <a:buNone/>
+            </a:pPr>
+            <a:r>
+              <a:rPr lang="en-US" sz="1050" dirty="0">
+                <a:solidFill>
+                  <a:srgbClr val="53565A"/>
+                </a:solidFill>
+                <a:latin typeface="Poppins" pitchFamily="34" charset="0"/>
+                <a:ea typeface="Poppins" pitchFamily="34" charset="-122"/>
+                <a:cs typeface="Poppins" pitchFamily="34" charset="-120"/>
+              </a:rPr>
+              <a:t>-WF for web files, -SF plus -ST for saved files. -QF names a Quasar tar directly, and pulls it down without restoring anything.</a:t>
+            </a:r>
+            <a:endParaRPr lang="en-US" sz="1050" dirty="0"/>
+          </a:p>
+        </p:txBody>
+      </p:sp>
+      <p:sp>
+        <p:nvSpPr>
+          <p:cNvPr id="12" name="Shape 10"/>
+          <p:cNvSpPr/>
+          <p:nvPr/>
+        </p:nvSpPr>
+        <p:spPr>
+          <a:xfrm>
+            <a:off x="457200" y="3383280"/>
+            <a:ext cx="11292840" cy="548640"/>
+          </a:xfrm>
+          <a:prstGeom prst="roundRect">
+            <a:avLst>
+              <a:gd name="adj" fmla="val 11667"/>
+            </a:avLst>
+          </a:prstGeom>
+          <a:solidFill>
+            <a:srgbClr val="DCEBF7"/>
+          </a:solidFill>
+          <a:ln/>
+        </p:spPr>
+      </p:sp>
+      <p:sp>
+        <p:nvSpPr>
+          <p:cNvPr id="13" name="Shape 11"/>
+          <p:cNvSpPr/>
+          <p:nvPr/>
+        </p:nvSpPr>
+        <p:spPr>
+          <a:xfrm>
+            <a:off x="621792" y="3456432"/>
+            <a:ext cx="402336" cy="402336"/>
+          </a:xfrm>
+          <a:prstGeom prst="ellipse">
+            <a:avLst/>
+          </a:prstGeom>
+          <a:solidFill>
+            <a:srgbClr val="0092DB"/>
+          </a:solidFill>
+          <a:ln/>
+        </p:spPr>
+      </p:sp>
+      <p:sp>
+        <p:nvSpPr>
+          <p:cNvPr id="14" name="Text 12"/>
+          <p:cNvSpPr/>
+          <p:nvPr/>
+        </p:nvSpPr>
+        <p:spPr>
+          <a:xfrm>
+            <a:off x="621792" y="3456432"/>
+            <a:ext cx="402336" cy="402336"/>
+          </a:xfrm>
+          <a:prstGeom prst="rect">
+            <a:avLst/>
+          </a:prstGeom>
+          <a:noFill/>
+          <a:ln/>
+        </p:spPr>
+        <p:txBody>
+          <a:bodyPr wrap="square" lIns="0" tIns="0" rIns="0" bIns="0" rtlCol="0" anchor="ctr"/>
+          <a:lstStyle/>
+          <a:p>
+            <a:pPr algn="ctr" indent="0" marL="0">
+              <a:buNone/>
+            </a:pPr>
+            <a:r>
+              <a:rPr lang="en-US" sz="1300" b="1" dirty="0">
+                <a:solidFill>
+                  <a:srgbClr val="FFFFFF"/>
+                </a:solidFill>
+                <a:latin typeface="Poppins" pitchFamily="34" charset="0"/>
+                <a:ea typeface="Poppins" pitchFamily="34" charset="-122"/>
+                <a:cs typeface="Poppins" pitchFamily="34" charset="-120"/>
+              </a:rPr>
+              <a:t>2</a:t>
+            </a:r>
+            <a:endParaRPr lang="en-US" sz="1300" dirty="0"/>
+          </a:p>
+        </p:txBody>
+      </p:sp>
+      <p:sp>
+        <p:nvSpPr>
+          <p:cNvPr id="15" name="Text 13"/>
+          <p:cNvSpPr/>
+          <p:nvPr/>
+        </p:nvSpPr>
+        <p:spPr>
+          <a:xfrm>
+            <a:off x="1170432" y="3383280"/>
+            <a:ext cx="1874520" cy="548640"/>
+          </a:xfrm>
+          <a:prstGeom prst="rect">
+            <a:avLst/>
+          </a:prstGeom>
+          <a:noFill/>
+          <a:ln/>
+        </p:spPr>
+        <p:txBody>
+          <a:bodyPr wrap="square" lIns="0" tIns="0" rIns="0" bIns="0" rtlCol="0" anchor="ctr"/>
+          <a:lstStyle/>
+          <a:p>
+            <a:pPr indent="0" marL="0">
+              <a:buNone/>
+            </a:pPr>
+            <a:r>
+              <a:rPr lang="en-US" sz="1250" b="1" dirty="0">
+                <a:solidFill>
+                  <a:srgbClr val="00357A"/>
+                </a:solidFill>
+                <a:latin typeface="Poppins" pitchFamily="34" charset="0"/>
+                <a:ea typeface="Poppins" pitchFamily="34" charset="-122"/>
+                <a:cs typeface="Poppins" pitchFamily="34" charset="-120"/>
+              </a:rPr>
+              <a:t>Find the tar</a:t>
+            </a:r>
+            <a:endParaRPr lang="en-US" sz="1250" dirty="0"/>
+          </a:p>
+        </p:txBody>
+      </p:sp>
+      <p:sp>
+        <p:nvSpPr>
+          <p:cNvPr id="16" name="Text 14"/>
+          <p:cNvSpPr/>
+          <p:nvPr/>
+        </p:nvSpPr>
+        <p:spPr>
+          <a:xfrm>
+            <a:off x="3063240" y="3383280"/>
+            <a:ext cx="8503920" cy="548640"/>
+          </a:xfrm>
+          <a:prstGeom prst="rect">
+            <a:avLst/>
+          </a:prstGeom>
+          <a:noFill/>
+          <a:ln/>
+        </p:spPr>
+        <p:txBody>
+          <a:bodyPr wrap="square" lIns="0" tIns="0" rIns="0" bIns="0" rtlCol="0" anchor="ctr"/>
+          <a:lstStyle/>
+          <a:p>
+            <a:pPr indent="0" marL="0">
+              <a:lnSpc>
+                <a:spcPct val="95000"/>
+              </a:lnSpc>
+              <a:buNone/>
+            </a:pPr>
+            <a:r>
+              <a:rPr lang="en-US" sz="1050" dirty="0">
+                <a:solidFill>
+                  <a:srgbClr val="53565A"/>
+                </a:solidFill>
+                <a:latin typeface="Poppins" pitchFamily="34" charset="0"/>
+                <a:ea typeface="Poppins" pitchFamily="34" charset="-122"/>
+                <a:cs typeface="Poppins" pitchFamily="34" charset="-120"/>
+              </a:rPr>
+              <a:t>Each wfile and sfile record carries the bid of the backup it went into, so one lookup gives the tar name, its end point and its path.</a:t>
+            </a:r>
+            <a:endParaRPr lang="en-US" sz="1050" dirty="0"/>
+          </a:p>
+        </p:txBody>
+      </p:sp>
+      <p:sp>
+        <p:nvSpPr>
+          <p:cNvPr id="17" name="Shape 15"/>
+          <p:cNvSpPr/>
+          <p:nvPr/>
+        </p:nvSpPr>
+        <p:spPr>
+          <a:xfrm>
+            <a:off x="457200" y="4005072"/>
+            <a:ext cx="11292840" cy="548640"/>
+          </a:xfrm>
+          <a:prstGeom prst="roundRect">
+            <a:avLst>
+              <a:gd name="adj" fmla="val 11667"/>
+            </a:avLst>
+          </a:prstGeom>
+          <a:solidFill>
+            <a:srgbClr val="DCEBF7"/>
+          </a:solidFill>
+          <a:ln/>
+        </p:spPr>
+      </p:sp>
+      <p:sp>
+        <p:nvSpPr>
+          <p:cNvPr id="18" name="Shape 16"/>
+          <p:cNvSpPr/>
+          <p:nvPr/>
+        </p:nvSpPr>
+        <p:spPr>
+          <a:xfrm>
+            <a:off x="621792" y="4078224"/>
+            <a:ext cx="402336" cy="402336"/>
+          </a:xfrm>
+          <a:prstGeom prst="ellipse">
+            <a:avLst/>
+          </a:prstGeom>
+          <a:solidFill>
+            <a:srgbClr val="0097A7"/>
+          </a:solidFill>
+          <a:ln/>
+        </p:spPr>
+      </p:sp>
+      <p:sp>
+        <p:nvSpPr>
+          <p:cNvPr id="19" name="Text 17"/>
+          <p:cNvSpPr/>
+          <p:nvPr/>
+        </p:nvSpPr>
+        <p:spPr>
+          <a:xfrm>
+            <a:off x="621792" y="4078224"/>
+            <a:ext cx="402336" cy="402336"/>
+          </a:xfrm>
+          <a:prstGeom prst="rect">
+            <a:avLst/>
+          </a:prstGeom>
+          <a:noFill/>
+          <a:ln/>
+        </p:spPr>
+        <p:txBody>
+          <a:bodyPr wrap="square" lIns="0" tIns="0" rIns="0" bIns="0" rtlCol="0" anchor="ctr"/>
+          <a:lstStyle/>
+          <a:p>
+            <a:pPr algn="ctr" indent="0" marL="0">
+              <a:buNone/>
+            </a:pPr>
+            <a:r>
+              <a:rPr lang="en-US" sz="1300" b="1" dirty="0">
+                <a:solidFill>
+                  <a:srgbClr val="FFFFFF"/>
+                </a:solidFill>
+                <a:latin typeface="Poppins" pitchFamily="34" charset="0"/>
+                <a:ea typeface="Poppins" pitchFamily="34" charset="-122"/>
+                <a:cs typeface="Poppins" pitchFamily="34" charset="-120"/>
+              </a:rPr>
+              <a:t>3</a:t>
+            </a:r>
+            <a:endParaRPr lang="en-US" sz="1300" dirty="0"/>
+          </a:p>
+        </p:txBody>
+      </p:sp>
+      <p:sp>
+        <p:nvSpPr>
+          <p:cNvPr id="20" name="Text 18"/>
+          <p:cNvSpPr/>
+          <p:nvPr/>
+        </p:nvSpPr>
+        <p:spPr>
+          <a:xfrm>
+            <a:off x="1170432" y="4005072"/>
+            <a:ext cx="1874520" cy="548640"/>
+          </a:xfrm>
+          <a:prstGeom prst="rect">
+            <a:avLst/>
+          </a:prstGeom>
+          <a:noFill/>
+          <a:ln/>
+        </p:spPr>
+        <p:txBody>
+          <a:bodyPr wrap="square" lIns="0" tIns="0" rIns="0" bIns="0" rtlCol="0" anchor="ctr"/>
+          <a:lstStyle/>
+          <a:p>
+            <a:pPr indent="0" marL="0">
+              <a:buNone/>
+            </a:pPr>
+            <a:r>
+              <a:rPr lang="en-US" sz="1250" b="1" dirty="0">
+                <a:solidFill>
+                  <a:srgbClr val="00357A"/>
+                </a:solidFill>
+                <a:latin typeface="Poppins" pitchFamily="34" charset="0"/>
+                <a:ea typeface="Poppins" pitchFamily="34" charset="-122"/>
+                <a:cs typeface="Poppins" pitchFamily="34" charset="-120"/>
+              </a:rPr>
+              <a:t>Fetch it once</a:t>
+            </a:r>
+            <a:endParaRPr lang="en-US" sz="1250" dirty="0"/>
+          </a:p>
+        </p:txBody>
+      </p:sp>
+      <p:sp>
+        <p:nvSpPr>
+          <p:cNvPr id="21" name="Text 19"/>
+          <p:cNvSpPr/>
+          <p:nvPr/>
+        </p:nvSpPr>
+        <p:spPr>
+          <a:xfrm>
+            <a:off x="3063240" y="4005072"/>
+            <a:ext cx="8503920" cy="548640"/>
+          </a:xfrm>
+          <a:prstGeom prst="rect">
+            <a:avLst/>
+          </a:prstGeom>
+          <a:noFill/>
+          <a:ln/>
+        </p:spPr>
+        <p:txBody>
+          <a:bodyPr wrap="square" lIns="0" tIns="0" rIns="0" bIns="0" rtlCol="0" anchor="ctr"/>
+          <a:lstStyle/>
+          <a:p>
+            <a:pPr indent="0" marL="0">
+              <a:lnSpc>
+                <a:spcPct val="95000"/>
+              </a:lnSpc>
+              <a:buNone/>
+            </a:pPr>
+            <a:r>
+              <a:rPr lang="en-US" sz="1050" dirty="0">
+                <a:solidFill>
+                  <a:srgbClr val="53565A"/>
+                </a:solidFill>
+                <a:latin typeface="Poppins" pitchFamily="34" charset="0"/>
+                <a:ea typeface="Poppins" pitchFamily="34" charset="-122"/>
+                <a:cs typeface="Poppins" pitchFamily="34" charset="-120"/>
+              </a:rPr>
+              <a:t>The tar is transferred from gdex-quasar into the dataset work area. A tar already sitting there is reused, so several files out of one tar cost one transfer.</a:t>
+            </a:r>
+            <a:endParaRPr lang="en-US" sz="1050" dirty="0"/>
+          </a:p>
+        </p:txBody>
+      </p:sp>
+      <p:sp>
+        <p:nvSpPr>
+          <p:cNvPr id="22" name="Shape 20"/>
+          <p:cNvSpPr/>
+          <p:nvPr/>
+        </p:nvSpPr>
+        <p:spPr>
+          <a:xfrm>
+            <a:off x="457200" y="4626864"/>
+            <a:ext cx="11292840" cy="548640"/>
+          </a:xfrm>
+          <a:prstGeom prst="roundRect">
+            <a:avLst>
+              <a:gd name="adj" fmla="val 11667"/>
+            </a:avLst>
+          </a:prstGeom>
+          <a:solidFill>
+            <a:srgbClr val="DCEBF7"/>
+          </a:solidFill>
+          <a:ln/>
+        </p:spPr>
+      </p:sp>
+      <p:sp>
+        <p:nvSpPr>
+          <p:cNvPr id="23" name="Shape 21"/>
+          <p:cNvSpPr/>
+          <p:nvPr/>
+        </p:nvSpPr>
+        <p:spPr>
+          <a:xfrm>
+            <a:off x="621792" y="4700016"/>
+            <a:ext cx="402336" cy="402336"/>
+          </a:xfrm>
+          <a:prstGeom prst="ellipse">
+            <a:avLst/>
+          </a:prstGeom>
+          <a:solidFill>
+            <a:srgbClr val="C25E00"/>
+          </a:solidFill>
+          <a:ln/>
+        </p:spPr>
+      </p:sp>
+      <p:sp>
+        <p:nvSpPr>
+          <p:cNvPr id="24" name="Text 22"/>
+          <p:cNvSpPr/>
+          <p:nvPr/>
+        </p:nvSpPr>
+        <p:spPr>
+          <a:xfrm>
+            <a:off x="621792" y="4700016"/>
+            <a:ext cx="402336" cy="402336"/>
+          </a:xfrm>
+          <a:prstGeom prst="rect">
+            <a:avLst/>
+          </a:prstGeom>
+          <a:noFill/>
+          <a:ln/>
+        </p:spPr>
+        <p:txBody>
+          <a:bodyPr wrap="square" lIns="0" tIns="0" rIns="0" bIns="0" rtlCol="0" anchor="ctr"/>
+          <a:lstStyle/>
+          <a:p>
+            <a:pPr algn="ctr" indent="0" marL="0">
+              <a:buNone/>
+            </a:pPr>
+            <a:r>
+              <a:rPr lang="en-US" sz="1300" b="1" dirty="0">
+                <a:solidFill>
+                  <a:srgbClr val="FFFFFF"/>
+                </a:solidFill>
+                <a:latin typeface="Poppins" pitchFamily="34" charset="0"/>
+                <a:ea typeface="Poppins" pitchFamily="34" charset="-122"/>
+                <a:cs typeface="Poppins" pitchFamily="34" charset="-120"/>
+              </a:rPr>
+              <a:t>4</a:t>
+            </a:r>
+            <a:endParaRPr lang="en-US" sz="1300" dirty="0"/>
+          </a:p>
+        </p:txBody>
+      </p:sp>
+      <p:sp>
+        <p:nvSpPr>
+          <p:cNvPr id="25" name="Text 23"/>
+          <p:cNvSpPr/>
+          <p:nvPr/>
+        </p:nvSpPr>
+        <p:spPr>
+          <a:xfrm>
+            <a:off x="1170432" y="4626864"/>
+            <a:ext cx="1874520" cy="548640"/>
+          </a:xfrm>
+          <a:prstGeom prst="rect">
+            <a:avLst/>
+          </a:prstGeom>
+          <a:noFill/>
+          <a:ln/>
+        </p:spPr>
+        <p:txBody>
+          <a:bodyPr wrap="square" lIns="0" tIns="0" rIns="0" bIns="0" rtlCol="0" anchor="ctr"/>
+          <a:lstStyle/>
+          <a:p>
+            <a:pPr indent="0" marL="0">
+              <a:buNone/>
+            </a:pPr>
+            <a:r>
+              <a:rPr lang="en-US" sz="1250" b="1" dirty="0">
+                <a:solidFill>
+                  <a:srgbClr val="00357A"/>
+                </a:solidFill>
+                <a:latin typeface="Poppins" pitchFamily="34" charset="0"/>
+                <a:ea typeface="Poppins" pitchFamily="34" charset="-122"/>
+                <a:cs typeface="Poppins" pitchFamily="34" charset="-120"/>
+              </a:rPr>
+              <a:t>Unpack what was asked</a:t>
+            </a:r>
+            <a:endParaRPr lang="en-US" sz="1250" dirty="0"/>
+          </a:p>
+        </p:txBody>
+      </p:sp>
+      <p:sp>
+        <p:nvSpPr>
+          <p:cNvPr id="26" name="Text 24"/>
+          <p:cNvSpPr/>
+          <p:nvPr/>
+        </p:nvSpPr>
+        <p:spPr>
+          <a:xfrm>
+            <a:off x="3063240" y="4626864"/>
+            <a:ext cx="8503920" cy="548640"/>
+          </a:xfrm>
+          <a:prstGeom prst="rect">
+            <a:avLst/>
+          </a:prstGeom>
+          <a:noFill/>
+          <a:ln/>
+        </p:spPr>
+        <p:txBody>
+          <a:bodyPr wrap="square" lIns="0" tIns="0" rIns="0" bIns="0" rtlCol="0" anchor="ctr"/>
+          <a:lstStyle/>
+          <a:p>
+            <a:pPr indent="0" marL="0">
+              <a:lnSpc>
+                <a:spcPct val="95000"/>
+              </a:lnSpc>
+              <a:buNone/>
+            </a:pPr>
+            <a:r>
+              <a:rPr lang="en-US" sz="1050" dirty="0">
+                <a:solidFill>
+                  <a:srgbClr val="53565A"/>
+                </a:solidFill>
+                <a:latin typeface="Poppins" pitchFamily="34" charset="0"/>
+                <a:ea typeface="Poppins" pitchFamily="34" charset="-122"/>
+                <a:cs typeface="Poppins" pitchFamily="34" charset="-120"/>
+              </a:rPr>
+              <a:t>The member list in the bfile note locates each file inside the tar — including any later rename — and only those members are extracted.</a:t>
+            </a:r>
+            <a:endParaRPr lang="en-US" sz="1050" dirty="0"/>
+          </a:p>
+        </p:txBody>
+      </p:sp>
+      <p:sp>
+        <p:nvSpPr>
+          <p:cNvPr id="27" name="Shape 25"/>
+          <p:cNvSpPr/>
+          <p:nvPr/>
+        </p:nvSpPr>
+        <p:spPr>
+          <a:xfrm>
+            <a:off x="457200" y="5248656"/>
+            <a:ext cx="11292840" cy="548640"/>
+          </a:xfrm>
+          <a:prstGeom prst="roundRect">
+            <a:avLst>
+              <a:gd name="adj" fmla="val 11667"/>
+            </a:avLst>
+          </a:prstGeom>
+          <a:solidFill>
+            <a:srgbClr val="DCEBF7"/>
+          </a:solidFill>
+          <a:ln/>
+        </p:spPr>
+      </p:sp>
+      <p:sp>
+        <p:nvSpPr>
+          <p:cNvPr id="28" name="Shape 26"/>
+          <p:cNvSpPr/>
+          <p:nvPr/>
+        </p:nvSpPr>
+        <p:spPr>
+          <a:xfrm>
+            <a:off x="621792" y="5321808"/>
+            <a:ext cx="402336" cy="402336"/>
+          </a:xfrm>
+          <a:prstGeom prst="ellipse">
+            <a:avLst/>
+          </a:prstGeom>
+          <a:solidFill>
+            <a:srgbClr val="0057C2"/>
+          </a:solidFill>
+          <a:ln/>
+        </p:spPr>
+      </p:sp>
+      <p:sp>
+        <p:nvSpPr>
+          <p:cNvPr id="29" name="Text 27"/>
+          <p:cNvSpPr/>
+          <p:nvPr/>
+        </p:nvSpPr>
+        <p:spPr>
+          <a:xfrm>
+            <a:off x="621792" y="5321808"/>
+            <a:ext cx="402336" cy="402336"/>
+          </a:xfrm>
+          <a:prstGeom prst="rect">
+            <a:avLst/>
+          </a:prstGeom>
+          <a:noFill/>
+          <a:ln/>
+        </p:spPr>
+        <p:txBody>
+          <a:bodyPr wrap="square" lIns="0" tIns="0" rIns="0" bIns="0" rtlCol="0" anchor="ctr"/>
+          <a:lstStyle/>
+          <a:p>
+            <a:pPr algn="ctr" indent="0" marL="0">
+              <a:buNone/>
+            </a:pPr>
+            <a:r>
+              <a:rPr lang="en-US" sz="1300" b="1" dirty="0">
+                <a:solidFill>
+                  <a:srgbClr val="FFFFFF"/>
+                </a:solidFill>
+                <a:latin typeface="Poppins" pitchFamily="34" charset="0"/>
+                <a:ea typeface="Poppins" pitchFamily="34" charset="-122"/>
+                <a:cs typeface="Poppins" pitchFamily="34" charset="-120"/>
+              </a:rPr>
+              <a:t>5</a:t>
+            </a:r>
+            <a:endParaRPr lang="en-US" sz="1300" dirty="0"/>
+          </a:p>
+        </p:txBody>
+      </p:sp>
+      <p:sp>
+        <p:nvSpPr>
+          <p:cNvPr id="30" name="Text 28"/>
+          <p:cNvSpPr/>
+          <p:nvPr/>
+        </p:nvSpPr>
+        <p:spPr>
+          <a:xfrm>
+            <a:off x="1170432" y="5248656"/>
+            <a:ext cx="1874520" cy="548640"/>
+          </a:xfrm>
+          <a:prstGeom prst="rect">
+            <a:avLst/>
+          </a:prstGeom>
+          <a:noFill/>
+          <a:ln/>
+        </p:spPr>
+        <p:txBody>
+          <a:bodyPr wrap="square" lIns="0" tIns="0" rIns="0" bIns="0" rtlCol="0" anchor="ctr"/>
+          <a:lstStyle/>
+          <a:p>
+            <a:pPr indent="0" marL="0">
+              <a:buNone/>
+            </a:pPr>
+            <a:r>
+              <a:rPr lang="en-US" sz="1250" b="1" dirty="0">
+                <a:solidFill>
+                  <a:srgbClr val="00357A"/>
+                </a:solidFill>
+                <a:latin typeface="Poppins" pitchFamily="34" charset="0"/>
+                <a:ea typeface="Poppins" pitchFamily="34" charset="-122"/>
+                <a:cs typeface="Poppins" pitchFamily="34" charset="-120"/>
+              </a:rPr>
+              <a:t>Put it back</a:t>
+            </a:r>
+            <a:endParaRPr lang="en-US" sz="1250" dirty="0"/>
+          </a:p>
+        </p:txBody>
+      </p:sp>
+      <p:sp>
+        <p:nvSpPr>
+          <p:cNvPr id="31" name="Text 29"/>
+          <p:cNvSpPr/>
+          <p:nvPr/>
+        </p:nvSpPr>
+        <p:spPr>
+          <a:xfrm>
+            <a:off x="3063240" y="5248656"/>
+            <a:ext cx="8503920" cy="548640"/>
+          </a:xfrm>
+          <a:prstGeom prst="rect">
+            <a:avLst/>
+          </a:prstGeom>
+          <a:noFill/>
+          <a:ln/>
+        </p:spPr>
+        <p:txBody>
+          <a:bodyPr wrap="square" lIns="0" tIns="0" rIns="0" bIns="0" rtlCol="0" anchor="ctr"/>
+          <a:lstStyle/>
+          <a:p>
+            <a:pPr indent="0" marL="0">
+              <a:lnSpc>
+                <a:spcPct val="95000"/>
+              </a:lnSpc>
+              <a:buNone/>
+            </a:pPr>
+            <a:r>
+              <a:rPr lang="en-US" sz="1050" dirty="0">
+                <a:solidFill>
+                  <a:srgbClr val="53565A"/>
+                </a:solidFill>
+                <a:latin typeface="Poppins" pitchFamily="34" charset="0"/>
+                <a:ea typeface="Poppins" pitchFamily="34" charset="-122"/>
+                <a:cs typeface="Poppins" pitchFamily="34" charset="-120"/>
+              </a:rPr>
+              <a:t>Web files return to the dataset data tree or the object store, saved files to decsdata. Files still present on GDEX are left untouched.</a:t>
+            </a:r>
+            <a:endParaRPr lang="en-US" sz="1050" dirty="0"/>
+          </a:p>
+        </p:txBody>
+      </p:sp>
+      <p:sp>
+        <p:nvSpPr>
+          <p:cNvPr id="32" name="Shape 30"/>
+          <p:cNvSpPr/>
+          <p:nvPr/>
+        </p:nvSpPr>
+        <p:spPr>
+          <a:xfrm>
+            <a:off x="457200" y="5907024"/>
+            <a:ext cx="11292840" cy="502920"/>
+          </a:xfrm>
+          <a:prstGeom prst="roundRect">
+            <a:avLst>
+              <a:gd name="adj" fmla="val 14545"/>
+            </a:avLst>
+          </a:prstGeom>
+          <a:solidFill>
+            <a:srgbClr val="011837"/>
+          </a:solidFill>
+          <a:ln/>
+        </p:spPr>
+      </p:sp>
+      <p:sp>
+        <p:nvSpPr>
+          <p:cNvPr id="33" name="Text 31"/>
+          <p:cNvSpPr/>
+          <p:nvPr/>
+        </p:nvSpPr>
+        <p:spPr>
+          <a:xfrm>
+            <a:off x="658368" y="5907024"/>
+            <a:ext cx="10881360" cy="502920"/>
+          </a:xfrm>
+          <a:prstGeom prst="rect">
+            <a:avLst/>
+          </a:prstGeom>
+          <a:noFill/>
+          <a:ln/>
+        </p:spPr>
+        <p:txBody>
+          <a:bodyPr wrap="square" lIns="0" tIns="0" rIns="0" bIns="0" rtlCol="0" anchor="ctr"/>
+          <a:lstStyle/>
+          <a:p>
+            <a:pPr indent="0" marL="0">
+              <a:buNone/>
+            </a:pPr>
+            <a:r>
+              <a:rPr lang="en-US" sz="1150" b="1" dirty="0">
+                <a:solidFill>
+                  <a:srgbClr val="42C0FF"/>
+                </a:solidFill>
+                <a:latin typeface="Poppins" pitchFamily="34" charset="0"/>
+                <a:ea typeface="Poppins" pitchFamily="34" charset="-122"/>
+                <a:cs typeface="Poppins" pitchFamily="34" charset="-120"/>
+              </a:rPr>
+              <a:t>Restores are safe to repeat.  </a:t>
+            </a:r>
+            <a:pPr indent="0" marL="0">
+              <a:buNone/>
+            </a:pPr>
+            <a:r>
+              <a:rPr lang="en-US" sz="1150" dirty="0">
+                <a:solidFill>
+                  <a:srgbClr val="C3D7EE"/>
+                </a:solidFill>
+                <a:latin typeface="Poppins" pitchFamily="34" charset="0"/>
+                <a:ea typeface="Poppins" pitchFamily="34" charset="-122"/>
+                <a:cs typeface="Poppins" pitchFamily="34" charset="-120"/>
+              </a:rPr>
+              <a:t>Anything already on GDEX is skipped, and each restored file is size checked against its GDEXDB record.</a:t>
+            </a:r>
+            <a:endParaRPr lang="en-US" sz="1150" dirty="0"/>
+          </a:p>
+        </p:txBody>
+      </p:sp>
+      <p:sp>
+        <p:nvSpPr>
+          <p:cNvPr id="34" name="Text 32"/>
           <p:cNvSpPr/>
           <p:nvPr/>
         </p:nvSpPr>
@@ -28385,7 +29484,7 @@
             <a:r>
               <a:rPr lang="en-US" sz="950" b="1" dirty="0">
                 <a:solidFill>
-                  <a:srgbClr val="FFFFFF"/>
+                  <a:srgbClr val="00357A"/>
                 </a:solidFill>
                 <a:latin typeface="Poppins" pitchFamily="34" charset="0"/>
                 <a:ea typeface="Poppins" pitchFamily="34" charset="-122"/>
@@ -28399,30 +29498,7 @@
       </p:sp>
       <p:sp>
         <p:nvSpPr>
-          <p:cNvPr id="6" name="Shape 1"/>
-          <p:cNvSpPr/>
-          <p:nvPr/>
-        </p:nvSpPr>
-        <p:spPr>
-          <a:xfrm>
-            <a:off x="612648" y="6437376"/>
-            <a:ext cx="0" cy="201168"/>
-          </a:xfrm>
-          <a:prstGeom prst="line">
-            <a:avLst/>
-          </a:prstGeom>
-          <a:noFill/>
-          <a:ln w="9525">
-            <a:solidFill>
-              <a:srgbClr val="FFFFFF"/>
-            </a:solidFill>
-            <a:prstDash val="solid"/>
-          </a:ln>
-        </p:spPr>
-      </p:sp>
-      <p:sp>
-        <p:nvSpPr>
-          <p:cNvPr id="7" name="Text 2"/>
+          <p:cNvPr id="35" name="Text 33"/>
           <p:cNvSpPr/>
           <p:nvPr/>
         </p:nvSpPr>
@@ -28447,7 +29523,7 @@
             <a:r>
               <a:rPr lang="en-US" sz="950" b="1" dirty="0">
                 <a:solidFill>
-                  <a:srgbClr val="FFFFFF"/>
+                  <a:srgbClr val="00357A"/>
                 </a:solidFill>
                 <a:latin typeface="Poppins" pitchFamily="34" charset="0"/>
                 <a:ea typeface="Poppins" pitchFamily="34" charset="-122"/>
@@ -28456,1086 +29532,6 @@
               <a:t>DSQUASAR  •  QUASAR BACKUP GUIDE</a:t>
             </a:r>
             <a:endParaRPr lang="en-US" sz="950" dirty="0"/>
-          </a:p>
-        </p:txBody>
-      </p:sp>
-      <p:sp>
-        <p:nvSpPr>
-          <p:cNvPr id="8" name="Text 3"/>
-          <p:cNvSpPr/>
-          <p:nvPr/>
-        </p:nvSpPr>
-        <p:spPr>
-          <a:xfrm>
-            <a:off x="1527048" y="1060704"/>
-            <a:ext cx="7315200" cy="320040"/>
-          </a:xfrm>
-          <a:prstGeom prst="rect">
-            <a:avLst/>
-          </a:prstGeom>
-          <a:noFill/>
-          <a:ln/>
-        </p:spPr>
-        <p:txBody>
-          <a:bodyPr wrap="square" lIns="0" tIns="0" rIns="0" bIns="0" rtlCol="0" anchor="ctr"/>
-          <a:lstStyle/>
-          <a:p>
-            <a:pPr indent="0" marL="0">
-              <a:buNone/>
-            </a:pPr>
-            <a:r>
-              <a:rPr lang="en-US" sz="1300" b="1" spc="200" kern="0" dirty="0">
-                <a:solidFill>
-                  <a:srgbClr val="42C0FF"/>
-                </a:solidFill>
-                <a:latin typeface="Poppins" pitchFamily="34" charset="0"/>
-                <a:ea typeface="Poppins" pitchFamily="34" charset="-122"/>
-                <a:cs typeface="Poppins" pitchFamily="34" charset="-120"/>
-              </a:rPr>
-              <a:t>RECAP</a:t>
-            </a:r>
-            <a:endParaRPr lang="en-US" sz="1300" dirty="0"/>
-          </a:p>
-        </p:txBody>
-      </p:sp>
-      <p:sp>
-        <p:nvSpPr>
-          <p:cNvPr id="9" name="Text 4"/>
-          <p:cNvSpPr/>
-          <p:nvPr/>
-        </p:nvSpPr>
-        <p:spPr>
-          <a:xfrm>
-            <a:off x="1527048" y="1408176"/>
-            <a:ext cx="9144000" cy="731520"/>
-          </a:xfrm>
-          <a:prstGeom prst="rect">
-            <a:avLst/>
-          </a:prstGeom>
-          <a:noFill/>
-          <a:ln/>
-        </p:spPr>
-        <p:txBody>
-          <a:bodyPr wrap="square" lIns="0" tIns="0" rIns="0" bIns="0" rtlCol="0" anchor="ctr"/>
-          <a:lstStyle/>
-          <a:p>
-            <a:pPr indent="0" marL="0">
-              <a:buNone/>
-            </a:pPr>
-            <a:r>
-              <a:rPr lang="en-US" sz="4000" b="1" dirty="0">
-                <a:solidFill>
-                  <a:srgbClr val="FFFFFF"/>
-                </a:solidFill>
-                <a:latin typeface="Poppins" pitchFamily="34" charset="0"/>
-                <a:ea typeface="Poppins" pitchFamily="34" charset="-122"/>
-                <a:cs typeface="Poppins" pitchFamily="34" charset="-120"/>
-              </a:rPr>
-              <a:t>Six Things Worth Remembering</a:t>
-            </a:r>
-            <a:endParaRPr lang="en-US" sz="4000" dirty="0"/>
-          </a:p>
-        </p:txBody>
-      </p:sp>
-      <p:sp>
-        <p:nvSpPr>
-          <p:cNvPr id="10" name="Shape 5"/>
-          <p:cNvSpPr/>
-          <p:nvPr/>
-        </p:nvSpPr>
-        <p:spPr>
-          <a:xfrm>
-            <a:off x="822960" y="2450592"/>
-            <a:ext cx="5120640" cy="1170432"/>
-          </a:xfrm>
-          <a:prstGeom prst="roundRect">
-            <a:avLst>
-              <a:gd name="adj" fmla="val 7813"/>
-            </a:avLst>
-          </a:prstGeom>
-          <a:solidFill>
-            <a:srgbClr val="00357A"/>
-          </a:solidFill>
-          <a:ln w="12700">
-            <a:solidFill>
-              <a:srgbClr val="2C6FB8"/>
-            </a:solidFill>
-            <a:prstDash val="solid"/>
-          </a:ln>
-        </p:spPr>
-      </p:sp>
-      <p:sp>
-        <p:nvSpPr>
-          <p:cNvPr id="11" name="Shape 6"/>
-          <p:cNvSpPr/>
-          <p:nvPr/>
-        </p:nvSpPr>
-        <p:spPr>
-          <a:xfrm>
-            <a:off x="1024128" y="2633472"/>
-            <a:ext cx="402336" cy="402336"/>
-          </a:xfrm>
-          <a:prstGeom prst="ellipse">
-            <a:avLst/>
-          </a:prstGeom>
-          <a:solidFill>
-            <a:srgbClr val="42C0FF"/>
-          </a:solidFill>
-          <a:ln/>
-        </p:spPr>
-      </p:sp>
-      <p:sp>
-        <p:nvSpPr>
-          <p:cNvPr id="12" name="Text 7"/>
-          <p:cNvSpPr/>
-          <p:nvPr/>
-        </p:nvSpPr>
-        <p:spPr>
-          <a:xfrm>
-            <a:off x="1024128" y="2633472"/>
-            <a:ext cx="402336" cy="402336"/>
-          </a:xfrm>
-          <a:prstGeom prst="rect">
-            <a:avLst/>
-          </a:prstGeom>
-          <a:noFill/>
-          <a:ln/>
-        </p:spPr>
-        <p:txBody>
-          <a:bodyPr wrap="square" lIns="0" tIns="0" rIns="0" bIns="0" rtlCol="0" anchor="ctr"/>
-          <a:lstStyle/>
-          <a:p>
-            <a:pPr algn="ctr" indent="0" marL="0">
-              <a:buNone/>
-            </a:pPr>
-            <a:r>
-              <a:rPr lang="en-US" sz="1400" b="1" dirty="0">
-                <a:solidFill>
-                  <a:srgbClr val="00357A"/>
-                </a:solidFill>
-                <a:latin typeface="Poppins" pitchFamily="34" charset="0"/>
-                <a:ea typeface="Poppins" pitchFamily="34" charset="-122"/>
-                <a:cs typeface="Poppins" pitchFamily="34" charset="-120"/>
-              </a:rPr>
-              <a:t>1</a:t>
-            </a:r>
-            <a:endParaRPr lang="en-US" sz="1400" dirty="0"/>
-          </a:p>
-        </p:txBody>
-      </p:sp>
-      <p:sp>
-        <p:nvSpPr>
-          <p:cNvPr id="13" name="Text 8"/>
-          <p:cNvSpPr/>
-          <p:nvPr/>
-        </p:nvSpPr>
-        <p:spPr>
-          <a:xfrm>
-            <a:off x="1536192" y="2578608"/>
-            <a:ext cx="4206240" cy="347472"/>
-          </a:xfrm>
-          <a:prstGeom prst="rect">
-            <a:avLst/>
-          </a:prstGeom>
-          <a:noFill/>
-          <a:ln/>
-        </p:spPr>
-        <p:txBody>
-          <a:bodyPr wrap="square" lIns="0" tIns="0" rIns="0" bIns="0" rtlCol="0" anchor="ctr"/>
-          <a:lstStyle/>
-          <a:p>
-            <a:pPr indent="0" marL="0">
-              <a:buNone/>
-            </a:pPr>
-            <a:r>
-              <a:rPr lang="en-US" sz="1300" b="1" dirty="0">
-                <a:solidFill>
-                  <a:srgbClr val="42C0FF"/>
-                </a:solidFill>
-                <a:latin typeface="Poppins" pitchFamily="34" charset="0"/>
-                <a:ea typeface="Poppins" pitchFamily="34" charset="-122"/>
-                <a:cs typeface="Poppins" pitchFamily="34" charset="-120"/>
-              </a:rPr>
-              <a:t>dataset.backflag enrolls</a:t>
-            </a:r>
-            <a:endParaRPr lang="en-US" sz="1300" dirty="0"/>
-          </a:p>
-        </p:txBody>
-      </p:sp>
-      <p:sp>
-        <p:nvSpPr>
-          <p:cNvPr id="14" name="Text 9"/>
-          <p:cNvSpPr/>
-          <p:nvPr/>
-        </p:nvSpPr>
-        <p:spPr>
-          <a:xfrm>
-            <a:off x="1536192" y="2944368"/>
-            <a:ext cx="4206240" cy="585216"/>
-          </a:xfrm>
-          <a:prstGeom prst="rect">
-            <a:avLst/>
-          </a:prstGeom>
-          <a:noFill/>
-          <a:ln/>
-        </p:spPr>
-        <p:txBody>
-          <a:bodyPr wrap="square" lIns="0" tIns="0" rIns="0" bIns="0" rtlCol="0" anchor="t"/>
-          <a:lstStyle/>
-          <a:p>
-            <a:pPr indent="0" marL="0">
-              <a:lnSpc>
-                <a:spcPct val="105000"/>
-              </a:lnSpc>
-              <a:buNone/>
-            </a:pPr>
-            <a:r>
-              <a:rPr lang="en-US" sz="1050" dirty="0">
-                <a:solidFill>
-                  <a:srgbClr val="D5E8FA"/>
-                </a:solidFill>
-                <a:latin typeface="Poppins" pitchFamily="34" charset="0"/>
-                <a:ea typeface="Poppins" pitchFamily="34" charset="-122"/>
-                <a:cs typeface="Poppins" pitchFamily="34" charset="-120"/>
-              </a:rPr>
-              <a:t>Setting that one field puts a dataset under backup; dsgroup.backflag refines it. -t narrows a run, it does not override a flag.</a:t>
-            </a:r>
-            <a:endParaRPr lang="en-US" sz="1050" dirty="0"/>
-          </a:p>
-        </p:txBody>
-      </p:sp>
-      <p:sp>
-        <p:nvSpPr>
-          <p:cNvPr id="15" name="Shape 10"/>
-          <p:cNvSpPr/>
-          <p:nvPr/>
-        </p:nvSpPr>
-        <p:spPr>
-          <a:xfrm>
-            <a:off x="6263640" y="2450592"/>
-            <a:ext cx="5120640" cy="1170432"/>
-          </a:xfrm>
-          <a:prstGeom prst="roundRect">
-            <a:avLst>
-              <a:gd name="adj" fmla="val 7813"/>
-            </a:avLst>
-          </a:prstGeom>
-          <a:solidFill>
-            <a:srgbClr val="00357A"/>
-          </a:solidFill>
-          <a:ln w="12700">
-            <a:solidFill>
-              <a:srgbClr val="2C6FB8"/>
-            </a:solidFill>
-            <a:prstDash val="solid"/>
-          </a:ln>
-        </p:spPr>
-      </p:sp>
-      <p:sp>
-        <p:nvSpPr>
-          <p:cNvPr id="16" name="Shape 11"/>
-          <p:cNvSpPr/>
-          <p:nvPr/>
-        </p:nvSpPr>
-        <p:spPr>
-          <a:xfrm>
-            <a:off x="6464808" y="2633472"/>
-            <a:ext cx="402336" cy="402336"/>
-          </a:xfrm>
-          <a:prstGeom prst="ellipse">
-            <a:avLst/>
-          </a:prstGeom>
-          <a:solidFill>
-            <a:srgbClr val="42C0FF"/>
-          </a:solidFill>
-          <a:ln/>
-        </p:spPr>
-      </p:sp>
-      <p:sp>
-        <p:nvSpPr>
-          <p:cNvPr id="17" name="Text 12"/>
-          <p:cNvSpPr/>
-          <p:nvPr/>
-        </p:nvSpPr>
-        <p:spPr>
-          <a:xfrm>
-            <a:off x="6464808" y="2633472"/>
-            <a:ext cx="402336" cy="402336"/>
-          </a:xfrm>
-          <a:prstGeom prst="rect">
-            <a:avLst/>
-          </a:prstGeom>
-          <a:noFill/>
-          <a:ln/>
-        </p:spPr>
-        <p:txBody>
-          <a:bodyPr wrap="square" lIns="0" tIns="0" rIns="0" bIns="0" rtlCol="0" anchor="ctr"/>
-          <a:lstStyle/>
-          <a:p>
-            <a:pPr algn="ctr" indent="0" marL="0">
-              <a:buNone/>
-            </a:pPr>
-            <a:r>
-              <a:rPr lang="en-US" sz="1400" b="1" dirty="0">
-                <a:solidFill>
-                  <a:srgbClr val="00357A"/>
-                </a:solidFill>
-                <a:latin typeface="Poppins" pitchFamily="34" charset="0"/>
-                <a:ea typeface="Poppins" pitchFamily="34" charset="-122"/>
-                <a:cs typeface="Poppins" pitchFamily="34" charset="-120"/>
-              </a:rPr>
-              <a:t>2</a:t>
-            </a:r>
-            <a:endParaRPr lang="en-US" sz="1400" dirty="0"/>
-          </a:p>
-        </p:txBody>
-      </p:sp>
-      <p:sp>
-        <p:nvSpPr>
-          <p:cNvPr id="18" name="Text 13"/>
-          <p:cNvSpPr/>
-          <p:nvPr/>
-        </p:nvSpPr>
-        <p:spPr>
-          <a:xfrm>
-            <a:off x="6976872" y="2578608"/>
-            <a:ext cx="4206240" cy="347472"/>
-          </a:xfrm>
-          <a:prstGeom prst="rect">
-            <a:avLst/>
-          </a:prstGeom>
-          <a:noFill/>
-          <a:ln/>
-        </p:spPr>
-        <p:txBody>
-          <a:bodyPr wrap="square" lIns="0" tIns="0" rIns="0" bIns="0" rtlCol="0" anchor="ctr"/>
-          <a:lstStyle/>
-          <a:p>
-            <a:pPr indent="0" marL="0">
-              <a:buNone/>
-            </a:pPr>
-            <a:r>
-              <a:rPr lang="en-US" sz="1300" b="1" dirty="0">
-                <a:solidFill>
-                  <a:srgbClr val="42C0FF"/>
-                </a:solidFill>
-                <a:latin typeface="Poppins" pitchFamily="34" charset="0"/>
-                <a:ea typeface="Poppins" pitchFamily="34" charset="-122"/>
-                <a:cs typeface="Poppins" pitchFamily="34" charset="-120"/>
-              </a:rPr>
-              <a:t>-A 3 is the working default</a:t>
-            </a:r>
-            <a:endParaRPr lang="en-US" sz="1300" dirty="0"/>
-          </a:p>
-        </p:txBody>
-      </p:sp>
-      <p:sp>
-        <p:nvSpPr>
-          <p:cNvPr id="19" name="Text 14"/>
-          <p:cNvSpPr/>
-          <p:nvPr/>
-        </p:nvSpPr>
-        <p:spPr>
-          <a:xfrm>
-            <a:off x="6976872" y="2944368"/>
-            <a:ext cx="4206240" cy="585216"/>
-          </a:xfrm>
-          <a:prstGeom prst="rect">
-            <a:avLst/>
-          </a:prstGeom>
-          <a:noFill/>
-          <a:ln/>
-        </p:spPr>
-        <p:txBody>
-          <a:bodyPr wrap="square" lIns="0" tIns="0" rIns="0" bIns="0" rtlCol="0" anchor="t"/>
-          <a:lstStyle/>
-          <a:p>
-            <a:pPr indent="0" marL="0">
-              <a:lnSpc>
-                <a:spcPct val="105000"/>
-              </a:lnSpc>
-              <a:buNone/>
-            </a:pPr>
-            <a:r>
-              <a:rPr lang="en-US" sz="1050" dirty="0">
-                <a:solidFill>
-                  <a:srgbClr val="D5E8FA"/>
-                </a:solidFill>
-                <a:latin typeface="Poppins" pitchFamily="34" charset="0"/>
-                <a:ea typeface="Poppins" pitchFamily="34" charset="-122"/>
-                <a:cs typeface="Poppins" pitchFamily="34" charset="-120"/>
-              </a:rPr>
-              <a:t>Create the input lists and build the tars in one pass. -A 4 ships them. -A 7 does both.</a:t>
-            </a:r>
-            <a:endParaRPr lang="en-US" sz="1050" dirty="0"/>
-          </a:p>
-        </p:txBody>
-      </p:sp>
-      <p:sp>
-        <p:nvSpPr>
-          <p:cNvPr id="20" name="Shape 15"/>
-          <p:cNvSpPr/>
-          <p:nvPr/>
-        </p:nvSpPr>
-        <p:spPr>
-          <a:xfrm>
-            <a:off x="822960" y="3694176"/>
-            <a:ext cx="5120640" cy="1170432"/>
-          </a:xfrm>
-          <a:prstGeom prst="roundRect">
-            <a:avLst>
-              <a:gd name="adj" fmla="val 7813"/>
-            </a:avLst>
-          </a:prstGeom>
-          <a:solidFill>
-            <a:srgbClr val="00357A"/>
-          </a:solidFill>
-          <a:ln w="12700">
-            <a:solidFill>
-              <a:srgbClr val="2C6FB8"/>
-            </a:solidFill>
-            <a:prstDash val="solid"/>
-          </a:ln>
-        </p:spPr>
-      </p:sp>
-      <p:sp>
-        <p:nvSpPr>
-          <p:cNvPr id="21" name="Shape 16"/>
-          <p:cNvSpPr/>
-          <p:nvPr/>
-        </p:nvSpPr>
-        <p:spPr>
-          <a:xfrm>
-            <a:off x="1024128" y="3877056"/>
-            <a:ext cx="402336" cy="402336"/>
-          </a:xfrm>
-          <a:prstGeom prst="ellipse">
-            <a:avLst/>
-          </a:prstGeom>
-          <a:solidFill>
-            <a:srgbClr val="42C0FF"/>
-          </a:solidFill>
-          <a:ln/>
-        </p:spPr>
-      </p:sp>
-      <p:sp>
-        <p:nvSpPr>
-          <p:cNvPr id="22" name="Text 17"/>
-          <p:cNvSpPr/>
-          <p:nvPr/>
-        </p:nvSpPr>
-        <p:spPr>
-          <a:xfrm>
-            <a:off x="1024128" y="3877056"/>
-            <a:ext cx="402336" cy="402336"/>
-          </a:xfrm>
-          <a:prstGeom prst="rect">
-            <a:avLst/>
-          </a:prstGeom>
-          <a:noFill/>
-          <a:ln/>
-        </p:spPr>
-        <p:txBody>
-          <a:bodyPr wrap="square" lIns="0" tIns="0" rIns="0" bIns="0" rtlCol="0" anchor="ctr"/>
-          <a:lstStyle/>
-          <a:p>
-            <a:pPr algn="ctr" indent="0" marL="0">
-              <a:buNone/>
-            </a:pPr>
-            <a:r>
-              <a:rPr lang="en-US" sz="1400" b="1" dirty="0">
-                <a:solidFill>
-                  <a:srgbClr val="00357A"/>
-                </a:solidFill>
-                <a:latin typeface="Poppins" pitchFamily="34" charset="0"/>
-                <a:ea typeface="Poppins" pitchFamily="34" charset="-122"/>
-                <a:cs typeface="Poppins" pitchFamily="34" charset="-120"/>
-              </a:rPr>
-              <a:t>3</a:t>
-            </a:r>
-            <a:endParaRPr lang="en-US" sz="1400" dirty="0"/>
-          </a:p>
-        </p:txBody>
-      </p:sp>
-      <p:sp>
-        <p:nvSpPr>
-          <p:cNvPr id="23" name="Text 18"/>
-          <p:cNvSpPr/>
-          <p:nvPr/>
-        </p:nvSpPr>
-        <p:spPr>
-          <a:xfrm>
-            <a:off x="1536192" y="3822192"/>
-            <a:ext cx="4206240" cy="347472"/>
-          </a:xfrm>
-          <a:prstGeom prst="rect">
-            <a:avLst/>
-          </a:prstGeom>
-          <a:noFill/>
-          <a:ln/>
-        </p:spPr>
-        <p:txBody>
-          <a:bodyPr wrap="square" lIns="0" tIns="0" rIns="0" bIns="0" rtlCol="0" anchor="ctr"/>
-          <a:lstStyle/>
-          <a:p>
-            <a:pPr indent="0" marL="0">
-              <a:buNone/>
-            </a:pPr>
-            <a:r>
-              <a:rPr lang="en-US" sz="1300" b="1" dirty="0">
-                <a:solidFill>
-                  <a:srgbClr val="42C0FF"/>
-                </a:solidFill>
-                <a:latin typeface="Poppins" pitchFamily="34" charset="0"/>
-                <a:ea typeface="Poppins" pitchFamily="34" charset="-122"/>
-                <a:cs typeface="Poppins" pitchFamily="34" charset="-120"/>
-              </a:rPr>
-              <a:t>Status is the whole story</a:t>
-            </a:r>
-            <a:endParaRPr lang="en-US" sz="1300" dirty="0"/>
-          </a:p>
-        </p:txBody>
-      </p:sp>
-      <p:sp>
-        <p:nvSpPr>
-          <p:cNvPr id="24" name="Text 19"/>
-          <p:cNvSpPr/>
-          <p:nvPr/>
-        </p:nvSpPr>
-        <p:spPr>
-          <a:xfrm>
-            <a:off x="1536192" y="4187952"/>
-            <a:ext cx="4206240" cy="585216"/>
-          </a:xfrm>
-          <a:prstGeom prst="rect">
-            <a:avLst/>
-          </a:prstGeom>
-          <a:noFill/>
-          <a:ln/>
-        </p:spPr>
-        <p:txBody>
-          <a:bodyPr wrap="square" lIns="0" tIns="0" rIns="0" bIns="0" rtlCol="0" anchor="t"/>
-          <a:lstStyle/>
-          <a:p>
-            <a:pPr indent="0" marL="0">
-              <a:lnSpc>
-                <a:spcPct val="105000"/>
-              </a:lnSpc>
-              <a:buNone/>
-            </a:pPr>
-            <a:r>
-              <a:rPr lang="en-US" sz="1050" dirty="0">
-                <a:solidFill>
-                  <a:srgbClr val="D5E8FA"/>
-                </a:solidFill>
-                <a:latin typeface="Poppins" pitchFamily="34" charset="0"/>
-                <a:ea typeface="Poppins" pitchFamily="34" charset="-122"/>
-                <a:cs typeface="Poppins" pitchFamily="34" charset="-120"/>
-              </a:rPr>
-              <a:t>N listed, T tarred, A archived. Backwards moves are deliberate and simply requeue the work.</a:t>
-            </a:r>
-            <a:endParaRPr lang="en-US" sz="1050" dirty="0"/>
-          </a:p>
-        </p:txBody>
-      </p:sp>
-      <p:sp>
-        <p:nvSpPr>
-          <p:cNvPr id="25" name="Shape 20"/>
-          <p:cNvSpPr/>
-          <p:nvPr/>
-        </p:nvSpPr>
-        <p:spPr>
-          <a:xfrm>
-            <a:off x="6263640" y="3694176"/>
-            <a:ext cx="5120640" cy="1170432"/>
-          </a:xfrm>
-          <a:prstGeom prst="roundRect">
-            <a:avLst>
-              <a:gd name="adj" fmla="val 7813"/>
-            </a:avLst>
-          </a:prstGeom>
-          <a:solidFill>
-            <a:srgbClr val="00357A"/>
-          </a:solidFill>
-          <a:ln w="12700">
-            <a:solidFill>
-              <a:srgbClr val="2C6FB8"/>
-            </a:solidFill>
-            <a:prstDash val="solid"/>
-          </a:ln>
-        </p:spPr>
-      </p:sp>
-      <p:sp>
-        <p:nvSpPr>
-          <p:cNvPr id="26" name="Shape 21"/>
-          <p:cNvSpPr/>
-          <p:nvPr/>
-        </p:nvSpPr>
-        <p:spPr>
-          <a:xfrm>
-            <a:off x="6464808" y="3877056"/>
-            <a:ext cx="402336" cy="402336"/>
-          </a:xfrm>
-          <a:prstGeom prst="ellipse">
-            <a:avLst/>
-          </a:prstGeom>
-          <a:solidFill>
-            <a:srgbClr val="42C0FF"/>
-          </a:solidFill>
-          <a:ln/>
-        </p:spPr>
-      </p:sp>
-      <p:sp>
-        <p:nvSpPr>
-          <p:cNvPr id="27" name="Text 22"/>
-          <p:cNvSpPr/>
-          <p:nvPr/>
-        </p:nvSpPr>
-        <p:spPr>
-          <a:xfrm>
-            <a:off x="6464808" y="3877056"/>
-            <a:ext cx="402336" cy="402336"/>
-          </a:xfrm>
-          <a:prstGeom prst="rect">
-            <a:avLst/>
-          </a:prstGeom>
-          <a:noFill/>
-          <a:ln/>
-        </p:spPr>
-        <p:txBody>
-          <a:bodyPr wrap="square" lIns="0" tIns="0" rIns="0" bIns="0" rtlCol="0" anchor="ctr"/>
-          <a:lstStyle/>
-          <a:p>
-            <a:pPr algn="ctr" indent="0" marL="0">
-              <a:buNone/>
-            </a:pPr>
-            <a:r>
-              <a:rPr lang="en-US" sz="1400" b="1" dirty="0">
-                <a:solidFill>
-                  <a:srgbClr val="00357A"/>
-                </a:solidFill>
-                <a:latin typeface="Poppins" pitchFamily="34" charset="0"/>
-                <a:ea typeface="Poppins" pitchFamily="34" charset="-122"/>
-                <a:cs typeface="Poppins" pitchFamily="34" charset="-120"/>
-              </a:rPr>
-              <a:t>4</a:t>
-            </a:r>
-            <a:endParaRPr lang="en-US" sz="1400" dirty="0"/>
-          </a:p>
-        </p:txBody>
-      </p:sp>
-      <p:sp>
-        <p:nvSpPr>
-          <p:cNvPr id="28" name="Text 23"/>
-          <p:cNvSpPr/>
-          <p:nvPr/>
-        </p:nvSpPr>
-        <p:spPr>
-          <a:xfrm>
-            <a:off x="6976872" y="3822192"/>
-            <a:ext cx="4206240" cy="347472"/>
-          </a:xfrm>
-          <a:prstGeom prst="rect">
-            <a:avLst/>
-          </a:prstGeom>
-          <a:noFill/>
-          <a:ln/>
-        </p:spPr>
-        <p:txBody>
-          <a:bodyPr wrap="square" lIns="0" tIns="0" rIns="0" bIns="0" rtlCol="0" anchor="ctr"/>
-          <a:lstStyle/>
-          <a:p>
-            <a:pPr indent="0" marL="0">
-              <a:buNone/>
-            </a:pPr>
-            <a:r>
-              <a:rPr lang="en-US" sz="1300" b="1" dirty="0">
-                <a:solidFill>
-                  <a:srgbClr val="42C0FF"/>
-                </a:solidFill>
-                <a:latin typeface="Poppins" pitchFamily="34" charset="0"/>
-                <a:ea typeface="Poppins" pitchFamily="34" charset="-122"/>
-                <a:cs typeface="Poppins" pitchFamily="34" charset="-120"/>
-              </a:rPr>
-              <a:t>Tar size is the economics</a:t>
-            </a:r>
-            <a:endParaRPr lang="en-US" sz="1300" dirty="0"/>
-          </a:p>
-        </p:txBody>
-      </p:sp>
-      <p:sp>
-        <p:nvSpPr>
-          <p:cNvPr id="29" name="Text 24"/>
-          <p:cNvSpPr/>
-          <p:nvPr/>
-        </p:nvSpPr>
-        <p:spPr>
-          <a:xfrm>
-            <a:off x="6976872" y="4187952"/>
-            <a:ext cx="4206240" cy="585216"/>
-          </a:xfrm>
-          <a:prstGeom prst="rect">
-            <a:avLst/>
-          </a:prstGeom>
-          <a:noFill/>
-          <a:ln/>
-        </p:spPr>
-        <p:txBody>
-          <a:bodyPr wrap="square" lIns="0" tIns="0" rIns="0" bIns="0" rtlCol="0" anchor="t"/>
-          <a:lstStyle/>
-          <a:p>
-            <a:pPr indent="0" marL="0">
-              <a:lnSpc>
-                <a:spcPct val="105000"/>
-              </a:lnSpc>
-              <a:buNone/>
-            </a:pPr>
-            <a:r>
-              <a:rPr lang="en-US" sz="1050" dirty="0">
-                <a:solidFill>
-                  <a:srgbClr val="D5E8FA"/>
-                </a:solidFill>
-                <a:latin typeface="Poppins" pitchFamily="34" charset="0"/>
-                <a:ea typeface="Poppins" pitchFamily="34" charset="-122"/>
-                <a:cs typeface="Poppins" pitchFamily="34" charset="-120"/>
-              </a:rPr>
-              <a:t>5 GB target tars batched into 90 GB transfers is what makes tape and Globus efficient.</a:t>
-            </a:r>
-            <a:endParaRPr lang="en-US" sz="1050" dirty="0"/>
-          </a:p>
-        </p:txBody>
-      </p:sp>
-      <p:sp>
-        <p:nvSpPr>
-          <p:cNvPr id="30" name="Shape 25"/>
-          <p:cNvSpPr/>
-          <p:nvPr/>
-        </p:nvSpPr>
-        <p:spPr>
-          <a:xfrm>
-            <a:off x="822960" y="4937760"/>
-            <a:ext cx="5120640" cy="1170432"/>
-          </a:xfrm>
-          <a:prstGeom prst="roundRect">
-            <a:avLst>
-              <a:gd name="adj" fmla="val 7813"/>
-            </a:avLst>
-          </a:prstGeom>
-          <a:solidFill>
-            <a:srgbClr val="00357A"/>
-          </a:solidFill>
-          <a:ln w="12700">
-            <a:solidFill>
-              <a:srgbClr val="2C6FB8"/>
-            </a:solidFill>
-            <a:prstDash val="solid"/>
-          </a:ln>
-        </p:spPr>
-      </p:sp>
-      <p:sp>
-        <p:nvSpPr>
-          <p:cNvPr id="31" name="Shape 26"/>
-          <p:cNvSpPr/>
-          <p:nvPr/>
-        </p:nvSpPr>
-        <p:spPr>
-          <a:xfrm>
-            <a:off x="1024128" y="5120640"/>
-            <a:ext cx="402336" cy="402336"/>
-          </a:xfrm>
-          <a:prstGeom prst="ellipse">
-            <a:avLst/>
-          </a:prstGeom>
-          <a:solidFill>
-            <a:srgbClr val="42C0FF"/>
-          </a:solidFill>
-          <a:ln/>
-        </p:spPr>
-      </p:sp>
-      <p:sp>
-        <p:nvSpPr>
-          <p:cNvPr id="32" name="Text 27"/>
-          <p:cNvSpPr/>
-          <p:nvPr/>
-        </p:nvSpPr>
-        <p:spPr>
-          <a:xfrm>
-            <a:off x="1024128" y="5120640"/>
-            <a:ext cx="402336" cy="402336"/>
-          </a:xfrm>
-          <a:prstGeom prst="rect">
-            <a:avLst/>
-          </a:prstGeom>
-          <a:noFill/>
-          <a:ln/>
-        </p:spPr>
-        <p:txBody>
-          <a:bodyPr wrap="square" lIns="0" tIns="0" rIns="0" bIns="0" rtlCol="0" anchor="ctr"/>
-          <a:lstStyle/>
-          <a:p>
-            <a:pPr algn="ctr" indent="0" marL="0">
-              <a:buNone/>
-            </a:pPr>
-            <a:r>
-              <a:rPr lang="en-US" sz="1400" b="1" dirty="0">
-                <a:solidFill>
-                  <a:srgbClr val="00357A"/>
-                </a:solidFill>
-                <a:latin typeface="Poppins" pitchFamily="34" charset="0"/>
-                <a:ea typeface="Poppins" pitchFamily="34" charset="-122"/>
-                <a:cs typeface="Poppins" pitchFamily="34" charset="-120"/>
-              </a:rPr>
-              <a:t>5</a:t>
-            </a:r>
-            <a:endParaRPr lang="en-US" sz="1400" dirty="0"/>
-          </a:p>
-        </p:txBody>
-      </p:sp>
-      <p:sp>
-        <p:nvSpPr>
-          <p:cNvPr id="33" name="Text 28"/>
-          <p:cNvSpPr/>
-          <p:nvPr/>
-        </p:nvSpPr>
-        <p:spPr>
-          <a:xfrm>
-            <a:off x="1536192" y="5065776"/>
-            <a:ext cx="4206240" cy="347472"/>
-          </a:xfrm>
-          <a:prstGeom prst="rect">
-            <a:avLst/>
-          </a:prstGeom>
-          <a:noFill/>
-          <a:ln/>
-        </p:spPr>
-        <p:txBody>
-          <a:bodyPr wrap="square" lIns="0" tIns="0" rIns="0" bIns="0" rtlCol="0" anchor="ctr"/>
-          <a:lstStyle/>
-          <a:p>
-            <a:pPr indent="0" marL="0">
-              <a:buNone/>
-            </a:pPr>
-            <a:r>
-              <a:rPr lang="en-US" sz="1300" b="1" dirty="0">
-                <a:solidFill>
-                  <a:srgbClr val="42C0FF"/>
-                </a:solidFill>
-                <a:latin typeface="Poppins" pitchFamily="34" charset="0"/>
-                <a:ea typeface="Poppins" pitchFamily="34" charset="-122"/>
-                <a:cs typeface="Poppins" pitchFamily="34" charset="-120"/>
-              </a:rPr>
-              <a:t>The dataset lock is the only lock</a:t>
-            </a:r>
-            <a:endParaRPr lang="en-US" sz="1300" dirty="0"/>
-          </a:p>
-        </p:txBody>
-      </p:sp>
-      <p:sp>
-        <p:nvSpPr>
-          <p:cNvPr id="34" name="Text 29"/>
-          <p:cNvSpPr/>
-          <p:nvPr/>
-        </p:nvSpPr>
-        <p:spPr>
-          <a:xfrm>
-            <a:off x="1536192" y="5431536"/>
-            <a:ext cx="4206240" cy="585216"/>
-          </a:xfrm>
-          <a:prstGeom prst="rect">
-            <a:avLst/>
-          </a:prstGeom>
-          <a:noFill/>
-          <a:ln/>
-        </p:spPr>
-        <p:txBody>
-          <a:bodyPr wrap="square" lIns="0" tIns="0" rIns="0" bIns="0" rtlCol="0" anchor="t"/>
-          <a:lstStyle/>
-          <a:p>
-            <a:pPr indent="0" marL="0">
-              <a:lnSpc>
-                <a:spcPct val="105000"/>
-              </a:lnSpc>
-              <a:buNone/>
-            </a:pPr>
-            <a:r>
-              <a:rPr lang="en-US" sz="1050" dirty="0">
-                <a:solidFill>
-                  <a:srgbClr val="D5E8FA"/>
-                </a:solidFill>
-                <a:latin typeface="Poppins" pitchFamily="34" charset="0"/>
-                <a:ea typeface="Poppins" pitchFamily="34" charset="-122"/>
-                <a:cs typeface="Poppins" pitchFamily="34" charset="-120"/>
-              </a:rPr>
-              <a:t>Everything about concurrency — workers, re-checks, multi-dataset tars — is built on it.</a:t>
-            </a:r>
-            <a:endParaRPr lang="en-US" sz="1050" dirty="0"/>
-          </a:p>
-        </p:txBody>
-      </p:sp>
-      <p:sp>
-        <p:nvSpPr>
-          <p:cNvPr id="35" name="Shape 30"/>
-          <p:cNvSpPr/>
-          <p:nvPr/>
-        </p:nvSpPr>
-        <p:spPr>
-          <a:xfrm>
-            <a:off x="6263640" y="4937760"/>
-            <a:ext cx="5120640" cy="1170432"/>
-          </a:xfrm>
-          <a:prstGeom prst="roundRect">
-            <a:avLst>
-              <a:gd name="adj" fmla="val 7813"/>
-            </a:avLst>
-          </a:prstGeom>
-          <a:solidFill>
-            <a:srgbClr val="00357A"/>
-          </a:solidFill>
-          <a:ln w="12700">
-            <a:solidFill>
-              <a:srgbClr val="2C6FB8"/>
-            </a:solidFill>
-            <a:prstDash val="solid"/>
-          </a:ln>
-        </p:spPr>
-      </p:sp>
-      <p:sp>
-        <p:nvSpPr>
-          <p:cNvPr id="36" name="Shape 31"/>
-          <p:cNvSpPr/>
-          <p:nvPr/>
-        </p:nvSpPr>
-        <p:spPr>
-          <a:xfrm>
-            <a:off x="6464808" y="5120640"/>
-            <a:ext cx="402336" cy="402336"/>
-          </a:xfrm>
-          <a:prstGeom prst="ellipse">
-            <a:avLst/>
-          </a:prstGeom>
-          <a:solidFill>
-            <a:srgbClr val="42C0FF"/>
-          </a:solidFill>
-          <a:ln/>
-        </p:spPr>
-      </p:sp>
-      <p:sp>
-        <p:nvSpPr>
-          <p:cNvPr id="37" name="Text 32"/>
-          <p:cNvSpPr/>
-          <p:nvPr/>
-        </p:nvSpPr>
-        <p:spPr>
-          <a:xfrm>
-            <a:off x="6464808" y="5120640"/>
-            <a:ext cx="402336" cy="402336"/>
-          </a:xfrm>
-          <a:prstGeom prst="rect">
-            <a:avLst/>
-          </a:prstGeom>
-          <a:noFill/>
-          <a:ln/>
-        </p:spPr>
-        <p:txBody>
-          <a:bodyPr wrap="square" lIns="0" tIns="0" rIns="0" bIns="0" rtlCol="0" anchor="ctr"/>
-          <a:lstStyle/>
-          <a:p>
-            <a:pPr algn="ctr" indent="0" marL="0">
-              <a:buNone/>
-            </a:pPr>
-            <a:r>
-              <a:rPr lang="en-US" sz="1400" b="1" dirty="0">
-                <a:solidFill>
-                  <a:srgbClr val="00357A"/>
-                </a:solidFill>
-                <a:latin typeface="Poppins" pitchFamily="34" charset="0"/>
-                <a:ea typeface="Poppins" pitchFamily="34" charset="-122"/>
-                <a:cs typeface="Poppins" pitchFamily="34" charset="-120"/>
-              </a:rPr>
-              <a:t>6</a:t>
-            </a:r>
-            <a:endParaRPr lang="en-US" sz="1400" dirty="0"/>
-          </a:p>
-        </p:txBody>
-      </p:sp>
-      <p:sp>
-        <p:nvSpPr>
-          <p:cNvPr id="38" name="Text 33"/>
-          <p:cNvSpPr/>
-          <p:nvPr/>
-        </p:nvSpPr>
-        <p:spPr>
-          <a:xfrm>
-            <a:off x="6976872" y="5065776"/>
-            <a:ext cx="4206240" cy="347472"/>
-          </a:xfrm>
-          <a:prstGeom prst="rect">
-            <a:avLst/>
-          </a:prstGeom>
-          <a:noFill/>
-          <a:ln/>
-        </p:spPr>
-        <p:txBody>
-          <a:bodyPr wrap="square" lIns="0" tIns="0" rIns="0" bIns="0" rtlCol="0" anchor="ctr"/>
-          <a:lstStyle/>
-          <a:p>
-            <a:pPr indent="0" marL="0">
-              <a:buNone/>
-            </a:pPr>
-            <a:r>
-              <a:rPr lang="en-US" sz="1300" b="1" dirty="0">
-                <a:solidFill>
-                  <a:srgbClr val="42C0FF"/>
-                </a:solidFill>
-                <a:latin typeface="Poppins" pitchFamily="34" charset="0"/>
-                <a:ea typeface="Poppins" pitchFamily="34" charset="-122"/>
-                <a:cs typeface="Poppins" pitchFamily="34" charset="-120"/>
-              </a:rPr>
-              <a:t>Nothing is lost by stopping</a:t>
-            </a:r>
-            <a:endParaRPr lang="en-US" sz="1300" dirty="0"/>
-          </a:p>
-        </p:txBody>
-      </p:sp>
-      <p:sp>
-        <p:nvSpPr>
-          <p:cNvPr id="39" name="Text 34"/>
-          <p:cNvSpPr/>
-          <p:nvPr/>
-        </p:nvSpPr>
-        <p:spPr>
-          <a:xfrm>
-            <a:off x="6976872" y="5431536"/>
-            <a:ext cx="4206240" cy="585216"/>
-          </a:xfrm>
-          <a:prstGeom prst="rect">
-            <a:avLst/>
-          </a:prstGeom>
-          <a:noFill/>
-          <a:ln/>
-        </p:spPr>
-        <p:txBody>
-          <a:bodyPr wrap="square" lIns="0" tIns="0" rIns="0" bIns="0" rtlCol="0" anchor="t"/>
-          <a:lstStyle/>
-          <a:p>
-            <a:pPr indent="0" marL="0">
-              <a:lnSpc>
-                <a:spcPct val="105000"/>
-              </a:lnSpc>
-              <a:buNone/>
-            </a:pPr>
-            <a:r>
-              <a:rPr lang="en-US" sz="1050" dirty="0">
-                <a:solidFill>
-                  <a:srgbClr val="D5E8FA"/>
-                </a:solidFill>
-                <a:latin typeface="Poppins" pitchFamily="34" charset="0"/>
-                <a:ea typeface="Poppins" pitchFamily="34" charset="-122"/>
-                <a:cs typeface="Poppins" pitchFamily="34" charset="-120"/>
-              </a:rPr>
-              <a:t>The 23-hour guard, the retry limit and the resumable statuses mean an interrupted run just continues later.</a:t>
-            </a:r>
-            <a:endParaRPr lang="en-US" sz="1050" dirty="0"/>
           </a:p>
         </p:txBody>
       </p:sp>
@@ -29752,6 +29748,1291 @@
         </p:nvSpPr>
         <p:spPr>
           <a:xfrm>
+            <a:off x="1527048" y="1060704"/>
+            <a:ext cx="7315200" cy="320040"/>
+          </a:xfrm>
+          <a:prstGeom prst="rect">
+            <a:avLst/>
+          </a:prstGeom>
+          <a:noFill/>
+          <a:ln/>
+        </p:spPr>
+        <p:txBody>
+          <a:bodyPr wrap="square" lIns="0" tIns="0" rIns="0" bIns="0" rtlCol="0" anchor="ctr"/>
+          <a:lstStyle/>
+          <a:p>
+            <a:pPr indent="0" marL="0">
+              <a:buNone/>
+            </a:pPr>
+            <a:r>
+              <a:rPr lang="en-US" sz="1300" b="1" spc="200" kern="0" dirty="0">
+                <a:solidFill>
+                  <a:srgbClr val="42C0FF"/>
+                </a:solidFill>
+                <a:latin typeface="Poppins" pitchFamily="34" charset="0"/>
+                <a:ea typeface="Poppins" pitchFamily="34" charset="-122"/>
+                <a:cs typeface="Poppins" pitchFamily="34" charset="-120"/>
+              </a:rPr>
+              <a:t>RECAP</a:t>
+            </a:r>
+            <a:endParaRPr lang="en-US" sz="1300" dirty="0"/>
+          </a:p>
+        </p:txBody>
+      </p:sp>
+      <p:sp>
+        <p:nvSpPr>
+          <p:cNvPr id="9" name="Text 4"/>
+          <p:cNvSpPr/>
+          <p:nvPr/>
+        </p:nvSpPr>
+        <p:spPr>
+          <a:xfrm>
+            <a:off x="1527048" y="1408176"/>
+            <a:ext cx="9144000" cy="731520"/>
+          </a:xfrm>
+          <a:prstGeom prst="rect">
+            <a:avLst/>
+          </a:prstGeom>
+          <a:noFill/>
+          <a:ln/>
+        </p:spPr>
+        <p:txBody>
+          <a:bodyPr wrap="square" lIns="0" tIns="0" rIns="0" bIns="0" rtlCol="0" anchor="ctr"/>
+          <a:lstStyle/>
+          <a:p>
+            <a:pPr indent="0" marL="0">
+              <a:buNone/>
+            </a:pPr>
+            <a:r>
+              <a:rPr lang="en-US" sz="4000" b="1" dirty="0">
+                <a:solidFill>
+                  <a:srgbClr val="FFFFFF"/>
+                </a:solidFill>
+                <a:latin typeface="Poppins" pitchFamily="34" charset="0"/>
+                <a:ea typeface="Poppins" pitchFamily="34" charset="-122"/>
+                <a:cs typeface="Poppins" pitchFamily="34" charset="-120"/>
+              </a:rPr>
+              <a:t>Six Things Worth Remembering</a:t>
+            </a:r>
+            <a:endParaRPr lang="en-US" sz="4000" dirty="0"/>
+          </a:p>
+        </p:txBody>
+      </p:sp>
+      <p:sp>
+        <p:nvSpPr>
+          <p:cNvPr id="10" name="Shape 5"/>
+          <p:cNvSpPr/>
+          <p:nvPr/>
+        </p:nvSpPr>
+        <p:spPr>
+          <a:xfrm>
+            <a:off x="822960" y="2450592"/>
+            <a:ext cx="5120640" cy="1170432"/>
+          </a:xfrm>
+          <a:prstGeom prst="roundRect">
+            <a:avLst>
+              <a:gd name="adj" fmla="val 7813"/>
+            </a:avLst>
+          </a:prstGeom>
+          <a:solidFill>
+            <a:srgbClr val="00357A"/>
+          </a:solidFill>
+          <a:ln w="12700">
+            <a:solidFill>
+              <a:srgbClr val="2C6FB8"/>
+            </a:solidFill>
+            <a:prstDash val="solid"/>
+          </a:ln>
+        </p:spPr>
+      </p:sp>
+      <p:sp>
+        <p:nvSpPr>
+          <p:cNvPr id="11" name="Shape 6"/>
+          <p:cNvSpPr/>
+          <p:nvPr/>
+        </p:nvSpPr>
+        <p:spPr>
+          <a:xfrm>
+            <a:off x="1024128" y="2633472"/>
+            <a:ext cx="402336" cy="402336"/>
+          </a:xfrm>
+          <a:prstGeom prst="ellipse">
+            <a:avLst/>
+          </a:prstGeom>
+          <a:solidFill>
+            <a:srgbClr val="42C0FF"/>
+          </a:solidFill>
+          <a:ln/>
+        </p:spPr>
+      </p:sp>
+      <p:sp>
+        <p:nvSpPr>
+          <p:cNvPr id="12" name="Text 7"/>
+          <p:cNvSpPr/>
+          <p:nvPr/>
+        </p:nvSpPr>
+        <p:spPr>
+          <a:xfrm>
+            <a:off x="1024128" y="2633472"/>
+            <a:ext cx="402336" cy="402336"/>
+          </a:xfrm>
+          <a:prstGeom prst="rect">
+            <a:avLst/>
+          </a:prstGeom>
+          <a:noFill/>
+          <a:ln/>
+        </p:spPr>
+        <p:txBody>
+          <a:bodyPr wrap="square" lIns="0" tIns="0" rIns="0" bIns="0" rtlCol="0" anchor="ctr"/>
+          <a:lstStyle/>
+          <a:p>
+            <a:pPr algn="ctr" indent="0" marL="0">
+              <a:buNone/>
+            </a:pPr>
+            <a:r>
+              <a:rPr lang="en-US" sz="1400" b="1" dirty="0">
+                <a:solidFill>
+                  <a:srgbClr val="00357A"/>
+                </a:solidFill>
+                <a:latin typeface="Poppins" pitchFamily="34" charset="0"/>
+                <a:ea typeface="Poppins" pitchFamily="34" charset="-122"/>
+                <a:cs typeface="Poppins" pitchFamily="34" charset="-120"/>
+              </a:rPr>
+              <a:t>1</a:t>
+            </a:r>
+            <a:endParaRPr lang="en-US" sz="1400" dirty="0"/>
+          </a:p>
+        </p:txBody>
+      </p:sp>
+      <p:sp>
+        <p:nvSpPr>
+          <p:cNvPr id="13" name="Text 8"/>
+          <p:cNvSpPr/>
+          <p:nvPr/>
+        </p:nvSpPr>
+        <p:spPr>
+          <a:xfrm>
+            <a:off x="1536192" y="2578608"/>
+            <a:ext cx="4206240" cy="347472"/>
+          </a:xfrm>
+          <a:prstGeom prst="rect">
+            <a:avLst/>
+          </a:prstGeom>
+          <a:noFill/>
+          <a:ln/>
+        </p:spPr>
+        <p:txBody>
+          <a:bodyPr wrap="square" lIns="0" tIns="0" rIns="0" bIns="0" rtlCol="0" anchor="ctr"/>
+          <a:lstStyle/>
+          <a:p>
+            <a:pPr indent="0" marL="0">
+              <a:buNone/>
+            </a:pPr>
+            <a:r>
+              <a:rPr lang="en-US" sz="1300" b="1" dirty="0">
+                <a:solidFill>
+                  <a:srgbClr val="42C0FF"/>
+                </a:solidFill>
+                <a:latin typeface="Poppins" pitchFamily="34" charset="0"/>
+                <a:ea typeface="Poppins" pitchFamily="34" charset="-122"/>
+                <a:cs typeface="Poppins" pitchFamily="34" charset="-120"/>
+              </a:rPr>
+              <a:t>dataset.backflag enrolls</a:t>
+            </a:r>
+            <a:endParaRPr lang="en-US" sz="1300" dirty="0"/>
+          </a:p>
+        </p:txBody>
+      </p:sp>
+      <p:sp>
+        <p:nvSpPr>
+          <p:cNvPr id="14" name="Text 9"/>
+          <p:cNvSpPr/>
+          <p:nvPr/>
+        </p:nvSpPr>
+        <p:spPr>
+          <a:xfrm>
+            <a:off x="1536192" y="2944368"/>
+            <a:ext cx="4206240" cy="585216"/>
+          </a:xfrm>
+          <a:prstGeom prst="rect">
+            <a:avLst/>
+          </a:prstGeom>
+          <a:noFill/>
+          <a:ln/>
+        </p:spPr>
+        <p:txBody>
+          <a:bodyPr wrap="square" lIns="0" tIns="0" rIns="0" bIns="0" rtlCol="0" anchor="t"/>
+          <a:lstStyle/>
+          <a:p>
+            <a:pPr indent="0" marL="0">
+              <a:lnSpc>
+                <a:spcPct val="105000"/>
+              </a:lnSpc>
+              <a:buNone/>
+            </a:pPr>
+            <a:r>
+              <a:rPr lang="en-US" sz="1050" dirty="0">
+                <a:solidFill>
+                  <a:srgbClr val="D5E8FA"/>
+                </a:solidFill>
+                <a:latin typeface="Poppins" pitchFamily="34" charset="0"/>
+                <a:ea typeface="Poppins" pitchFamily="34" charset="-122"/>
+                <a:cs typeface="Poppins" pitchFamily="34" charset="-120"/>
+              </a:rPr>
+              <a:t>Setting that one field puts a dataset under backup; dsgroup.backflag refines it. -t narrows a run, it does not override a flag.</a:t>
+            </a:r>
+            <a:endParaRPr lang="en-US" sz="1050" dirty="0"/>
+          </a:p>
+        </p:txBody>
+      </p:sp>
+      <p:sp>
+        <p:nvSpPr>
+          <p:cNvPr id="15" name="Shape 10"/>
+          <p:cNvSpPr/>
+          <p:nvPr/>
+        </p:nvSpPr>
+        <p:spPr>
+          <a:xfrm>
+            <a:off x="6263640" y="2450592"/>
+            <a:ext cx="5120640" cy="1170432"/>
+          </a:xfrm>
+          <a:prstGeom prst="roundRect">
+            <a:avLst>
+              <a:gd name="adj" fmla="val 7813"/>
+            </a:avLst>
+          </a:prstGeom>
+          <a:solidFill>
+            <a:srgbClr val="00357A"/>
+          </a:solidFill>
+          <a:ln w="12700">
+            <a:solidFill>
+              <a:srgbClr val="2C6FB8"/>
+            </a:solidFill>
+            <a:prstDash val="solid"/>
+          </a:ln>
+        </p:spPr>
+      </p:sp>
+      <p:sp>
+        <p:nvSpPr>
+          <p:cNvPr id="16" name="Shape 11"/>
+          <p:cNvSpPr/>
+          <p:nvPr/>
+        </p:nvSpPr>
+        <p:spPr>
+          <a:xfrm>
+            <a:off x="6464808" y="2633472"/>
+            <a:ext cx="402336" cy="402336"/>
+          </a:xfrm>
+          <a:prstGeom prst="ellipse">
+            <a:avLst/>
+          </a:prstGeom>
+          <a:solidFill>
+            <a:srgbClr val="42C0FF"/>
+          </a:solidFill>
+          <a:ln/>
+        </p:spPr>
+      </p:sp>
+      <p:sp>
+        <p:nvSpPr>
+          <p:cNvPr id="17" name="Text 12"/>
+          <p:cNvSpPr/>
+          <p:nvPr/>
+        </p:nvSpPr>
+        <p:spPr>
+          <a:xfrm>
+            <a:off x="6464808" y="2633472"/>
+            <a:ext cx="402336" cy="402336"/>
+          </a:xfrm>
+          <a:prstGeom prst="rect">
+            <a:avLst/>
+          </a:prstGeom>
+          <a:noFill/>
+          <a:ln/>
+        </p:spPr>
+        <p:txBody>
+          <a:bodyPr wrap="square" lIns="0" tIns="0" rIns="0" bIns="0" rtlCol="0" anchor="ctr"/>
+          <a:lstStyle/>
+          <a:p>
+            <a:pPr algn="ctr" indent="0" marL="0">
+              <a:buNone/>
+            </a:pPr>
+            <a:r>
+              <a:rPr lang="en-US" sz="1400" b="1" dirty="0">
+                <a:solidFill>
+                  <a:srgbClr val="00357A"/>
+                </a:solidFill>
+                <a:latin typeface="Poppins" pitchFamily="34" charset="0"/>
+                <a:ea typeface="Poppins" pitchFamily="34" charset="-122"/>
+                <a:cs typeface="Poppins" pitchFamily="34" charset="-120"/>
+              </a:rPr>
+              <a:t>2</a:t>
+            </a:r>
+            <a:endParaRPr lang="en-US" sz="1400" dirty="0"/>
+          </a:p>
+        </p:txBody>
+      </p:sp>
+      <p:sp>
+        <p:nvSpPr>
+          <p:cNvPr id="18" name="Text 13"/>
+          <p:cNvSpPr/>
+          <p:nvPr/>
+        </p:nvSpPr>
+        <p:spPr>
+          <a:xfrm>
+            <a:off x="6976872" y="2578608"/>
+            <a:ext cx="4206240" cy="347472"/>
+          </a:xfrm>
+          <a:prstGeom prst="rect">
+            <a:avLst/>
+          </a:prstGeom>
+          <a:noFill/>
+          <a:ln/>
+        </p:spPr>
+        <p:txBody>
+          <a:bodyPr wrap="square" lIns="0" tIns="0" rIns="0" bIns="0" rtlCol="0" anchor="ctr"/>
+          <a:lstStyle/>
+          <a:p>
+            <a:pPr indent="0" marL="0">
+              <a:buNone/>
+            </a:pPr>
+            <a:r>
+              <a:rPr lang="en-US" sz="1300" b="1" dirty="0">
+                <a:solidFill>
+                  <a:srgbClr val="42C0FF"/>
+                </a:solidFill>
+                <a:latin typeface="Poppins" pitchFamily="34" charset="0"/>
+                <a:ea typeface="Poppins" pitchFamily="34" charset="-122"/>
+                <a:cs typeface="Poppins" pitchFamily="34" charset="-120"/>
+              </a:rPr>
+              <a:t>-A 3 is the working default</a:t>
+            </a:r>
+            <a:endParaRPr lang="en-US" sz="1300" dirty="0"/>
+          </a:p>
+        </p:txBody>
+      </p:sp>
+      <p:sp>
+        <p:nvSpPr>
+          <p:cNvPr id="19" name="Text 14"/>
+          <p:cNvSpPr/>
+          <p:nvPr/>
+        </p:nvSpPr>
+        <p:spPr>
+          <a:xfrm>
+            <a:off x="6976872" y="2944368"/>
+            <a:ext cx="4206240" cy="585216"/>
+          </a:xfrm>
+          <a:prstGeom prst="rect">
+            <a:avLst/>
+          </a:prstGeom>
+          <a:noFill/>
+          <a:ln/>
+        </p:spPr>
+        <p:txBody>
+          <a:bodyPr wrap="square" lIns="0" tIns="0" rIns="0" bIns="0" rtlCol="0" anchor="t"/>
+          <a:lstStyle/>
+          <a:p>
+            <a:pPr indent="0" marL="0">
+              <a:lnSpc>
+                <a:spcPct val="105000"/>
+              </a:lnSpc>
+              <a:buNone/>
+            </a:pPr>
+            <a:r>
+              <a:rPr lang="en-US" sz="1050" dirty="0">
+                <a:solidFill>
+                  <a:srgbClr val="D5E8FA"/>
+                </a:solidFill>
+                <a:latin typeface="Poppins" pitchFamily="34" charset="0"/>
+                <a:ea typeface="Poppins" pitchFamily="34" charset="-122"/>
+                <a:cs typeface="Poppins" pitchFamily="34" charset="-120"/>
+              </a:rPr>
+              <a:t>Create the input lists and build the tars in one pass. -A 4 ships them. -A 7 does both.</a:t>
+            </a:r>
+            <a:endParaRPr lang="en-US" sz="1050" dirty="0"/>
+          </a:p>
+        </p:txBody>
+      </p:sp>
+      <p:sp>
+        <p:nvSpPr>
+          <p:cNvPr id="20" name="Shape 15"/>
+          <p:cNvSpPr/>
+          <p:nvPr/>
+        </p:nvSpPr>
+        <p:spPr>
+          <a:xfrm>
+            <a:off x="822960" y="3694176"/>
+            <a:ext cx="5120640" cy="1170432"/>
+          </a:xfrm>
+          <a:prstGeom prst="roundRect">
+            <a:avLst>
+              <a:gd name="adj" fmla="val 7813"/>
+            </a:avLst>
+          </a:prstGeom>
+          <a:solidFill>
+            <a:srgbClr val="00357A"/>
+          </a:solidFill>
+          <a:ln w="12700">
+            <a:solidFill>
+              <a:srgbClr val="2C6FB8"/>
+            </a:solidFill>
+            <a:prstDash val="solid"/>
+          </a:ln>
+        </p:spPr>
+      </p:sp>
+      <p:sp>
+        <p:nvSpPr>
+          <p:cNvPr id="21" name="Shape 16"/>
+          <p:cNvSpPr/>
+          <p:nvPr/>
+        </p:nvSpPr>
+        <p:spPr>
+          <a:xfrm>
+            <a:off x="1024128" y="3877056"/>
+            <a:ext cx="402336" cy="402336"/>
+          </a:xfrm>
+          <a:prstGeom prst="ellipse">
+            <a:avLst/>
+          </a:prstGeom>
+          <a:solidFill>
+            <a:srgbClr val="42C0FF"/>
+          </a:solidFill>
+          <a:ln/>
+        </p:spPr>
+      </p:sp>
+      <p:sp>
+        <p:nvSpPr>
+          <p:cNvPr id="22" name="Text 17"/>
+          <p:cNvSpPr/>
+          <p:nvPr/>
+        </p:nvSpPr>
+        <p:spPr>
+          <a:xfrm>
+            <a:off x="1024128" y="3877056"/>
+            <a:ext cx="402336" cy="402336"/>
+          </a:xfrm>
+          <a:prstGeom prst="rect">
+            <a:avLst/>
+          </a:prstGeom>
+          <a:noFill/>
+          <a:ln/>
+        </p:spPr>
+        <p:txBody>
+          <a:bodyPr wrap="square" lIns="0" tIns="0" rIns="0" bIns="0" rtlCol="0" anchor="ctr"/>
+          <a:lstStyle/>
+          <a:p>
+            <a:pPr algn="ctr" indent="0" marL="0">
+              <a:buNone/>
+            </a:pPr>
+            <a:r>
+              <a:rPr lang="en-US" sz="1400" b="1" dirty="0">
+                <a:solidFill>
+                  <a:srgbClr val="00357A"/>
+                </a:solidFill>
+                <a:latin typeface="Poppins" pitchFamily="34" charset="0"/>
+                <a:ea typeface="Poppins" pitchFamily="34" charset="-122"/>
+                <a:cs typeface="Poppins" pitchFamily="34" charset="-120"/>
+              </a:rPr>
+              <a:t>3</a:t>
+            </a:r>
+            <a:endParaRPr lang="en-US" sz="1400" dirty="0"/>
+          </a:p>
+        </p:txBody>
+      </p:sp>
+      <p:sp>
+        <p:nvSpPr>
+          <p:cNvPr id="23" name="Text 18"/>
+          <p:cNvSpPr/>
+          <p:nvPr/>
+        </p:nvSpPr>
+        <p:spPr>
+          <a:xfrm>
+            <a:off x="1536192" y="3822192"/>
+            <a:ext cx="4206240" cy="347472"/>
+          </a:xfrm>
+          <a:prstGeom prst="rect">
+            <a:avLst/>
+          </a:prstGeom>
+          <a:noFill/>
+          <a:ln/>
+        </p:spPr>
+        <p:txBody>
+          <a:bodyPr wrap="square" lIns="0" tIns="0" rIns="0" bIns="0" rtlCol="0" anchor="ctr"/>
+          <a:lstStyle/>
+          <a:p>
+            <a:pPr indent="0" marL="0">
+              <a:buNone/>
+            </a:pPr>
+            <a:r>
+              <a:rPr lang="en-US" sz="1300" b="1" dirty="0">
+                <a:solidFill>
+                  <a:srgbClr val="42C0FF"/>
+                </a:solidFill>
+                <a:latin typeface="Poppins" pitchFamily="34" charset="0"/>
+                <a:ea typeface="Poppins" pitchFamily="34" charset="-122"/>
+                <a:cs typeface="Poppins" pitchFamily="34" charset="-120"/>
+              </a:rPr>
+              <a:t>Status is the whole story</a:t>
+            </a:r>
+            <a:endParaRPr lang="en-US" sz="1300" dirty="0"/>
+          </a:p>
+        </p:txBody>
+      </p:sp>
+      <p:sp>
+        <p:nvSpPr>
+          <p:cNvPr id="24" name="Text 19"/>
+          <p:cNvSpPr/>
+          <p:nvPr/>
+        </p:nvSpPr>
+        <p:spPr>
+          <a:xfrm>
+            <a:off x="1536192" y="4187952"/>
+            <a:ext cx="4206240" cy="585216"/>
+          </a:xfrm>
+          <a:prstGeom prst="rect">
+            <a:avLst/>
+          </a:prstGeom>
+          <a:noFill/>
+          <a:ln/>
+        </p:spPr>
+        <p:txBody>
+          <a:bodyPr wrap="square" lIns="0" tIns="0" rIns="0" bIns="0" rtlCol="0" anchor="t"/>
+          <a:lstStyle/>
+          <a:p>
+            <a:pPr indent="0" marL="0">
+              <a:lnSpc>
+                <a:spcPct val="105000"/>
+              </a:lnSpc>
+              <a:buNone/>
+            </a:pPr>
+            <a:r>
+              <a:rPr lang="en-US" sz="1050" dirty="0">
+                <a:solidFill>
+                  <a:srgbClr val="D5E8FA"/>
+                </a:solidFill>
+                <a:latin typeface="Poppins" pitchFamily="34" charset="0"/>
+                <a:ea typeface="Poppins" pitchFamily="34" charset="-122"/>
+                <a:cs typeface="Poppins" pitchFamily="34" charset="-120"/>
+              </a:rPr>
+              <a:t>N listed, T tarred, A archived. Backwards moves are deliberate and simply requeue the work.</a:t>
+            </a:r>
+            <a:endParaRPr lang="en-US" sz="1050" dirty="0"/>
+          </a:p>
+        </p:txBody>
+      </p:sp>
+      <p:sp>
+        <p:nvSpPr>
+          <p:cNvPr id="25" name="Shape 20"/>
+          <p:cNvSpPr/>
+          <p:nvPr/>
+        </p:nvSpPr>
+        <p:spPr>
+          <a:xfrm>
+            <a:off x="6263640" y="3694176"/>
+            <a:ext cx="5120640" cy="1170432"/>
+          </a:xfrm>
+          <a:prstGeom prst="roundRect">
+            <a:avLst>
+              <a:gd name="adj" fmla="val 7813"/>
+            </a:avLst>
+          </a:prstGeom>
+          <a:solidFill>
+            <a:srgbClr val="00357A"/>
+          </a:solidFill>
+          <a:ln w="12700">
+            <a:solidFill>
+              <a:srgbClr val="2C6FB8"/>
+            </a:solidFill>
+            <a:prstDash val="solid"/>
+          </a:ln>
+        </p:spPr>
+      </p:sp>
+      <p:sp>
+        <p:nvSpPr>
+          <p:cNvPr id="26" name="Shape 21"/>
+          <p:cNvSpPr/>
+          <p:nvPr/>
+        </p:nvSpPr>
+        <p:spPr>
+          <a:xfrm>
+            <a:off x="6464808" y="3877056"/>
+            <a:ext cx="402336" cy="402336"/>
+          </a:xfrm>
+          <a:prstGeom prst="ellipse">
+            <a:avLst/>
+          </a:prstGeom>
+          <a:solidFill>
+            <a:srgbClr val="42C0FF"/>
+          </a:solidFill>
+          <a:ln/>
+        </p:spPr>
+      </p:sp>
+      <p:sp>
+        <p:nvSpPr>
+          <p:cNvPr id="27" name="Text 22"/>
+          <p:cNvSpPr/>
+          <p:nvPr/>
+        </p:nvSpPr>
+        <p:spPr>
+          <a:xfrm>
+            <a:off x="6464808" y="3877056"/>
+            <a:ext cx="402336" cy="402336"/>
+          </a:xfrm>
+          <a:prstGeom prst="rect">
+            <a:avLst/>
+          </a:prstGeom>
+          <a:noFill/>
+          <a:ln/>
+        </p:spPr>
+        <p:txBody>
+          <a:bodyPr wrap="square" lIns="0" tIns="0" rIns="0" bIns="0" rtlCol="0" anchor="ctr"/>
+          <a:lstStyle/>
+          <a:p>
+            <a:pPr algn="ctr" indent="0" marL="0">
+              <a:buNone/>
+            </a:pPr>
+            <a:r>
+              <a:rPr lang="en-US" sz="1400" b="1" dirty="0">
+                <a:solidFill>
+                  <a:srgbClr val="00357A"/>
+                </a:solidFill>
+                <a:latin typeface="Poppins" pitchFamily="34" charset="0"/>
+                <a:ea typeface="Poppins" pitchFamily="34" charset="-122"/>
+                <a:cs typeface="Poppins" pitchFamily="34" charset="-120"/>
+              </a:rPr>
+              <a:t>4</a:t>
+            </a:r>
+            <a:endParaRPr lang="en-US" sz="1400" dirty="0"/>
+          </a:p>
+        </p:txBody>
+      </p:sp>
+      <p:sp>
+        <p:nvSpPr>
+          <p:cNvPr id="28" name="Text 23"/>
+          <p:cNvSpPr/>
+          <p:nvPr/>
+        </p:nvSpPr>
+        <p:spPr>
+          <a:xfrm>
+            <a:off x="6976872" y="3822192"/>
+            <a:ext cx="4206240" cy="347472"/>
+          </a:xfrm>
+          <a:prstGeom prst="rect">
+            <a:avLst/>
+          </a:prstGeom>
+          <a:noFill/>
+          <a:ln/>
+        </p:spPr>
+        <p:txBody>
+          <a:bodyPr wrap="square" lIns="0" tIns="0" rIns="0" bIns="0" rtlCol="0" anchor="ctr"/>
+          <a:lstStyle/>
+          <a:p>
+            <a:pPr indent="0" marL="0">
+              <a:buNone/>
+            </a:pPr>
+            <a:r>
+              <a:rPr lang="en-US" sz="1300" b="1" dirty="0">
+                <a:solidFill>
+                  <a:srgbClr val="42C0FF"/>
+                </a:solidFill>
+                <a:latin typeface="Poppins" pitchFamily="34" charset="0"/>
+                <a:ea typeface="Poppins" pitchFamily="34" charset="-122"/>
+                <a:cs typeface="Poppins" pitchFamily="34" charset="-120"/>
+              </a:rPr>
+              <a:t>Tar size is the economics</a:t>
+            </a:r>
+            <a:endParaRPr lang="en-US" sz="1300" dirty="0"/>
+          </a:p>
+        </p:txBody>
+      </p:sp>
+      <p:sp>
+        <p:nvSpPr>
+          <p:cNvPr id="29" name="Text 24"/>
+          <p:cNvSpPr/>
+          <p:nvPr/>
+        </p:nvSpPr>
+        <p:spPr>
+          <a:xfrm>
+            <a:off x="6976872" y="4187952"/>
+            <a:ext cx="4206240" cy="585216"/>
+          </a:xfrm>
+          <a:prstGeom prst="rect">
+            <a:avLst/>
+          </a:prstGeom>
+          <a:noFill/>
+          <a:ln/>
+        </p:spPr>
+        <p:txBody>
+          <a:bodyPr wrap="square" lIns="0" tIns="0" rIns="0" bIns="0" rtlCol="0" anchor="t"/>
+          <a:lstStyle/>
+          <a:p>
+            <a:pPr indent="0" marL="0">
+              <a:lnSpc>
+                <a:spcPct val="105000"/>
+              </a:lnSpc>
+              <a:buNone/>
+            </a:pPr>
+            <a:r>
+              <a:rPr lang="en-US" sz="1050" dirty="0">
+                <a:solidFill>
+                  <a:srgbClr val="D5E8FA"/>
+                </a:solidFill>
+                <a:latin typeface="Poppins" pitchFamily="34" charset="0"/>
+                <a:ea typeface="Poppins" pitchFamily="34" charset="-122"/>
+                <a:cs typeface="Poppins" pitchFamily="34" charset="-120"/>
+              </a:rPr>
+              <a:t>5 GB target tars batched into 90 GB transfers is what makes tape and Globus efficient.</a:t>
+            </a:r>
+            <a:endParaRPr lang="en-US" sz="1050" dirty="0"/>
+          </a:p>
+        </p:txBody>
+      </p:sp>
+      <p:sp>
+        <p:nvSpPr>
+          <p:cNvPr id="30" name="Shape 25"/>
+          <p:cNvSpPr/>
+          <p:nvPr/>
+        </p:nvSpPr>
+        <p:spPr>
+          <a:xfrm>
+            <a:off x="822960" y="4937760"/>
+            <a:ext cx="5120640" cy="1170432"/>
+          </a:xfrm>
+          <a:prstGeom prst="roundRect">
+            <a:avLst>
+              <a:gd name="adj" fmla="val 7813"/>
+            </a:avLst>
+          </a:prstGeom>
+          <a:solidFill>
+            <a:srgbClr val="00357A"/>
+          </a:solidFill>
+          <a:ln w="12700">
+            <a:solidFill>
+              <a:srgbClr val="2C6FB8"/>
+            </a:solidFill>
+            <a:prstDash val="solid"/>
+          </a:ln>
+        </p:spPr>
+      </p:sp>
+      <p:sp>
+        <p:nvSpPr>
+          <p:cNvPr id="31" name="Shape 26"/>
+          <p:cNvSpPr/>
+          <p:nvPr/>
+        </p:nvSpPr>
+        <p:spPr>
+          <a:xfrm>
+            <a:off x="1024128" y="5120640"/>
+            <a:ext cx="402336" cy="402336"/>
+          </a:xfrm>
+          <a:prstGeom prst="ellipse">
+            <a:avLst/>
+          </a:prstGeom>
+          <a:solidFill>
+            <a:srgbClr val="42C0FF"/>
+          </a:solidFill>
+          <a:ln/>
+        </p:spPr>
+      </p:sp>
+      <p:sp>
+        <p:nvSpPr>
+          <p:cNvPr id="32" name="Text 27"/>
+          <p:cNvSpPr/>
+          <p:nvPr/>
+        </p:nvSpPr>
+        <p:spPr>
+          <a:xfrm>
+            <a:off x="1024128" y="5120640"/>
+            <a:ext cx="402336" cy="402336"/>
+          </a:xfrm>
+          <a:prstGeom prst="rect">
+            <a:avLst/>
+          </a:prstGeom>
+          <a:noFill/>
+          <a:ln/>
+        </p:spPr>
+        <p:txBody>
+          <a:bodyPr wrap="square" lIns="0" tIns="0" rIns="0" bIns="0" rtlCol="0" anchor="ctr"/>
+          <a:lstStyle/>
+          <a:p>
+            <a:pPr algn="ctr" indent="0" marL="0">
+              <a:buNone/>
+            </a:pPr>
+            <a:r>
+              <a:rPr lang="en-US" sz="1400" b="1" dirty="0">
+                <a:solidFill>
+                  <a:srgbClr val="00357A"/>
+                </a:solidFill>
+                <a:latin typeface="Poppins" pitchFamily="34" charset="0"/>
+                <a:ea typeface="Poppins" pitchFamily="34" charset="-122"/>
+                <a:cs typeface="Poppins" pitchFamily="34" charset="-120"/>
+              </a:rPr>
+              <a:t>5</a:t>
+            </a:r>
+            <a:endParaRPr lang="en-US" sz="1400" dirty="0"/>
+          </a:p>
+        </p:txBody>
+      </p:sp>
+      <p:sp>
+        <p:nvSpPr>
+          <p:cNvPr id="33" name="Text 28"/>
+          <p:cNvSpPr/>
+          <p:nvPr/>
+        </p:nvSpPr>
+        <p:spPr>
+          <a:xfrm>
+            <a:off x="1536192" y="5065776"/>
+            <a:ext cx="4206240" cy="347472"/>
+          </a:xfrm>
+          <a:prstGeom prst="rect">
+            <a:avLst/>
+          </a:prstGeom>
+          <a:noFill/>
+          <a:ln/>
+        </p:spPr>
+        <p:txBody>
+          <a:bodyPr wrap="square" lIns="0" tIns="0" rIns="0" bIns="0" rtlCol="0" anchor="ctr"/>
+          <a:lstStyle/>
+          <a:p>
+            <a:pPr indent="0" marL="0">
+              <a:buNone/>
+            </a:pPr>
+            <a:r>
+              <a:rPr lang="en-US" sz="1300" b="1" dirty="0">
+                <a:solidFill>
+                  <a:srgbClr val="42C0FF"/>
+                </a:solidFill>
+                <a:latin typeface="Poppins" pitchFamily="34" charset="0"/>
+                <a:ea typeface="Poppins" pitchFamily="34" charset="-122"/>
+                <a:cs typeface="Poppins" pitchFamily="34" charset="-120"/>
+              </a:rPr>
+              <a:t>The dataset lock is the only lock</a:t>
+            </a:r>
+            <a:endParaRPr lang="en-US" sz="1300" dirty="0"/>
+          </a:p>
+        </p:txBody>
+      </p:sp>
+      <p:sp>
+        <p:nvSpPr>
+          <p:cNvPr id="34" name="Text 29"/>
+          <p:cNvSpPr/>
+          <p:nvPr/>
+        </p:nvSpPr>
+        <p:spPr>
+          <a:xfrm>
+            <a:off x="1536192" y="5431536"/>
+            <a:ext cx="4206240" cy="585216"/>
+          </a:xfrm>
+          <a:prstGeom prst="rect">
+            <a:avLst/>
+          </a:prstGeom>
+          <a:noFill/>
+          <a:ln/>
+        </p:spPr>
+        <p:txBody>
+          <a:bodyPr wrap="square" lIns="0" tIns="0" rIns="0" bIns="0" rtlCol="0" anchor="t"/>
+          <a:lstStyle/>
+          <a:p>
+            <a:pPr indent="0" marL="0">
+              <a:lnSpc>
+                <a:spcPct val="105000"/>
+              </a:lnSpc>
+              <a:buNone/>
+            </a:pPr>
+            <a:r>
+              <a:rPr lang="en-US" sz="1050" dirty="0">
+                <a:solidFill>
+                  <a:srgbClr val="D5E8FA"/>
+                </a:solidFill>
+                <a:latin typeface="Poppins" pitchFamily="34" charset="0"/>
+                <a:ea typeface="Poppins" pitchFamily="34" charset="-122"/>
+                <a:cs typeface="Poppins" pitchFamily="34" charset="-120"/>
+              </a:rPr>
+              <a:t>Everything about concurrency — workers, re-checks, multi-dataset tars — is built on it.</a:t>
+            </a:r>
+            <a:endParaRPr lang="en-US" sz="1050" dirty="0"/>
+          </a:p>
+        </p:txBody>
+      </p:sp>
+      <p:sp>
+        <p:nvSpPr>
+          <p:cNvPr id="35" name="Shape 30"/>
+          <p:cNvSpPr/>
+          <p:nvPr/>
+        </p:nvSpPr>
+        <p:spPr>
+          <a:xfrm>
+            <a:off x="6263640" y="4937760"/>
+            <a:ext cx="5120640" cy="1170432"/>
+          </a:xfrm>
+          <a:prstGeom prst="roundRect">
+            <a:avLst>
+              <a:gd name="adj" fmla="val 7813"/>
+            </a:avLst>
+          </a:prstGeom>
+          <a:solidFill>
+            <a:srgbClr val="00357A"/>
+          </a:solidFill>
+          <a:ln w="12700">
+            <a:solidFill>
+              <a:srgbClr val="2C6FB8"/>
+            </a:solidFill>
+            <a:prstDash val="solid"/>
+          </a:ln>
+        </p:spPr>
+      </p:sp>
+      <p:sp>
+        <p:nvSpPr>
+          <p:cNvPr id="36" name="Shape 31"/>
+          <p:cNvSpPr/>
+          <p:nvPr/>
+        </p:nvSpPr>
+        <p:spPr>
+          <a:xfrm>
+            <a:off x="6464808" y="5120640"/>
+            <a:ext cx="402336" cy="402336"/>
+          </a:xfrm>
+          <a:prstGeom prst="ellipse">
+            <a:avLst/>
+          </a:prstGeom>
+          <a:solidFill>
+            <a:srgbClr val="42C0FF"/>
+          </a:solidFill>
+          <a:ln/>
+        </p:spPr>
+      </p:sp>
+      <p:sp>
+        <p:nvSpPr>
+          <p:cNvPr id="37" name="Text 32"/>
+          <p:cNvSpPr/>
+          <p:nvPr/>
+        </p:nvSpPr>
+        <p:spPr>
+          <a:xfrm>
+            <a:off x="6464808" y="5120640"/>
+            <a:ext cx="402336" cy="402336"/>
+          </a:xfrm>
+          <a:prstGeom prst="rect">
+            <a:avLst/>
+          </a:prstGeom>
+          <a:noFill/>
+          <a:ln/>
+        </p:spPr>
+        <p:txBody>
+          <a:bodyPr wrap="square" lIns="0" tIns="0" rIns="0" bIns="0" rtlCol="0" anchor="ctr"/>
+          <a:lstStyle/>
+          <a:p>
+            <a:pPr algn="ctr" indent="0" marL="0">
+              <a:buNone/>
+            </a:pPr>
+            <a:r>
+              <a:rPr lang="en-US" sz="1400" b="1" dirty="0">
+                <a:solidFill>
+                  <a:srgbClr val="00357A"/>
+                </a:solidFill>
+                <a:latin typeface="Poppins" pitchFamily="34" charset="0"/>
+                <a:ea typeface="Poppins" pitchFamily="34" charset="-122"/>
+                <a:cs typeface="Poppins" pitchFamily="34" charset="-120"/>
+              </a:rPr>
+              <a:t>6</a:t>
+            </a:r>
+            <a:endParaRPr lang="en-US" sz="1400" dirty="0"/>
+          </a:p>
+        </p:txBody>
+      </p:sp>
+      <p:sp>
+        <p:nvSpPr>
+          <p:cNvPr id="38" name="Text 33"/>
+          <p:cNvSpPr/>
+          <p:nvPr/>
+        </p:nvSpPr>
+        <p:spPr>
+          <a:xfrm>
+            <a:off x="6976872" y="5065776"/>
+            <a:ext cx="4206240" cy="347472"/>
+          </a:xfrm>
+          <a:prstGeom prst="rect">
+            <a:avLst/>
+          </a:prstGeom>
+          <a:noFill/>
+          <a:ln/>
+        </p:spPr>
+        <p:txBody>
+          <a:bodyPr wrap="square" lIns="0" tIns="0" rIns="0" bIns="0" rtlCol="0" anchor="ctr"/>
+          <a:lstStyle/>
+          <a:p>
+            <a:pPr indent="0" marL="0">
+              <a:buNone/>
+            </a:pPr>
+            <a:r>
+              <a:rPr lang="en-US" sz="1300" b="1" dirty="0">
+                <a:solidFill>
+                  <a:srgbClr val="42C0FF"/>
+                </a:solidFill>
+                <a:latin typeface="Poppins" pitchFamily="34" charset="0"/>
+                <a:ea typeface="Poppins" pitchFamily="34" charset="-122"/>
+                <a:cs typeface="Poppins" pitchFamily="34" charset="-120"/>
+              </a:rPr>
+              <a:t>Nothing is lost by stopping</a:t>
+            </a:r>
+            <a:endParaRPr lang="en-US" sz="1300" dirty="0"/>
+          </a:p>
+        </p:txBody>
+      </p:sp>
+      <p:sp>
+        <p:nvSpPr>
+          <p:cNvPr id="39" name="Text 34"/>
+          <p:cNvSpPr/>
+          <p:nvPr/>
+        </p:nvSpPr>
+        <p:spPr>
+          <a:xfrm>
+            <a:off x="6976872" y="5431536"/>
+            <a:ext cx="4206240" cy="585216"/>
+          </a:xfrm>
+          <a:prstGeom prst="rect">
+            <a:avLst/>
+          </a:prstGeom>
+          <a:noFill/>
+          <a:ln/>
+        </p:spPr>
+        <p:txBody>
+          <a:bodyPr wrap="square" lIns="0" tIns="0" rIns="0" bIns="0" rtlCol="0" anchor="t"/>
+          <a:lstStyle/>
+          <a:p>
+            <a:pPr indent="0" marL="0">
+              <a:lnSpc>
+                <a:spcPct val="105000"/>
+              </a:lnSpc>
+              <a:buNone/>
+            </a:pPr>
+            <a:r>
+              <a:rPr lang="en-US" sz="1050" dirty="0">
+                <a:solidFill>
+                  <a:srgbClr val="D5E8FA"/>
+                </a:solidFill>
+                <a:latin typeface="Poppins" pitchFamily="34" charset="0"/>
+                <a:ea typeface="Poppins" pitchFamily="34" charset="-122"/>
+                <a:cs typeface="Poppins" pitchFamily="34" charset="-120"/>
+              </a:rPr>
+              <a:t>The 23-hour guard, the retry limit and the resumable statuses mean an interrupted run just continues later.</a:t>
+            </a:r>
+            <a:endParaRPr lang="en-US" sz="1050" dirty="0"/>
+          </a:p>
+        </p:txBody>
+      </p:sp>
+    </p:spTree>
+  </p:cSld>
+  <p:clrMapOvr>
+    <a:masterClrMapping/>
+  </p:clrMapOvr>
+</p:sld>
+</file>
+
+<file path=ppt/slides/slide28.xml><?xml version="1.0" encoding="utf-8"?>
+<p:sld xmlns:a="http://schemas.openxmlformats.org/drawingml/2006/main" xmlns:r="http://schemas.openxmlformats.org/officeDocument/2006/relationships" xmlns:p="http://schemas.openxmlformats.org/presentationml/2006/main">
+  <p:cSld name="Slide 28">
+    <p:bg>
+      <p:bgPr>
+        <a:solidFill>
+          <a:srgbClr val="0057C2"/>
+        </a:solidFill>
+      </p:bgPr>
+    </p:bg>
+    <p:spTree>
+      <p:nvGrpSpPr>
+        <p:cNvPr id="1" name=""/>
+        <p:cNvGrpSpPr/>
+        <p:nvPr/>
+      </p:nvGrpSpPr>
+      <p:grpSpPr>
+        <a:xfrm>
+          <a:off x="0" y="0"/>
+          <a:ext cx="0" cy="0"/>
+          <a:chOff x="0" y="0"/>
+          <a:chExt cx="0" cy="0"/>
+        </a:xfrm>
+      </p:grpSpPr>
+      <p:pic>
+        <p:nvPicPr>
+          <p:cNvPr id="2" name="Image 0" descr="interior_bg.png">    </p:cNvPr>
+          <p:cNvPicPr>
+            <a:picLocks noChangeAspect="1"/>
+          </p:cNvPicPr>
+          <p:nvPr/>
+        </p:nvPicPr>
+        <p:blipFill>
+          <a:blip r:embed="rId1"/>
+          <a:stretch>
+            <a:fillRect/>
+          </a:stretch>
+        </p:blipFill>
+        <p:spPr>
+          <a:xfrm>
+            <a:off x="0" y="0"/>
+            <a:ext cx="12191695" cy="6858000"/>
+          </a:xfrm>
+          <a:prstGeom prst="rect">
+            <a:avLst/>
+          </a:prstGeom>
+        </p:spPr>
+      </p:pic>
+      <p:pic>
+        <p:nvPicPr>
+          <p:cNvPr id="3" name="Image 1" descr="gdex_lockup_white.png">    </p:cNvPr>
+          <p:cNvPicPr>
+            <a:picLocks noChangeAspect="1"/>
+          </p:cNvPicPr>
+          <p:nvPr/>
+        </p:nvPicPr>
+        <p:blipFill>
+          <a:blip r:embed="rId2"/>
+          <a:stretch>
+            <a:fillRect/>
+          </a:stretch>
+        </p:blipFill>
+        <p:spPr>
+          <a:xfrm>
+            <a:off x="612648" y="365760"/>
+            <a:ext cx="1024128" cy="521208"/>
+          </a:xfrm>
+          <a:prstGeom prst="rect">
+            <a:avLst/>
+          </a:prstGeom>
+        </p:spPr>
+      </p:pic>
+      <p:pic>
+        <p:nvPicPr>
+          <p:cNvPr id="4" name="Image 2" descr="nsf_ncar_logo_white.png">    </p:cNvPr>
+          <p:cNvPicPr>
+            <a:picLocks noChangeAspect="1"/>
+          </p:cNvPicPr>
+          <p:nvPr/>
+        </p:nvPicPr>
+        <p:blipFill>
+          <a:blip r:embed="rId3"/>
+          <a:stretch>
+            <a:fillRect/>
+          </a:stretch>
+        </p:blipFill>
+        <p:spPr>
+          <a:xfrm>
+            <a:off x="9683496" y="393192"/>
+            <a:ext cx="1892808" cy="521208"/>
+          </a:xfrm>
+          <a:prstGeom prst="rect">
+            <a:avLst/>
+          </a:prstGeom>
+        </p:spPr>
+      </p:pic>
+      <p:sp>
+        <p:nvSpPr>
+          <p:cNvPr id="5" name="Text 0"/>
+          <p:cNvSpPr/>
+          <p:nvPr/>
+        </p:nvSpPr>
+        <p:spPr>
+          <a:xfrm>
+            <a:off x="256032" y="6446520"/>
+            <a:ext cx="365760" cy="274320"/>
+          </a:xfrm>
+          <a:prstGeom prst="rect">
+            <a:avLst/>
+          </a:prstGeom>
+          <a:noFill/>
+          <a:ln/>
+        </p:spPr>
+        <p:txBody>
+          <a:bodyPr wrap="square" lIns="0" tIns="0" rIns="0" bIns="0" rtlCol="0" anchor="ctr"/>
+          <a:lstStyle/>
+          <a:p>
+            <a:pPr indent="0" marL="0">
+              <a:buNone/>
+            </a:pPr>
+            <a:r>
+              <a:rPr lang="en-US" sz="950" b="1" dirty="0">
+                <a:solidFill>
+                  <a:srgbClr val="FFFFFF"/>
+                </a:solidFill>
+                <a:latin typeface="Poppins" pitchFamily="34" charset="0"/>
+                <a:ea typeface="Poppins" pitchFamily="34" charset="-122"/>
+                <a:cs typeface="Poppins" pitchFamily="34" charset="-120"/>
+              </a:rPr>
+              <a:t>27</a:t>
+            </a:r>
+            <a:endParaRPr lang="en-US" sz="950" dirty="0"/>
+          </a:p>
+        </p:txBody>
+      </p:sp>
+      <p:sp>
+        <p:nvSpPr>
+          <p:cNvPr id="6" name="Shape 1"/>
+          <p:cNvSpPr/>
+          <p:nvPr/>
+        </p:nvSpPr>
+        <p:spPr>
+          <a:xfrm>
+            <a:off x="612648" y="6437376"/>
+            <a:ext cx="0" cy="201168"/>
+          </a:xfrm>
+          <a:prstGeom prst="line">
+            <a:avLst/>
+          </a:prstGeom>
+          <a:noFill/>
+          <a:ln w="9525">
+            <a:solidFill>
+              <a:srgbClr val="FFFFFF"/>
+            </a:solidFill>
+            <a:prstDash val="solid"/>
+          </a:ln>
+        </p:spPr>
+      </p:sp>
+      <p:sp>
+        <p:nvSpPr>
+          <p:cNvPr id="7" name="Text 2"/>
+          <p:cNvSpPr/>
+          <p:nvPr/>
+        </p:nvSpPr>
+        <p:spPr>
+          <a:xfrm>
+            <a:off x="786384" y="6446520"/>
+            <a:ext cx="5486400" cy="274320"/>
+          </a:xfrm>
+          <a:prstGeom prst="rect">
+            <a:avLst/>
+          </a:prstGeom>
+          <a:noFill/>
+          <a:ln/>
+        </p:spPr>
+        <p:txBody>
+          <a:bodyPr wrap="square" lIns="0" tIns="0" rIns="0" bIns="0" rtlCol="0" anchor="ctr"/>
+          <a:lstStyle/>
+          <a:p>
+            <a:pPr indent="0" marL="0">
+              <a:buNone/>
+            </a:pPr>
+            <a:r>
+              <a:rPr lang="en-US" sz="950" b="1" dirty="0">
+                <a:solidFill>
+                  <a:srgbClr val="FFFFFF"/>
+                </a:solidFill>
+                <a:latin typeface="Poppins" pitchFamily="34" charset="0"/>
+                <a:ea typeface="Poppins" pitchFamily="34" charset="-122"/>
+                <a:cs typeface="Poppins" pitchFamily="34" charset="-120"/>
+              </a:rPr>
+              <a:t>DSQUASAR  •  QUASAR BACKUP GUIDE</a:t>
+            </a:r>
+            <a:endParaRPr lang="en-US" sz="950" dirty="0"/>
+          </a:p>
+        </p:txBody>
+      </p:sp>
+      <p:sp>
+        <p:nvSpPr>
+          <p:cNvPr id="8" name="Text 3"/>
+          <p:cNvSpPr/>
+          <p:nvPr/>
+        </p:nvSpPr>
+        <p:spPr>
+          <a:xfrm>
             <a:off x="1527048" y="1078992"/>
             <a:ext cx="9144000" cy="2743200"/>
           </a:xfrm>
@@ -34443,7 +35724,7 @@
                 <a:ea typeface="Poppins" pitchFamily="34" charset="-122"/>
                 <a:cs typeface="Poppins" pitchFamily="34" charset="-120"/>
               </a:rPr>
-              <a:t>Which end points. -B Backup only, -D Backup + Drdata. Default: both.</a:t>
+              <a:t>A filter, not an override. -B keeps single copy datasets, -D keeps two copy ones. Default: each dataset follows its own flag.</a:t>
             </a:r>
             <a:endParaRPr lang="en-US" sz="1200" dirty="0"/>
           </a:p>

</xml_diff>